<commit_message>
docs: fix CUDA SFM deck scope labels
</commit_message>
<xml_diff>
--- a/timing/sfm_ba/benchmark_logs/20260710T_cuda_sfm_progress/cuda_sfm_progress_update.pptx
+++ b/timing/sfm_ba/benchmark_logs/20260710T_cuda_sfm_progress/cuda_sfm_progress_update.pptx
@@ -14042,7 +14042,7 @@
                   <a:srgbClr val="5A6472"/>
                 </a:solidFill>
               </a:rPr>
-              <a:t>Measured components; percentages below are of the 426.223 ms whole graph API.</a:t>
+              <a:t>Measured components. Stacked bar: % of optimize(); table: % of Graph API.</a:t>
             </a:r>
             <a:endParaRPr lang="en-US" sz="1450" dirty="0"/>
           </a:p>
@@ -17700,7 +17700,7 @@
                   <a:srgbClr val="18212F"/>
                 </a:solidFill>
               </a:rPr>
-              <a:t>Dense Schur 23.009 ms | damping diagonal 2.979 ms | linearized error change 3.655 ms</a:t>
+              <a:t>Dense Schur 23.009 ms | Hessian / damping diagonal 2.979 ms | linearized error change 3.655 ms</a:t>
             </a:r>
             <a:endParaRPr lang="en-US" sz="1350" dirty="0"/>
           </a:p>
@@ -19825,7 +19825,7 @@
                   <a:srgbClr val="18212F"/>
                 </a:solidFill>
               </a:rPr>
-              <a:t>0.49%</a:t>
+              <a:t>0.45%</a:t>
             </a:r>
             <a:endParaRPr lang="en-US" sz="1230" dirty="0"/>
           </a:p>
@@ -23751,8 +23751,8 @@
         </p:nvSpPr>
         <p:spPr>
           <a:xfrm>
-            <a:off x="941832" y="2212848"/>
-            <a:ext cx="4617720" cy="978408"/>
+            <a:off x="941832" y="2121408"/>
+            <a:ext cx="4617720" cy="1115568"/>
           </a:xfrm>
           <a:prstGeom prst="rect">
             <a:avLst/>
@@ -23770,14 +23770,14 @@
               <a:buNone/>
             </a:pPr>
             <a:r>
-              <a:rPr lang="en-US" sz="1700" b="1" dirty="0">
+              <a:rPr lang="en-US" sz="1600" b="1" dirty="0">
                 <a:solidFill>
                   <a:srgbClr val="FFFFFF"/>
                 </a:solidFill>
               </a:rPr>
-              <a:t>CPU linearization, retraction, and trial error are small enough to justify implementing a hybrid baseline. Expected benefit: generality and removal of specialized graph conversion, not a proven end-to-end speedup.</a:t>
-            </a:r>
-            <a:endParaRPr lang="en-US" sz="1700" dirty="0"/>
+              <a:t>Separately timed CPU nonlinear subtotal is tens of milliseconds per candidate versus the prior 0.426 s three-iteration API run. Scopes differ, so this supports feasibility, not a speedup claim. Expected benefit: generality and removal of specialized graph conversion.</a:t>
+            </a:r>
+            <a:endParaRPr lang="en-US" sz="1600" dirty="0"/>
           </a:p>
         </p:txBody>
       </p:sp>

</xml_diff>

<commit_message>
docs: refine CUDA SFM progress deck
</commit_message>
<xml_diff>
--- a/timing/sfm_ba/benchmark_logs/20260710T_cuda_sfm_progress/cuda_sfm_progress_update.pptx
+++ b/timing/sfm_ba/benchmark_logs/20260710T_cuda_sfm_progress/cuda_sfm_progress_update.pptx
@@ -512,7 +512,7 @@
           <a:p>
             <a:r>
               <a:rPr lang="en-US" dirty="0"/>
-              <a:t>About 30 seconds. This is a factual progress update. I will first show the measured timing for the current specialized CUDA SFM path on Dubrovnik 135 with dense Schur and three LM iterations. Then I will use separate feasibility measurements to motivate, but not claim success for, a more general hybrid baseline.</a:t>
+              <a:t>About 30 seconds. This is a factual progress update. First I will show the measured timing for the current specialized CUDA SFM path on Dubrovnik 135 with dense Schur and three LM iterations. Then I will use separate feasibility measurements to ask whether a more general CPU and GPU separation is worth building. The goal is to identify the next experiment, not to claim a finished faster solver.</a:t>
             </a:r>
             <a:endParaRPr lang="en-US" dirty="0"/>
           </a:p>
@@ -776,7 +776,7 @@
           <a:p>
             <a:r>
               <a:rPr lang="en-US" dirty="0"/>
-              <a:t>About 50 seconds. Start from the left: the user-facing input is a normal GTSAM graph and Values. The specialized path must scan and convert that representation to SFM arrays before CUDA can act. After the backend returns, the result must be rebuilt as Values and merged back into the original state. These boundaries are important because they are part of the measured time.</a:t>
+              <a:t>About 60 seconds. Start from the left: the user-facing input is a normal GTSAM graph and Values, with generic factor ownership and the current variable state. The specialized path scans that graph, selects the SFM subset, and creates arrays for cameras, points, measurements, and key maps. CUDA operates on those arrays, not on arbitrary GTSAM factors. After the backend returns, optimized arrays must be rebuilt as Values and merged into the original state. I am calling out each boundary because the timing includes this integration work, not only the GPU kernel.</a:t>
             </a:r>
             <a:endParaRPr lang="en-US" dirty="0"/>
           </a:p>
@@ -864,7 +864,7 @@
           <a:p>
             <a:r>
               <a:rPr lang="en-US" dirty="0"/>
-              <a:t>About 45 seconds. This is the complete public API timing. Warm-up on a small problem was excluded and this is the mean of three runs. Nearly eighty-eight percent of the total is optimize, so I now unpack that call. I am keeping construction and result queries visible because they establish the scope and prevent us from silently calling a partial number end-to-end.</a:t>
+              <a:t>About 55 seconds. This is the complete public API timing. Warm-up on a small problem was excluded, and the result is the mean of three timed runs. Construction contributes 36.203 milliseconds, optimize contributes 376.192 milliseconds, and final result and error queries contribute 13.828 milliseconds. Nearly eighty-eight percent is optimize, so the next slides unpack that call. I keep the other pieces visible because they define the graph API scope and prevent a partial number from being presented as end-to-end.</a:t>
             </a:r>
             <a:endParaRPr lang="en-US" dirty="0"/>
           </a:p>
@@ -952,7 +952,7 @@
           <a:p>
             <a:r>
               <a:rPr lang="en-US" dirty="0"/>
-              <a:t>About 60 seconds. This is the detailed optimize decomposition. Graph conversion is 114.246 milliseconds: it is CPU work creating the specialized representation. The CUDA backend is 137.542 milliseconds. On the way back, Values merge and destruction of converted data add almost 98 milliseconds. That makes conversion and object/state management major optimization targets, rather than an afterthought around the GPU call.</a:t>
+              <a:t>About 70 seconds. This is the detailed optimize decomposition. The stacked bar uses percent of optimize, while the table uses percent of the full graph API, so the denominators are explicit. Graph conversion is 114.246 milliseconds of CPU work creating the specialized representation. The CUDA backend is 137.542 milliseconds. On the way back, return and assignment, Values merge, and destruction of converted data are all CPU-side result-management work. Values merge plus destruction alone add almost 98 milliseconds. The main point is that conversion and object/state management are first-order costs beside the backend, not bookkeeping after the GPU call.</a:t>
             </a:r>
             <a:endParaRPr lang="en-US" dirty="0"/>
           </a:p>
@@ -1040,7 +1040,7 @@
           <a:p>
             <a:r>
               <a:rPr lang="en-US" dirty="0"/>
-              <a:t>About 50 seconds. Inside the backend, setup is almost half of the time and download plus Values reconstruction is another twenty-nine percent. The solve loop is only 29.968 milliseconds. Its largest part is dense Schur at 23.009 milliseconds. In contrast, the raw D2H copy is only 0.615 milliseconds: much of download time is host work around the copy.</a:t>
+              <a:t>About 60 seconds. Inside the backend, setup is almost half of the time and download plus Values reconstruction is another twenty-nine percent. Setup is led by the 38.686 millisecond projection host build. The solve loop is only 29.968 milliseconds, with dense Schur at 23.009 milliseconds, the Hessian or damping diagonal at 2.979 milliseconds, and linearized error change at 3.655 milliseconds. In contrast, the raw D2H copy is only 0.615 milliseconds. Much of download time is therefore host allocation, wrapping, destruction, and Values rebuilding around the copy.</a:t>
             </a:r>
             <a:endParaRPr lang="en-US" dirty="0"/>
           </a:p>
@@ -1128,7 +1128,7 @@
           <a:p>
             <a:r>
               <a:rPr lang="en-US" dirty="0"/>
-              <a:t>About 45 seconds. The comparison puts the relative scale in one place. Pure specialized H2D plus D2H is 1.936 milliseconds, under half a percent of the graph API. The dense-Schur solve loop is also smaller than graph conversion and Values merge. The careful conclusion is not that transfer never matters; it is that it is not the dominant cost in this measured specialized path.</a:t>
+              <a:t>About 55 seconds. This comparison puts the relative scale in one place. Pure specialized H2D plus D2H is 1.936 milliseconds, or 0.45 percent of the 426.223 millisecond graph API. The dense-Schur solve loop is also smaller than graph conversion and Values merge. The careful conclusion is not that transfer never matters or that the GPU solve is free. It is that PCIe copies and dense Schur are not the dominant costs in this measured specialized representation. That motivates testing a different architecture rather than only tuning the kernel.</a:t>
             </a:r>
             <a:endParaRPr lang="en-US" dirty="0"/>
           </a:p>
@@ -1216,7 +1216,7 @@
           <a:p>
             <a:r>
               <a:rPr lang="en-US" dirty="0"/>
-              <a:t>About 90 seconds. This is a proposed baseline architecture. I am calling it Ceres-style separation because it follows the useful conceptual split between nonlinear evaluation and a selectable linear-algebra backend. I am not claiming it exactly describes every Ceres path. The purpose is to keep arbitrary GTSAM factors on CPU while putting a generic linear system on the GPU, which removes the need for the existing SFM-only graph conversion.</a:t>
+              <a:t>About 90 seconds. This is a proposed baseline architecture. I call it Ceres-style separation because the useful idea is to separate nonlinear residual and Jacobian evaluation from a selectable linear-algebra backend. I am not claiming that every Ceres path has this exact data flow. In this baseline, arbitrary GTSAM factors stay in the CPU and TBB nonlinear layer. The CPU fills reusable sparse numeric J or H buffers, the GPU receives the generic linear system, and only the solved delta returns. The CPU then performs manifold retraction, trial error, and the trust-region decision. This removes the current SFM-only graph conversion, while leaving the real costs of sparse packing and repeated upload to be measured.</a:t>
             </a:r>
             <a:endParaRPr lang="en-US" dirty="0"/>
           </a:p>
@@ -1304,7 +1304,7 @@
           <a:p>
             <a:r>
               <a:rPr lang="en-US" dirty="0"/>
-              <a:t>About 90 seconds. These numbers are deliberately separate from the current API profile. Each CPU operation was timed in its own loop, and the GPU reference is synthetic arithmetic from separately timed components. Excluding repeat zero gives 54.088 milliseconds for the illustrative CPU subtotal and 8.051 milliseconds for the synthetic GPU reference, or 62.139 milliseconds. A 115.1 MB generic Jacobian-transfer estimate adds 11.284 milliseconds. Neither number is an end-to-end runtime, and neither should be visually compared against the three-iteration 426.223 millisecond API total.</a:t>
+              <a:t>About 90 seconds. These numbers are deliberately separate from the current API profile. Each CPU operation was timed in its own loop, and the GPU reference is synthetic arithmetic from separately timed components. Excluding repeat zero gives 54.088 milliseconds for the illustrative CPU subtotal and 8.051 milliseconds for the synthetic GPU reference, or 62.139 milliseconds. The 115.1 MB generic Jacobian-transfer estimate is 11.283 milliseconds before display rounding, which gives the displayed 73.422 millisecond combination when added to the unrounded estimate. Neither number is an end-to-end runtime, and neither should be visually compared against the three-iteration 426.223 millisecond API total. Sparse packing, repeated upload, delta mapping, and convergence still need the actual prototype measurement.</a:t>
             </a:r>
             <a:endParaRPr lang="en-US" dirty="0"/>
           </a:p>
@@ -1392,7 +1392,7 @@
           <a:p>
             <a:r>
               <a:rPr lang="en-US" dirty="0"/>
-              <a:t>About one minute. The measured evidence says the CPU nonlinear pieces are sufficiently small to be worth implementing as a hybrid baseline. It does not say the hybrid is faster end-to-end. The expected immediate benefit is generality and removal of the specialized SFM conversion. The next experiment needs cached sparse structure, direct numeric fill, numeric upload, a GPU solve, and then actual CPU retraction and error checks inside a full converging LM run.</a:t>
+              <a:t>About 60 seconds. The measured evidence says the CPU nonlinear pieces are sufficiently small to be worth implementing as a hybrid baseline. The separately timed CPU subtotal is on the order of tens of milliseconds per candidate, while the prior graph API measurement is 0.426 seconds for three iterations. Those scopes differ, so this supports feasibility rather than a speedup claim. The expected immediate benefit is generality and removal of specialized graph conversion. The next experiment is concrete: cache sparse structure, fill numeric buffers directly with TBB, upload only numeric values, solve on the GPU, then perform the actual CPU retract and error path in a full converging LM measurement.</a:t>
             </a:r>
             <a:endParaRPr lang="en-US" dirty="0"/>
           </a:p>
@@ -10374,7 +10374,7 @@
                   <a:srgbClr val="18212F"/>
                 </a:solidFill>
               </a:rPr>
-              <a:t>553,336 x (24 Jacobian + 2 residual) x 8 B = 115,093,888 B = 115.1 MB. / 9.50 GiB/s = 11.284 ms. Dataset: dubrovnik-135-90642-pre.txt; AMD EPYC Milan, NVIDIA A100 80 GB PCIe; CUDA, driver, and TBB thread configuration not recorded.</a:t>
+              <a:t>553,336 x (24 Jacobian + 2 residual) x 8 B = 115,093,888 B = 115.1 MB. / 9.50 GiB/s = 11.283 ms. Dataset: dubrovnik-135-90642-pre.txt; AMD EPYC Milan, NVIDIA A100 80 GB PCIe; CUDA, driver, and TBB thread configuration not recorded.</a:t>
             </a:r>
             <a:endParaRPr lang="en-US" sz="1120" dirty="0"/>
           </a:p>
@@ -21391,7 +21391,54 @@
                   <a:srgbClr val="5A6472"/>
                 </a:solidFill>
               </a:rPr>
-              <a:t>Sources: https://ceres-solver.readthedocs.io/latest/installation.html | https://ceres-solver.readthedocs.io/latest/nnls_solving.html</a:t>
+              <a:t>Sources: </a:t>
+            </a:r>
+            <a:pPr indent="0" marL="0">
+              <a:buNone/>
+            </a:pPr>
+            <a:r>
+              <a:rPr lang="en-US" sz="950" u="sng" dirty="0">
+                <a:solidFill>
+                  <a:srgbClr val="3E74B8"/>
+                </a:solidFill>
+                <a:hlinkClick r:id="rId1" invalidUrl="" action="" tgtFrame="" tooltip="" history="1" highlightClick="0" endSnd="0">
+                  <a:extLst>
+                    <a:ext uri="{A12FA001-AC4F-418D-AE19-62706E023703}">
+                      <ahyp:hlinkClr xmlns:ahyp="http://schemas.microsoft.com/office/drawing/2018/hyperlinkcolor" val="tx"/>
+                    </a:ext>
+                  </a:extLst>
+                </a:hlinkClick>
+              </a:rPr>
+              <a:t>https://ceres-solver.readthedocs.io/latest/installation.html</a:t>
+            </a:r>
+            <a:pPr indent="0" marL="0">
+              <a:buNone/>
+            </a:pPr>
+            <a:r>
+              <a:rPr lang="en-US" sz="950" dirty="0">
+                <a:solidFill>
+                  <a:srgbClr val="5A6472"/>
+                </a:solidFill>
+              </a:rPr>
+              <a:t> | </a:t>
+            </a:r>
+            <a:pPr indent="0" marL="0">
+              <a:buNone/>
+            </a:pPr>
+            <a:r>
+              <a:rPr lang="en-US" sz="950" u="sng" dirty="0">
+                <a:solidFill>
+                  <a:srgbClr val="3E74B8"/>
+                </a:solidFill>
+                <a:hlinkClick r:id="rId2" invalidUrl="" action="" tgtFrame="" tooltip="" history="1" highlightClick="0" endSnd="0">
+                  <a:extLst>
+                    <a:ext uri="{A12FA001-AC4F-418D-AE19-62706E023703}">
+                      <ahyp:hlinkClr xmlns:ahyp="http://schemas.microsoft.com/office/drawing/2018/hyperlinkcolor" val="tx"/>
+                    </a:ext>
+                  </a:extLst>
+                </a:hlinkClick>
+              </a:rPr>
+              <a:t>https://ceres-solver.readthedocs.io/latest/nnls_solving.html</a:t>
             </a:r>
             <a:endParaRPr lang="en-US" sz="950" dirty="0"/>
           </a:p>
@@ -23048,7 +23095,7 @@
                   <a:srgbClr val="F2A23A"/>
                 </a:solidFill>
               </a:rPr>
-              <a:t>+11.284 ms</a:t>
+              <a:t>+11.283 ms</a:t>
             </a:r>
             <a:endParaRPr lang="en-US" sz="2500" dirty="0"/>
           </a:p>

</xml_diff>

<commit_message>
docs: finalize CUDA SFM progress deck QA
</commit_message>
<xml_diff>
--- a/timing/sfm_ba/benchmark_logs/20260710T_cuda_sfm_progress/cuda_sfm_progress_update.pptx
+++ b/timing/sfm_ba/benchmark_logs/20260710T_cuda_sfm_progress/cuda_sfm_progress_update.pptx
@@ -3188,7 +3188,7 @@
         <p:spPr>
           <a:xfrm>
             <a:off x="502920" y="1234440"/>
-            <a:ext cx="1143000" cy="288036"/>
+            <a:ext cx="1143000" cy="274320"/>
           </a:xfrm>
           <a:prstGeom prst="rect">
             <a:avLst/>
@@ -3213,7 +3213,7 @@
         <p:spPr>
           <a:xfrm>
             <a:off x="566928" y="1321308"/>
-            <a:ext cx="1014984" cy="150876"/>
+            <a:ext cx="1014984" cy="137160"/>
           </a:xfrm>
           <a:prstGeom prst="rect">
             <a:avLst/>
@@ -3231,14 +3231,14 @@
               <a:buNone/>
             </a:pPr>
             <a:r>
-              <a:rPr lang="en-US" sz="1080" b="1" dirty="0">
+              <a:rPr lang="en-US" sz="1050" b="1" dirty="0">
                 <a:solidFill>
                   <a:srgbClr val="FFFFFF"/>
                 </a:solidFill>
               </a:rPr>
               <a:t>Level</a:t>
             </a:r>
-            <a:endParaRPr lang="en-US" sz="1080" dirty="0"/>
+            <a:endParaRPr lang="en-US" sz="1050" dirty="0"/>
           </a:p>
         </p:txBody>
       </p:sp>
@@ -3251,7 +3251,7 @@
         <p:spPr>
           <a:xfrm>
             <a:off x="1645920" y="1234440"/>
-            <a:ext cx="4251960" cy="288036"/>
+            <a:ext cx="4251960" cy="274320"/>
           </a:xfrm>
           <a:prstGeom prst="rect">
             <a:avLst/>
@@ -3276,7 +3276,7 @@
         <p:spPr>
           <a:xfrm>
             <a:off x="1709928" y="1321308"/>
-            <a:ext cx="4123944" cy="150876"/>
+            <a:ext cx="4123944" cy="137160"/>
           </a:xfrm>
           <a:prstGeom prst="rect">
             <a:avLst/>
@@ -3294,14 +3294,14 @@
               <a:buNone/>
             </a:pPr>
             <a:r>
-              <a:rPr lang="en-US" sz="1080" b="1" dirty="0">
+              <a:rPr lang="en-US" sz="1050" b="1" dirty="0">
                 <a:solidFill>
                   <a:srgbClr val="FFFFFF"/>
                 </a:solidFill>
               </a:rPr>
               <a:t>Component</a:t>
             </a:r>
-            <a:endParaRPr lang="en-US" sz="1080" dirty="0"/>
+            <a:endParaRPr lang="en-US" sz="1050" dirty="0"/>
           </a:p>
         </p:txBody>
       </p:sp>
@@ -3314,7 +3314,7 @@
         <p:spPr>
           <a:xfrm>
             <a:off x="5897880" y="1234440"/>
-            <a:ext cx="1234440" cy="288036"/>
+            <a:ext cx="1234440" cy="274320"/>
           </a:xfrm>
           <a:prstGeom prst="rect">
             <a:avLst/>
@@ -3339,7 +3339,7 @@
         <p:spPr>
           <a:xfrm>
             <a:off x="5961888" y="1321308"/>
-            <a:ext cx="1106424" cy="150876"/>
+            <a:ext cx="1106424" cy="137160"/>
           </a:xfrm>
           <a:prstGeom prst="rect">
             <a:avLst/>
@@ -3357,14 +3357,14 @@
               <a:buNone/>
             </a:pPr>
             <a:r>
-              <a:rPr lang="en-US" sz="1080" b="1" dirty="0">
+              <a:rPr lang="en-US" sz="1050" b="1" dirty="0">
                 <a:solidFill>
                   <a:srgbClr val="FFFFFF"/>
                 </a:solidFill>
               </a:rPr>
               <a:t>Time</a:t>
             </a:r>
-            <a:endParaRPr lang="en-US" sz="1080" dirty="0"/>
+            <a:endParaRPr lang="en-US" sz="1050" dirty="0"/>
           </a:p>
         </p:txBody>
       </p:sp>
@@ -3377,7 +3377,7 @@
         <p:spPr>
           <a:xfrm>
             <a:off x="7132320" y="1234440"/>
-            <a:ext cx="1417320" cy="288036"/>
+            <a:ext cx="1417320" cy="274320"/>
           </a:xfrm>
           <a:prstGeom prst="rect">
             <a:avLst/>
@@ -3402,7 +3402,7 @@
         <p:spPr>
           <a:xfrm>
             <a:off x="7196328" y="1321308"/>
-            <a:ext cx="1289304" cy="150876"/>
+            <a:ext cx="1289304" cy="137160"/>
           </a:xfrm>
           <a:prstGeom prst="rect">
             <a:avLst/>
@@ -3420,14 +3420,14 @@
               <a:buNone/>
             </a:pPr>
             <a:r>
-              <a:rPr lang="en-US" sz="1080" b="1" dirty="0">
+              <a:rPr lang="en-US" sz="1050" b="1" dirty="0">
                 <a:solidFill>
                   <a:srgbClr val="FFFFFF"/>
                 </a:solidFill>
               </a:rPr>
               <a:t>% graph API</a:t>
             </a:r>
-            <a:endParaRPr lang="en-US" sz="1080" dirty="0"/>
+            <a:endParaRPr lang="en-US" sz="1050" dirty="0"/>
           </a:p>
         </p:txBody>
       </p:sp>
@@ -3440,7 +3440,7 @@
         <p:spPr>
           <a:xfrm>
             <a:off x="8549640" y="1234440"/>
-            <a:ext cx="1325880" cy="288036"/>
+            <a:ext cx="1325880" cy="274320"/>
           </a:xfrm>
           <a:prstGeom prst="rect">
             <a:avLst/>
@@ -3465,7 +3465,7 @@
         <p:spPr>
           <a:xfrm>
             <a:off x="8613648" y="1321308"/>
-            <a:ext cx="1197864" cy="150876"/>
+            <a:ext cx="1197864" cy="137160"/>
           </a:xfrm>
           <a:prstGeom prst="rect">
             <a:avLst/>
@@ -3483,14 +3483,14 @@
               <a:buNone/>
             </a:pPr>
             <a:r>
-              <a:rPr lang="en-US" sz="1080" b="1" dirty="0">
+              <a:rPr lang="en-US" sz="1050" b="1" dirty="0">
                 <a:solidFill>
                   <a:srgbClr val="FFFFFF"/>
                 </a:solidFill>
               </a:rPr>
               <a:t>% parent</a:t>
             </a:r>
-            <a:endParaRPr lang="en-US" sz="1080" dirty="0"/>
+            <a:endParaRPr lang="en-US" sz="1050" dirty="0"/>
           </a:p>
         </p:txBody>
       </p:sp>
@@ -3502,8 +3502,8 @@
         </p:nvSpPr>
         <p:spPr>
           <a:xfrm>
-            <a:off x="502920" y="1522476"/>
-            <a:ext cx="1143000" cy="288036"/>
+            <a:off x="502920" y="1508760"/>
+            <a:ext cx="1143000" cy="274320"/>
           </a:xfrm>
           <a:prstGeom prst="rect">
             <a:avLst/>
@@ -3527,8 +3527,8 @@
         </p:nvSpPr>
         <p:spPr>
           <a:xfrm>
-            <a:off x="566928" y="1609344"/>
-            <a:ext cx="1014984" cy="150876"/>
+            <a:off x="566928" y="1595628"/>
+            <a:ext cx="1014984" cy="137160"/>
           </a:xfrm>
           <a:prstGeom prst="rect">
             <a:avLst/>
@@ -3546,14 +3546,14 @@
               <a:buNone/>
             </a:pPr>
             <a:r>
-              <a:rPr lang="en-US" sz="1080" b="1" dirty="0">
+              <a:rPr lang="en-US" sz="1050" b="1" dirty="0">
                 <a:solidFill>
                   <a:srgbClr val="18212F"/>
                 </a:solidFill>
               </a:rPr>
               <a:t>Graph API</a:t>
             </a:r>
-            <a:endParaRPr lang="en-US" sz="1080" dirty="0"/>
+            <a:endParaRPr lang="en-US" sz="1050" dirty="0"/>
           </a:p>
         </p:txBody>
       </p:sp>
@@ -3565,8 +3565,8 @@
         </p:nvSpPr>
         <p:spPr>
           <a:xfrm>
-            <a:off x="1645920" y="1522476"/>
-            <a:ext cx="4251960" cy="288036"/>
+            <a:off x="1645920" y="1508760"/>
+            <a:ext cx="4251960" cy="274320"/>
           </a:xfrm>
           <a:prstGeom prst="rect">
             <a:avLst/>
@@ -3590,8 +3590,8 @@
         </p:nvSpPr>
         <p:spPr>
           <a:xfrm>
-            <a:off x="1709928" y="1609344"/>
-            <a:ext cx="4123944" cy="150876"/>
+            <a:off x="1709928" y="1595628"/>
+            <a:ext cx="4123944" cy="137160"/>
           </a:xfrm>
           <a:prstGeom prst="rect">
             <a:avLst/>
@@ -3609,14 +3609,14 @@
               <a:buNone/>
             </a:pPr>
             <a:r>
-              <a:rPr lang="en-US" sz="1080" dirty="0">
+              <a:rPr lang="en-US" sz="1050" dirty="0">
                 <a:solidFill>
                   <a:srgbClr val="18212F"/>
                 </a:solidFill>
               </a:rPr>
               <a:t>Optimizer construction</a:t>
             </a:r>
-            <a:endParaRPr lang="en-US" sz="1080" dirty="0"/>
+            <a:endParaRPr lang="en-US" sz="1050" dirty="0"/>
           </a:p>
         </p:txBody>
       </p:sp>
@@ -3628,8 +3628,8 @@
         </p:nvSpPr>
         <p:spPr>
           <a:xfrm>
-            <a:off x="5897880" y="1522476"/>
-            <a:ext cx="1234440" cy="288036"/>
+            <a:off x="5897880" y="1508760"/>
+            <a:ext cx="1234440" cy="274320"/>
           </a:xfrm>
           <a:prstGeom prst="rect">
             <a:avLst/>
@@ -3653,8 +3653,8 @@
         </p:nvSpPr>
         <p:spPr>
           <a:xfrm>
-            <a:off x="5961888" y="1609344"/>
-            <a:ext cx="1106424" cy="150876"/>
+            <a:off x="5961888" y="1595628"/>
+            <a:ext cx="1106424" cy="137160"/>
           </a:xfrm>
           <a:prstGeom prst="rect">
             <a:avLst/>
@@ -3672,14 +3672,14 @@
               <a:buNone/>
             </a:pPr>
             <a:r>
-              <a:rPr lang="en-US" sz="1080" dirty="0">
+              <a:rPr lang="en-US" sz="1050" dirty="0">
                 <a:solidFill>
                   <a:srgbClr val="18212F"/>
                 </a:solidFill>
               </a:rPr>
               <a:t>36.203</a:t>
             </a:r>
-            <a:endParaRPr lang="en-US" sz="1080" dirty="0"/>
+            <a:endParaRPr lang="en-US" sz="1050" dirty="0"/>
           </a:p>
         </p:txBody>
       </p:sp>
@@ -3691,8 +3691,8 @@
         </p:nvSpPr>
         <p:spPr>
           <a:xfrm>
-            <a:off x="7132320" y="1522476"/>
-            <a:ext cx="1417320" cy="288036"/>
+            <a:off x="7132320" y="1508760"/>
+            <a:ext cx="1417320" cy="274320"/>
           </a:xfrm>
           <a:prstGeom prst="rect">
             <a:avLst/>
@@ -3716,8 +3716,8 @@
         </p:nvSpPr>
         <p:spPr>
           <a:xfrm>
-            <a:off x="7196328" y="1609344"/>
-            <a:ext cx="1289304" cy="150876"/>
+            <a:off x="7196328" y="1595628"/>
+            <a:ext cx="1289304" cy="137160"/>
           </a:xfrm>
           <a:prstGeom prst="rect">
             <a:avLst/>
@@ -3735,14 +3735,14 @@
               <a:buNone/>
             </a:pPr>
             <a:r>
-              <a:rPr lang="en-US" sz="1080" dirty="0">
+              <a:rPr lang="en-US" sz="1050" dirty="0">
                 <a:solidFill>
                   <a:srgbClr val="18212F"/>
                 </a:solidFill>
               </a:rPr>
               <a:t>8.49%</a:t>
             </a:r>
-            <a:endParaRPr lang="en-US" sz="1080" dirty="0"/>
+            <a:endParaRPr lang="en-US" sz="1050" dirty="0"/>
           </a:p>
         </p:txBody>
       </p:sp>
@@ -3754,8 +3754,8 @@
         </p:nvSpPr>
         <p:spPr>
           <a:xfrm>
-            <a:off x="8549640" y="1522476"/>
-            <a:ext cx="1325880" cy="288036"/>
+            <a:off x="8549640" y="1508760"/>
+            <a:ext cx="1325880" cy="274320"/>
           </a:xfrm>
           <a:prstGeom prst="rect">
             <a:avLst/>
@@ -3779,8 +3779,8 @@
         </p:nvSpPr>
         <p:spPr>
           <a:xfrm>
-            <a:off x="8613648" y="1609344"/>
-            <a:ext cx="1197864" cy="150876"/>
+            <a:off x="8613648" y="1595628"/>
+            <a:ext cx="1197864" cy="137160"/>
           </a:xfrm>
           <a:prstGeom prst="rect">
             <a:avLst/>
@@ -3798,14 +3798,14 @@
               <a:buNone/>
             </a:pPr>
             <a:r>
-              <a:rPr lang="en-US" sz="1080" dirty="0">
+              <a:rPr lang="en-US" sz="1050" dirty="0">
                 <a:solidFill>
                   <a:srgbClr val="18212F"/>
                 </a:solidFill>
               </a:rPr>
               <a:t>-</a:t>
             </a:r>
-            <a:endParaRPr lang="en-US" sz="1080" dirty="0"/>
+            <a:endParaRPr lang="en-US" sz="1050" dirty="0"/>
           </a:p>
         </p:txBody>
       </p:sp>
@@ -3817,8 +3817,8 @@
         </p:nvSpPr>
         <p:spPr>
           <a:xfrm>
-            <a:off x="502920" y="1810512"/>
-            <a:ext cx="1143000" cy="288036"/>
+            <a:off x="502920" y="1783080"/>
+            <a:ext cx="1143000" cy="274320"/>
           </a:xfrm>
           <a:prstGeom prst="rect">
             <a:avLst/>
@@ -3842,8 +3842,8 @@
         </p:nvSpPr>
         <p:spPr>
           <a:xfrm>
-            <a:off x="566928" y="1897380"/>
-            <a:ext cx="1014984" cy="150876"/>
+            <a:off x="566928" y="1869948"/>
+            <a:ext cx="1014984" cy="137160"/>
           </a:xfrm>
           <a:prstGeom prst="rect">
             <a:avLst/>
@@ -3861,14 +3861,14 @@
               <a:buNone/>
             </a:pPr>
             <a:r>
-              <a:rPr lang="en-US" sz="1080" b="1" dirty="0">
+              <a:rPr lang="en-US" sz="1050" b="1" dirty="0">
                 <a:solidFill>
                   <a:srgbClr val="18212F"/>
                 </a:solidFill>
               </a:rPr>
               <a:t>Graph API</a:t>
             </a:r>
-            <a:endParaRPr lang="en-US" sz="1080" dirty="0"/>
+            <a:endParaRPr lang="en-US" sz="1050" dirty="0"/>
           </a:p>
         </p:txBody>
       </p:sp>
@@ -3880,8 +3880,8 @@
         </p:nvSpPr>
         <p:spPr>
           <a:xfrm>
-            <a:off x="1645920" y="1810512"/>
-            <a:ext cx="4251960" cy="288036"/>
+            <a:off x="1645920" y="1783080"/>
+            <a:ext cx="4251960" cy="274320"/>
           </a:xfrm>
           <a:prstGeom prst="rect">
             <a:avLst/>
@@ -3905,8 +3905,8 @@
         </p:nvSpPr>
         <p:spPr>
           <a:xfrm>
-            <a:off x="1709928" y="1897380"/>
-            <a:ext cx="4123944" cy="150876"/>
+            <a:off x="1709928" y="1869948"/>
+            <a:ext cx="4123944" cy="137160"/>
           </a:xfrm>
           <a:prstGeom prst="rect">
             <a:avLst/>
@@ -3924,14 +3924,14 @@
               <a:buNone/>
             </a:pPr>
             <a:r>
-              <a:rPr lang="en-US" sz="1080" dirty="0">
+              <a:rPr lang="en-US" sz="1050" dirty="0">
                 <a:solidFill>
                   <a:srgbClr val="18212F"/>
                 </a:solidFill>
               </a:rPr>
               <a:t>optimize()</a:t>
             </a:r>
-            <a:endParaRPr lang="en-US" sz="1080" dirty="0"/>
+            <a:endParaRPr lang="en-US" sz="1050" dirty="0"/>
           </a:p>
         </p:txBody>
       </p:sp>
@@ -3943,8 +3943,8 @@
         </p:nvSpPr>
         <p:spPr>
           <a:xfrm>
-            <a:off x="5897880" y="1810512"/>
-            <a:ext cx="1234440" cy="288036"/>
+            <a:off x="5897880" y="1783080"/>
+            <a:ext cx="1234440" cy="274320"/>
           </a:xfrm>
           <a:prstGeom prst="rect">
             <a:avLst/>
@@ -3968,8 +3968,8 @@
         </p:nvSpPr>
         <p:spPr>
           <a:xfrm>
-            <a:off x="5961888" y="1897380"/>
-            <a:ext cx="1106424" cy="150876"/>
+            <a:off x="5961888" y="1869948"/>
+            <a:ext cx="1106424" cy="137160"/>
           </a:xfrm>
           <a:prstGeom prst="rect">
             <a:avLst/>
@@ -3987,14 +3987,14 @@
               <a:buNone/>
             </a:pPr>
             <a:r>
-              <a:rPr lang="en-US" sz="1080" dirty="0">
+              <a:rPr lang="en-US" sz="1050" dirty="0">
                 <a:solidFill>
                   <a:srgbClr val="18212F"/>
                 </a:solidFill>
               </a:rPr>
               <a:t>376.192</a:t>
             </a:r>
-            <a:endParaRPr lang="en-US" sz="1080" dirty="0"/>
+            <a:endParaRPr lang="en-US" sz="1050" dirty="0"/>
           </a:p>
         </p:txBody>
       </p:sp>
@@ -4006,8 +4006,8 @@
         </p:nvSpPr>
         <p:spPr>
           <a:xfrm>
-            <a:off x="7132320" y="1810512"/>
-            <a:ext cx="1417320" cy="288036"/>
+            <a:off x="7132320" y="1783080"/>
+            <a:ext cx="1417320" cy="274320"/>
           </a:xfrm>
           <a:prstGeom prst="rect">
             <a:avLst/>
@@ -4031,8 +4031,8 @@
         </p:nvSpPr>
         <p:spPr>
           <a:xfrm>
-            <a:off x="7196328" y="1897380"/>
-            <a:ext cx="1289304" cy="150876"/>
+            <a:off x="7196328" y="1869948"/>
+            <a:ext cx="1289304" cy="137160"/>
           </a:xfrm>
           <a:prstGeom prst="rect">
             <a:avLst/>
@@ -4050,14 +4050,14 @@
               <a:buNone/>
             </a:pPr>
             <a:r>
-              <a:rPr lang="en-US" sz="1080" dirty="0">
+              <a:rPr lang="en-US" sz="1050" dirty="0">
                 <a:solidFill>
                   <a:srgbClr val="18212F"/>
                 </a:solidFill>
               </a:rPr>
               <a:t>88.26%</a:t>
             </a:r>
-            <a:endParaRPr lang="en-US" sz="1080" dirty="0"/>
+            <a:endParaRPr lang="en-US" sz="1050" dirty="0"/>
           </a:p>
         </p:txBody>
       </p:sp>
@@ -4069,8 +4069,8 @@
         </p:nvSpPr>
         <p:spPr>
           <a:xfrm>
-            <a:off x="8549640" y="1810512"/>
-            <a:ext cx="1325880" cy="288036"/>
+            <a:off x="8549640" y="1783080"/>
+            <a:ext cx="1325880" cy="274320"/>
           </a:xfrm>
           <a:prstGeom prst="rect">
             <a:avLst/>
@@ -4094,8 +4094,8 @@
         </p:nvSpPr>
         <p:spPr>
           <a:xfrm>
-            <a:off x="8613648" y="1897380"/>
-            <a:ext cx="1197864" cy="150876"/>
+            <a:off x="8613648" y="1869948"/>
+            <a:ext cx="1197864" cy="137160"/>
           </a:xfrm>
           <a:prstGeom prst="rect">
             <a:avLst/>
@@ -4113,14 +4113,14 @@
               <a:buNone/>
             </a:pPr>
             <a:r>
-              <a:rPr lang="en-US" sz="1080" dirty="0">
+              <a:rPr lang="en-US" sz="1050" dirty="0">
                 <a:solidFill>
                   <a:srgbClr val="18212F"/>
                 </a:solidFill>
               </a:rPr>
               <a:t>-</a:t>
             </a:r>
-            <a:endParaRPr lang="en-US" sz="1080" dirty="0"/>
+            <a:endParaRPr lang="en-US" sz="1050" dirty="0"/>
           </a:p>
         </p:txBody>
       </p:sp>
@@ -4132,8 +4132,8 @@
         </p:nvSpPr>
         <p:spPr>
           <a:xfrm>
-            <a:off x="502920" y="2098548"/>
-            <a:ext cx="1143000" cy="288036"/>
+            <a:off x="502920" y="2057400"/>
+            <a:ext cx="1143000" cy="274320"/>
           </a:xfrm>
           <a:prstGeom prst="rect">
             <a:avLst/>
@@ -4157,8 +4157,8 @@
         </p:nvSpPr>
         <p:spPr>
           <a:xfrm>
-            <a:off x="566928" y="2185416"/>
-            <a:ext cx="1014984" cy="150876"/>
+            <a:off x="566928" y="2144268"/>
+            <a:ext cx="1014984" cy="137160"/>
           </a:xfrm>
           <a:prstGeom prst="rect">
             <a:avLst/>
@@ -4176,14 +4176,14 @@
               <a:buNone/>
             </a:pPr>
             <a:r>
-              <a:rPr lang="en-US" sz="1080" b="1" dirty="0">
+              <a:rPr lang="en-US" sz="1050" b="1" dirty="0">
                 <a:solidFill>
                   <a:srgbClr val="18212F"/>
                 </a:solidFill>
               </a:rPr>
               <a:t>Graph API</a:t>
             </a:r>
-            <a:endParaRPr lang="en-US" sz="1080" dirty="0"/>
+            <a:endParaRPr lang="en-US" sz="1050" dirty="0"/>
           </a:p>
         </p:txBody>
       </p:sp>
@@ -4195,8 +4195,8 @@
         </p:nvSpPr>
         <p:spPr>
           <a:xfrm>
-            <a:off x="1645920" y="2098548"/>
-            <a:ext cx="4251960" cy="288036"/>
+            <a:off x="1645920" y="2057400"/>
+            <a:ext cx="4251960" cy="274320"/>
           </a:xfrm>
           <a:prstGeom prst="rect">
             <a:avLst/>
@@ -4220,8 +4220,8 @@
         </p:nvSpPr>
         <p:spPr>
           <a:xfrm>
-            <a:off x="1709928" y="2185416"/>
-            <a:ext cx="4123944" cy="150876"/>
+            <a:off x="1709928" y="2144268"/>
+            <a:ext cx="4123944" cy="137160"/>
           </a:xfrm>
           <a:prstGeom prst="rect">
             <a:avLst/>
@@ -4239,14 +4239,14 @@
               <a:buNone/>
             </a:pPr>
             <a:r>
-              <a:rPr lang="en-US" sz="1080" dirty="0">
+              <a:rPr lang="en-US" sz="1050" dirty="0">
                 <a:solidFill>
                   <a:srgbClr val="18212F"/>
                 </a:solidFill>
               </a:rPr>
               <a:t>Result/error queries</a:t>
             </a:r>
-            <a:endParaRPr lang="en-US" sz="1080" dirty="0"/>
+            <a:endParaRPr lang="en-US" sz="1050" dirty="0"/>
           </a:p>
         </p:txBody>
       </p:sp>
@@ -4258,8 +4258,8 @@
         </p:nvSpPr>
         <p:spPr>
           <a:xfrm>
-            <a:off x="5897880" y="2098548"/>
-            <a:ext cx="1234440" cy="288036"/>
+            <a:off x="5897880" y="2057400"/>
+            <a:ext cx="1234440" cy="274320"/>
           </a:xfrm>
           <a:prstGeom prst="rect">
             <a:avLst/>
@@ -4283,8 +4283,8 @@
         </p:nvSpPr>
         <p:spPr>
           <a:xfrm>
-            <a:off x="5961888" y="2185416"/>
-            <a:ext cx="1106424" cy="150876"/>
+            <a:off x="5961888" y="2144268"/>
+            <a:ext cx="1106424" cy="137160"/>
           </a:xfrm>
           <a:prstGeom prst="rect">
             <a:avLst/>
@@ -4302,14 +4302,14 @@
               <a:buNone/>
             </a:pPr>
             <a:r>
-              <a:rPr lang="en-US" sz="1080" dirty="0">
+              <a:rPr lang="en-US" sz="1050" dirty="0">
                 <a:solidFill>
                   <a:srgbClr val="18212F"/>
                 </a:solidFill>
               </a:rPr>
               <a:t>13.828</a:t>
             </a:r>
-            <a:endParaRPr lang="en-US" sz="1080" dirty="0"/>
+            <a:endParaRPr lang="en-US" sz="1050" dirty="0"/>
           </a:p>
         </p:txBody>
       </p:sp>
@@ -4321,8 +4321,8 @@
         </p:nvSpPr>
         <p:spPr>
           <a:xfrm>
-            <a:off x="7132320" y="2098548"/>
-            <a:ext cx="1417320" cy="288036"/>
+            <a:off x="7132320" y="2057400"/>
+            <a:ext cx="1417320" cy="274320"/>
           </a:xfrm>
           <a:prstGeom prst="rect">
             <a:avLst/>
@@ -4346,8 +4346,8 @@
         </p:nvSpPr>
         <p:spPr>
           <a:xfrm>
-            <a:off x="7196328" y="2185416"/>
-            <a:ext cx="1289304" cy="150876"/>
+            <a:off x="7196328" y="2144268"/>
+            <a:ext cx="1289304" cy="137160"/>
           </a:xfrm>
           <a:prstGeom prst="rect">
             <a:avLst/>
@@ -4365,14 +4365,14 @@
               <a:buNone/>
             </a:pPr>
             <a:r>
-              <a:rPr lang="en-US" sz="1080" dirty="0">
+              <a:rPr lang="en-US" sz="1050" dirty="0">
                 <a:solidFill>
                   <a:srgbClr val="18212F"/>
                 </a:solidFill>
               </a:rPr>
               <a:t>3.24%</a:t>
             </a:r>
-            <a:endParaRPr lang="en-US" sz="1080" dirty="0"/>
+            <a:endParaRPr lang="en-US" sz="1050" dirty="0"/>
           </a:p>
         </p:txBody>
       </p:sp>
@@ -4384,8 +4384,8 @@
         </p:nvSpPr>
         <p:spPr>
           <a:xfrm>
-            <a:off x="8549640" y="2098548"/>
-            <a:ext cx="1325880" cy="288036"/>
+            <a:off x="8549640" y="2057400"/>
+            <a:ext cx="1325880" cy="274320"/>
           </a:xfrm>
           <a:prstGeom prst="rect">
             <a:avLst/>
@@ -4409,8 +4409,8 @@
         </p:nvSpPr>
         <p:spPr>
           <a:xfrm>
-            <a:off x="8613648" y="2185416"/>
-            <a:ext cx="1197864" cy="150876"/>
+            <a:off x="8613648" y="2144268"/>
+            <a:ext cx="1197864" cy="137160"/>
           </a:xfrm>
           <a:prstGeom prst="rect">
             <a:avLst/>
@@ -4428,14 +4428,14 @@
               <a:buNone/>
             </a:pPr>
             <a:r>
-              <a:rPr lang="en-US" sz="1080" dirty="0">
+              <a:rPr lang="en-US" sz="1050" dirty="0">
                 <a:solidFill>
                   <a:srgbClr val="18212F"/>
                 </a:solidFill>
               </a:rPr>
               <a:t>-</a:t>
             </a:r>
-            <a:endParaRPr lang="en-US" sz="1080" dirty="0"/>
+            <a:endParaRPr lang="en-US" sz="1050" dirty="0"/>
           </a:p>
         </p:txBody>
       </p:sp>
@@ -4447,8 +4447,8 @@
         </p:nvSpPr>
         <p:spPr>
           <a:xfrm>
-            <a:off x="502920" y="2386584"/>
-            <a:ext cx="1143000" cy="288036"/>
+            <a:off x="502920" y="2331720"/>
+            <a:ext cx="1143000" cy="274320"/>
           </a:xfrm>
           <a:prstGeom prst="rect">
             <a:avLst/>
@@ -4472,8 +4472,8 @@
         </p:nvSpPr>
         <p:spPr>
           <a:xfrm>
-            <a:off x="566928" y="2473452"/>
-            <a:ext cx="1014984" cy="150876"/>
+            <a:off x="566928" y="2418588"/>
+            <a:ext cx="1014984" cy="137160"/>
           </a:xfrm>
           <a:prstGeom prst="rect">
             <a:avLst/>
@@ -4491,14 +4491,14 @@
               <a:buNone/>
             </a:pPr>
             <a:r>
-              <a:rPr lang="en-US" sz="1080" b="1" dirty="0">
+              <a:rPr lang="en-US" sz="1050" b="1" dirty="0">
                 <a:solidFill>
                   <a:srgbClr val="18212F"/>
                 </a:solidFill>
               </a:rPr>
               <a:t>optimize</a:t>
             </a:r>
-            <a:endParaRPr lang="en-US" sz="1080" dirty="0"/>
+            <a:endParaRPr lang="en-US" sz="1050" dirty="0"/>
           </a:p>
         </p:txBody>
       </p:sp>
@@ -4510,8 +4510,8 @@
         </p:nvSpPr>
         <p:spPr>
           <a:xfrm>
-            <a:off x="1645920" y="2386584"/>
-            <a:ext cx="4251960" cy="288036"/>
+            <a:off x="1645920" y="2331720"/>
+            <a:ext cx="4251960" cy="274320"/>
           </a:xfrm>
           <a:prstGeom prst="rect">
             <a:avLst/>
@@ -4535,8 +4535,8 @@
         </p:nvSpPr>
         <p:spPr>
           <a:xfrm>
-            <a:off x="1709928" y="2473452"/>
-            <a:ext cx="4123944" cy="150876"/>
+            <a:off x="1709928" y="2418588"/>
+            <a:ext cx="4123944" cy="137160"/>
           </a:xfrm>
           <a:prstGeom prst="rect">
             <a:avLst/>
@@ -4554,14 +4554,14 @@
               <a:buNone/>
             </a:pPr>
             <a:r>
-              <a:rPr lang="en-US" sz="1080" dirty="0">
+              <a:rPr lang="en-US" sz="1050" dirty="0">
                 <a:solidFill>
                   <a:srgbClr val="18212F"/>
                 </a:solidFill>
               </a:rPr>
               <a:t>Graph conversion</a:t>
             </a:r>
-            <a:endParaRPr lang="en-US" sz="1080" dirty="0"/>
+            <a:endParaRPr lang="en-US" sz="1050" dirty="0"/>
           </a:p>
         </p:txBody>
       </p:sp>
@@ -4573,8 +4573,8 @@
         </p:nvSpPr>
         <p:spPr>
           <a:xfrm>
-            <a:off x="5897880" y="2386584"/>
-            <a:ext cx="1234440" cy="288036"/>
+            <a:off x="5897880" y="2331720"/>
+            <a:ext cx="1234440" cy="274320"/>
           </a:xfrm>
           <a:prstGeom prst="rect">
             <a:avLst/>
@@ -4598,8 +4598,8 @@
         </p:nvSpPr>
         <p:spPr>
           <a:xfrm>
-            <a:off x="5961888" y="2473452"/>
-            <a:ext cx="1106424" cy="150876"/>
+            <a:off x="5961888" y="2418588"/>
+            <a:ext cx="1106424" cy="137160"/>
           </a:xfrm>
           <a:prstGeom prst="rect">
             <a:avLst/>
@@ -4617,14 +4617,14 @@
               <a:buNone/>
             </a:pPr>
             <a:r>
-              <a:rPr lang="en-US" sz="1080" dirty="0">
+              <a:rPr lang="en-US" sz="1050" dirty="0">
                 <a:solidFill>
                   <a:srgbClr val="18212F"/>
                 </a:solidFill>
               </a:rPr>
               <a:t>114.246</a:t>
             </a:r>
-            <a:endParaRPr lang="en-US" sz="1080" dirty="0"/>
+            <a:endParaRPr lang="en-US" sz="1050" dirty="0"/>
           </a:p>
         </p:txBody>
       </p:sp>
@@ -4636,8 +4636,8 @@
         </p:nvSpPr>
         <p:spPr>
           <a:xfrm>
-            <a:off x="7132320" y="2386584"/>
-            <a:ext cx="1417320" cy="288036"/>
+            <a:off x="7132320" y="2331720"/>
+            <a:ext cx="1417320" cy="274320"/>
           </a:xfrm>
           <a:prstGeom prst="rect">
             <a:avLst/>
@@ -4661,8 +4661,8 @@
         </p:nvSpPr>
         <p:spPr>
           <a:xfrm>
-            <a:off x="7196328" y="2473452"/>
-            <a:ext cx="1289304" cy="150876"/>
+            <a:off x="7196328" y="2418588"/>
+            <a:ext cx="1289304" cy="137160"/>
           </a:xfrm>
           <a:prstGeom prst="rect">
             <a:avLst/>
@@ -4680,14 +4680,14 @@
               <a:buNone/>
             </a:pPr>
             <a:r>
-              <a:rPr lang="en-US" sz="1080" dirty="0">
+              <a:rPr lang="en-US" sz="1050" dirty="0">
                 <a:solidFill>
                   <a:srgbClr val="18212F"/>
                 </a:solidFill>
               </a:rPr>
               <a:t>26.80%</a:t>
             </a:r>
-            <a:endParaRPr lang="en-US" sz="1080" dirty="0"/>
+            <a:endParaRPr lang="en-US" sz="1050" dirty="0"/>
           </a:p>
         </p:txBody>
       </p:sp>
@@ -4699,8 +4699,8 @@
         </p:nvSpPr>
         <p:spPr>
           <a:xfrm>
-            <a:off x="8549640" y="2386584"/>
-            <a:ext cx="1325880" cy="288036"/>
+            <a:off x="8549640" y="2331720"/>
+            <a:ext cx="1325880" cy="274320"/>
           </a:xfrm>
           <a:prstGeom prst="rect">
             <a:avLst/>
@@ -4724,8 +4724,8 @@
         </p:nvSpPr>
         <p:spPr>
           <a:xfrm>
-            <a:off x="8613648" y="2473452"/>
-            <a:ext cx="1197864" cy="150876"/>
+            <a:off x="8613648" y="2418588"/>
+            <a:ext cx="1197864" cy="137160"/>
           </a:xfrm>
           <a:prstGeom prst="rect">
             <a:avLst/>
@@ -4743,14 +4743,14 @@
               <a:buNone/>
             </a:pPr>
             <a:r>
-              <a:rPr lang="en-US" sz="1080" dirty="0">
+              <a:rPr lang="en-US" sz="1050" dirty="0">
                 <a:solidFill>
                   <a:srgbClr val="18212F"/>
                 </a:solidFill>
               </a:rPr>
               <a:t>30.37%</a:t>
             </a:r>
-            <a:endParaRPr lang="en-US" sz="1080" dirty="0"/>
+            <a:endParaRPr lang="en-US" sz="1050" dirty="0"/>
           </a:p>
         </p:txBody>
       </p:sp>
@@ -4762,8 +4762,8 @@
         </p:nvSpPr>
         <p:spPr>
           <a:xfrm>
-            <a:off x="502920" y="2674620"/>
-            <a:ext cx="1143000" cy="288036"/>
+            <a:off x="502920" y="2606040"/>
+            <a:ext cx="1143000" cy="274320"/>
           </a:xfrm>
           <a:prstGeom prst="rect">
             <a:avLst/>
@@ -4787,8 +4787,8 @@
         </p:nvSpPr>
         <p:spPr>
           <a:xfrm>
-            <a:off x="566928" y="2761488"/>
-            <a:ext cx="1014984" cy="150876"/>
+            <a:off x="566928" y="2692908"/>
+            <a:ext cx="1014984" cy="137160"/>
           </a:xfrm>
           <a:prstGeom prst="rect">
             <a:avLst/>
@@ -4806,14 +4806,14 @@
               <a:buNone/>
             </a:pPr>
             <a:r>
-              <a:rPr lang="en-US" sz="1080" b="1" dirty="0">
+              <a:rPr lang="en-US" sz="1050" b="1" dirty="0">
                 <a:solidFill>
                   <a:srgbClr val="18212F"/>
                 </a:solidFill>
               </a:rPr>
               <a:t>optimize</a:t>
             </a:r>
-            <a:endParaRPr lang="en-US" sz="1080" dirty="0"/>
+            <a:endParaRPr lang="en-US" sz="1050" dirty="0"/>
           </a:p>
         </p:txBody>
       </p:sp>
@@ -4825,8 +4825,8 @@
         </p:nvSpPr>
         <p:spPr>
           <a:xfrm>
-            <a:off x="1645920" y="2674620"/>
-            <a:ext cx="4251960" cy="288036"/>
+            <a:off x="1645920" y="2606040"/>
+            <a:ext cx="4251960" cy="274320"/>
           </a:xfrm>
           <a:prstGeom prst="rect">
             <a:avLst/>
@@ -4850,8 +4850,8 @@
         </p:nvSpPr>
         <p:spPr>
           <a:xfrm>
-            <a:off x="1709928" y="2761488"/>
-            <a:ext cx="4123944" cy="150876"/>
+            <a:off x="1709928" y="2692908"/>
+            <a:ext cx="4123944" cy="137160"/>
           </a:xfrm>
           <a:prstGeom prst="rect">
             <a:avLst/>
@@ -4869,14 +4869,14 @@
               <a:buNone/>
             </a:pPr>
             <a:r>
-              <a:rPr lang="en-US" sz="1080" dirty="0">
+              <a:rPr lang="en-US" sz="1050" dirty="0">
                 <a:solidFill>
                   <a:srgbClr val="18212F"/>
                 </a:solidFill>
               </a:rPr>
               <a:t>CUDA backend</a:t>
             </a:r>
-            <a:endParaRPr lang="en-US" sz="1080" dirty="0"/>
+            <a:endParaRPr lang="en-US" sz="1050" dirty="0"/>
           </a:p>
         </p:txBody>
       </p:sp>
@@ -4888,8 +4888,8 @@
         </p:nvSpPr>
         <p:spPr>
           <a:xfrm>
-            <a:off x="5897880" y="2674620"/>
-            <a:ext cx="1234440" cy="288036"/>
+            <a:off x="5897880" y="2606040"/>
+            <a:ext cx="1234440" cy="274320"/>
           </a:xfrm>
           <a:prstGeom prst="rect">
             <a:avLst/>
@@ -4913,8 +4913,8 @@
         </p:nvSpPr>
         <p:spPr>
           <a:xfrm>
-            <a:off x="5961888" y="2761488"/>
-            <a:ext cx="1106424" cy="150876"/>
+            <a:off x="5961888" y="2692908"/>
+            <a:ext cx="1106424" cy="137160"/>
           </a:xfrm>
           <a:prstGeom prst="rect">
             <a:avLst/>
@@ -4932,14 +4932,14 @@
               <a:buNone/>
             </a:pPr>
             <a:r>
-              <a:rPr lang="en-US" sz="1080" dirty="0">
+              <a:rPr lang="en-US" sz="1050" dirty="0">
                 <a:solidFill>
                   <a:srgbClr val="18212F"/>
                 </a:solidFill>
               </a:rPr>
               <a:t>137.542</a:t>
             </a:r>
-            <a:endParaRPr lang="en-US" sz="1080" dirty="0"/>
+            <a:endParaRPr lang="en-US" sz="1050" dirty="0"/>
           </a:p>
         </p:txBody>
       </p:sp>
@@ -4951,8 +4951,8 @@
         </p:nvSpPr>
         <p:spPr>
           <a:xfrm>
-            <a:off x="7132320" y="2674620"/>
-            <a:ext cx="1417320" cy="288036"/>
+            <a:off x="7132320" y="2606040"/>
+            <a:ext cx="1417320" cy="274320"/>
           </a:xfrm>
           <a:prstGeom prst="rect">
             <a:avLst/>
@@ -4976,8 +4976,8 @@
         </p:nvSpPr>
         <p:spPr>
           <a:xfrm>
-            <a:off x="7196328" y="2761488"/>
-            <a:ext cx="1289304" cy="150876"/>
+            <a:off x="7196328" y="2692908"/>
+            <a:ext cx="1289304" cy="137160"/>
           </a:xfrm>
           <a:prstGeom prst="rect">
             <a:avLst/>
@@ -4995,14 +4995,14 @@
               <a:buNone/>
             </a:pPr>
             <a:r>
-              <a:rPr lang="en-US" sz="1080" dirty="0">
+              <a:rPr lang="en-US" sz="1050" dirty="0">
                 <a:solidFill>
                   <a:srgbClr val="18212F"/>
                 </a:solidFill>
               </a:rPr>
               <a:t>32.27%</a:t>
             </a:r>
-            <a:endParaRPr lang="en-US" sz="1080" dirty="0"/>
+            <a:endParaRPr lang="en-US" sz="1050" dirty="0"/>
           </a:p>
         </p:txBody>
       </p:sp>
@@ -5014,8 +5014,8 @@
         </p:nvSpPr>
         <p:spPr>
           <a:xfrm>
-            <a:off x="8549640" y="2674620"/>
-            <a:ext cx="1325880" cy="288036"/>
+            <a:off x="8549640" y="2606040"/>
+            <a:ext cx="1325880" cy="274320"/>
           </a:xfrm>
           <a:prstGeom prst="rect">
             <a:avLst/>
@@ -5039,8 +5039,8 @@
         </p:nvSpPr>
         <p:spPr>
           <a:xfrm>
-            <a:off x="8613648" y="2761488"/>
-            <a:ext cx="1197864" cy="150876"/>
+            <a:off x="8613648" y="2692908"/>
+            <a:ext cx="1197864" cy="137160"/>
           </a:xfrm>
           <a:prstGeom prst="rect">
             <a:avLst/>
@@ -5058,14 +5058,14 @@
               <a:buNone/>
             </a:pPr>
             <a:r>
-              <a:rPr lang="en-US" sz="1080" dirty="0">
+              <a:rPr lang="en-US" sz="1050" dirty="0">
                 <a:solidFill>
                   <a:srgbClr val="18212F"/>
                 </a:solidFill>
               </a:rPr>
               <a:t>36.56%</a:t>
             </a:r>
-            <a:endParaRPr lang="en-US" sz="1080" dirty="0"/>
+            <a:endParaRPr lang="en-US" sz="1050" dirty="0"/>
           </a:p>
         </p:txBody>
       </p:sp>
@@ -5077,8 +5077,8 @@
         </p:nvSpPr>
         <p:spPr>
           <a:xfrm>
-            <a:off x="502920" y="2962656"/>
-            <a:ext cx="1143000" cy="288036"/>
+            <a:off x="502920" y="2880360"/>
+            <a:ext cx="1143000" cy="274320"/>
           </a:xfrm>
           <a:prstGeom prst="rect">
             <a:avLst/>
@@ -5102,8 +5102,8 @@
         </p:nvSpPr>
         <p:spPr>
           <a:xfrm>
-            <a:off x="566928" y="3049524"/>
-            <a:ext cx="1014984" cy="150876"/>
+            <a:off x="566928" y="2967228"/>
+            <a:ext cx="1014984" cy="137160"/>
           </a:xfrm>
           <a:prstGeom prst="rect">
             <a:avLst/>
@@ -5121,14 +5121,14 @@
               <a:buNone/>
             </a:pPr>
             <a:r>
-              <a:rPr lang="en-US" sz="1080" b="1" dirty="0">
+              <a:rPr lang="en-US" sz="1050" b="1" dirty="0">
                 <a:solidFill>
                   <a:srgbClr val="18212F"/>
                 </a:solidFill>
               </a:rPr>
               <a:t>optimize</a:t>
             </a:r>
-            <a:endParaRPr lang="en-US" sz="1080" dirty="0"/>
+            <a:endParaRPr lang="en-US" sz="1050" dirty="0"/>
           </a:p>
         </p:txBody>
       </p:sp>
@@ -5140,8 +5140,8 @@
         </p:nvSpPr>
         <p:spPr>
           <a:xfrm>
-            <a:off x="1645920" y="2962656"/>
-            <a:ext cx="4251960" cy="288036"/>
+            <a:off x="1645920" y="2880360"/>
+            <a:ext cx="4251960" cy="274320"/>
           </a:xfrm>
           <a:prstGeom prst="rect">
             <a:avLst/>
@@ -5165,8 +5165,8 @@
         </p:nvSpPr>
         <p:spPr>
           <a:xfrm>
-            <a:off x="1709928" y="3049524"/>
-            <a:ext cx="4123944" cy="150876"/>
+            <a:off x="1709928" y="2967228"/>
+            <a:ext cx="4123944" cy="137160"/>
           </a:xfrm>
           <a:prstGeom prst="rect">
             <a:avLst/>
@@ -5184,14 +5184,14 @@
               <a:buNone/>
             </a:pPr>
             <a:r>
-              <a:rPr lang="en-US" sz="1080" dirty="0">
+              <a:rPr lang="en-US" sz="1050" dirty="0">
                 <a:solidFill>
                   <a:srgbClr val="18212F"/>
                 </a:solidFill>
               </a:rPr>
               <a:t>Backend return / assignment</a:t>
             </a:r>
-            <a:endParaRPr lang="en-US" sz="1080" dirty="0"/>
+            <a:endParaRPr lang="en-US" sz="1050" dirty="0"/>
           </a:p>
         </p:txBody>
       </p:sp>
@@ -5203,8 +5203,8 @@
         </p:nvSpPr>
         <p:spPr>
           <a:xfrm>
-            <a:off x="5897880" y="2962656"/>
-            <a:ext cx="1234440" cy="288036"/>
+            <a:off x="5897880" y="2880360"/>
+            <a:ext cx="1234440" cy="274320"/>
           </a:xfrm>
           <a:prstGeom prst="rect">
             <a:avLst/>
@@ -5228,8 +5228,8 @@
         </p:nvSpPr>
         <p:spPr>
           <a:xfrm>
-            <a:off x="5961888" y="3049524"/>
-            <a:ext cx="1106424" cy="150876"/>
+            <a:off x="5961888" y="2967228"/>
+            <a:ext cx="1106424" cy="137160"/>
           </a:xfrm>
           <a:prstGeom prst="rect">
             <a:avLst/>
@@ -5247,14 +5247,14 @@
               <a:buNone/>
             </a:pPr>
             <a:r>
-              <a:rPr lang="en-US" sz="1080" dirty="0">
+              <a:rPr lang="en-US" sz="1050" dirty="0">
                 <a:solidFill>
                   <a:srgbClr val="18212F"/>
                 </a:solidFill>
               </a:rPr>
               <a:t>26.685</a:t>
             </a:r>
-            <a:endParaRPr lang="en-US" sz="1080" dirty="0"/>
+            <a:endParaRPr lang="en-US" sz="1050" dirty="0"/>
           </a:p>
         </p:txBody>
       </p:sp>
@@ -5266,8 +5266,8 @@
         </p:nvSpPr>
         <p:spPr>
           <a:xfrm>
-            <a:off x="7132320" y="2962656"/>
-            <a:ext cx="1417320" cy="288036"/>
+            <a:off x="7132320" y="2880360"/>
+            <a:ext cx="1417320" cy="274320"/>
           </a:xfrm>
           <a:prstGeom prst="rect">
             <a:avLst/>
@@ -5291,8 +5291,8 @@
         </p:nvSpPr>
         <p:spPr>
           <a:xfrm>
-            <a:off x="7196328" y="3049524"/>
-            <a:ext cx="1289304" cy="150876"/>
+            <a:off x="7196328" y="2967228"/>
+            <a:ext cx="1289304" cy="137160"/>
           </a:xfrm>
           <a:prstGeom prst="rect">
             <a:avLst/>
@@ -5310,14 +5310,14 @@
               <a:buNone/>
             </a:pPr>
             <a:r>
-              <a:rPr lang="en-US" sz="1080" dirty="0">
+              <a:rPr lang="en-US" sz="1050" dirty="0">
                 <a:solidFill>
                   <a:srgbClr val="18212F"/>
                 </a:solidFill>
               </a:rPr>
               <a:t>6.26%</a:t>
             </a:r>
-            <a:endParaRPr lang="en-US" sz="1080" dirty="0"/>
+            <a:endParaRPr lang="en-US" sz="1050" dirty="0"/>
           </a:p>
         </p:txBody>
       </p:sp>
@@ -5329,8 +5329,8 @@
         </p:nvSpPr>
         <p:spPr>
           <a:xfrm>
-            <a:off x="8549640" y="2962656"/>
-            <a:ext cx="1325880" cy="288036"/>
+            <a:off x="8549640" y="2880360"/>
+            <a:ext cx="1325880" cy="274320"/>
           </a:xfrm>
           <a:prstGeom prst="rect">
             <a:avLst/>
@@ -5354,8 +5354,8 @@
         </p:nvSpPr>
         <p:spPr>
           <a:xfrm>
-            <a:off x="8613648" y="3049524"/>
-            <a:ext cx="1197864" cy="150876"/>
+            <a:off x="8613648" y="2967228"/>
+            <a:ext cx="1197864" cy="137160"/>
           </a:xfrm>
           <a:prstGeom prst="rect">
             <a:avLst/>
@@ -5373,14 +5373,14 @@
               <a:buNone/>
             </a:pPr>
             <a:r>
-              <a:rPr lang="en-US" sz="1080" dirty="0">
+              <a:rPr lang="en-US" sz="1050" dirty="0">
                 <a:solidFill>
                   <a:srgbClr val="18212F"/>
                 </a:solidFill>
               </a:rPr>
               <a:t>7.09%</a:t>
             </a:r>
-            <a:endParaRPr lang="en-US" sz="1080" dirty="0"/>
+            <a:endParaRPr lang="en-US" sz="1050" dirty="0"/>
           </a:p>
         </p:txBody>
       </p:sp>
@@ -5392,8 +5392,8 @@
         </p:nvSpPr>
         <p:spPr>
           <a:xfrm>
-            <a:off x="502920" y="3250692"/>
-            <a:ext cx="1143000" cy="288036"/>
+            <a:off x="502920" y="3154680"/>
+            <a:ext cx="1143000" cy="274320"/>
           </a:xfrm>
           <a:prstGeom prst="rect">
             <a:avLst/>
@@ -5417,8 +5417,8 @@
         </p:nvSpPr>
         <p:spPr>
           <a:xfrm>
-            <a:off x="566928" y="3337560"/>
-            <a:ext cx="1014984" cy="150876"/>
+            <a:off x="566928" y="3241548"/>
+            <a:ext cx="1014984" cy="137160"/>
           </a:xfrm>
           <a:prstGeom prst="rect">
             <a:avLst/>
@@ -5436,14 +5436,14 @@
               <a:buNone/>
             </a:pPr>
             <a:r>
-              <a:rPr lang="en-US" sz="1080" b="1" dirty="0">
+              <a:rPr lang="en-US" sz="1050" b="1" dirty="0">
                 <a:solidFill>
                   <a:srgbClr val="18212F"/>
                 </a:solidFill>
               </a:rPr>
               <a:t>optimize</a:t>
             </a:r>
-            <a:endParaRPr lang="en-US" sz="1080" dirty="0"/>
+            <a:endParaRPr lang="en-US" sz="1050" dirty="0"/>
           </a:p>
         </p:txBody>
       </p:sp>
@@ -5455,8 +5455,8 @@
         </p:nvSpPr>
         <p:spPr>
           <a:xfrm>
-            <a:off x="1645920" y="3250692"/>
-            <a:ext cx="4251960" cy="288036"/>
+            <a:off x="1645920" y="3154680"/>
+            <a:ext cx="4251960" cy="274320"/>
           </a:xfrm>
           <a:prstGeom prst="rect">
             <a:avLst/>
@@ -5480,8 +5480,8 @@
         </p:nvSpPr>
         <p:spPr>
           <a:xfrm>
-            <a:off x="1709928" y="3337560"/>
-            <a:ext cx="4123944" cy="150876"/>
+            <a:off x="1709928" y="3241548"/>
+            <a:ext cx="4123944" cy="137160"/>
           </a:xfrm>
           <a:prstGeom prst="rect">
             <a:avLst/>
@@ -5499,14 +5499,14 @@
               <a:buNone/>
             </a:pPr>
             <a:r>
-              <a:rPr lang="en-US" sz="1080" dirty="0">
+              <a:rPr lang="en-US" sz="1050" dirty="0">
                 <a:solidFill>
                   <a:srgbClr val="18212F"/>
                 </a:solidFill>
               </a:rPr>
               <a:t>Values merge / state update</a:t>
             </a:r>
-            <a:endParaRPr lang="en-US" sz="1080" dirty="0"/>
+            <a:endParaRPr lang="en-US" sz="1050" dirty="0"/>
           </a:p>
         </p:txBody>
       </p:sp>
@@ -5518,8 +5518,8 @@
         </p:nvSpPr>
         <p:spPr>
           <a:xfrm>
-            <a:off x="5897880" y="3250692"/>
-            <a:ext cx="1234440" cy="288036"/>
+            <a:off x="5897880" y="3154680"/>
+            <a:ext cx="1234440" cy="274320"/>
           </a:xfrm>
           <a:prstGeom prst="rect">
             <a:avLst/>
@@ -5543,8 +5543,8 @@
         </p:nvSpPr>
         <p:spPr>
           <a:xfrm>
-            <a:off x="5961888" y="3337560"/>
-            <a:ext cx="1106424" cy="150876"/>
+            <a:off x="5961888" y="3241548"/>
+            <a:ext cx="1106424" cy="137160"/>
           </a:xfrm>
           <a:prstGeom prst="rect">
             <a:avLst/>
@@ -5562,14 +5562,14 @@
               <a:buNone/>
             </a:pPr>
             <a:r>
-              <a:rPr lang="en-US" sz="1080" dirty="0">
+              <a:rPr lang="en-US" sz="1050" dirty="0">
                 <a:solidFill>
                   <a:srgbClr val="18212F"/>
                 </a:solidFill>
               </a:rPr>
               <a:t>67.464</a:t>
             </a:r>
-            <a:endParaRPr lang="en-US" sz="1080" dirty="0"/>
+            <a:endParaRPr lang="en-US" sz="1050" dirty="0"/>
           </a:p>
         </p:txBody>
       </p:sp>
@@ -5581,8 +5581,8 @@
         </p:nvSpPr>
         <p:spPr>
           <a:xfrm>
-            <a:off x="7132320" y="3250692"/>
-            <a:ext cx="1417320" cy="288036"/>
+            <a:off x="7132320" y="3154680"/>
+            <a:ext cx="1417320" cy="274320"/>
           </a:xfrm>
           <a:prstGeom prst="rect">
             <a:avLst/>
@@ -5606,8 +5606,8 @@
         </p:nvSpPr>
         <p:spPr>
           <a:xfrm>
-            <a:off x="7196328" y="3337560"/>
-            <a:ext cx="1289304" cy="150876"/>
+            <a:off x="7196328" y="3241548"/>
+            <a:ext cx="1289304" cy="137160"/>
           </a:xfrm>
           <a:prstGeom prst="rect">
             <a:avLst/>
@@ -5625,14 +5625,14 @@
               <a:buNone/>
             </a:pPr>
             <a:r>
-              <a:rPr lang="en-US" sz="1080" dirty="0">
+              <a:rPr lang="en-US" sz="1050" dirty="0">
                 <a:solidFill>
                   <a:srgbClr val="18212F"/>
                 </a:solidFill>
               </a:rPr>
               <a:t>15.83%</a:t>
             </a:r>
-            <a:endParaRPr lang="en-US" sz="1080" dirty="0"/>
+            <a:endParaRPr lang="en-US" sz="1050" dirty="0"/>
           </a:p>
         </p:txBody>
       </p:sp>
@@ -5644,8 +5644,8 @@
         </p:nvSpPr>
         <p:spPr>
           <a:xfrm>
-            <a:off x="8549640" y="3250692"/>
-            <a:ext cx="1325880" cy="288036"/>
+            <a:off x="8549640" y="3154680"/>
+            <a:ext cx="1325880" cy="274320"/>
           </a:xfrm>
           <a:prstGeom prst="rect">
             <a:avLst/>
@@ -5669,8 +5669,8 @@
         </p:nvSpPr>
         <p:spPr>
           <a:xfrm>
-            <a:off x="8613648" y="3337560"/>
-            <a:ext cx="1197864" cy="150876"/>
+            <a:off x="8613648" y="3241548"/>
+            <a:ext cx="1197864" cy="137160"/>
           </a:xfrm>
           <a:prstGeom prst="rect">
             <a:avLst/>
@@ -5688,14 +5688,14 @@
               <a:buNone/>
             </a:pPr>
             <a:r>
-              <a:rPr lang="en-US" sz="1080" dirty="0">
+              <a:rPr lang="en-US" sz="1050" dirty="0">
                 <a:solidFill>
                   <a:srgbClr val="18212F"/>
                 </a:solidFill>
               </a:rPr>
               <a:t>17.93%</a:t>
             </a:r>
-            <a:endParaRPr lang="en-US" sz="1080" dirty="0"/>
+            <a:endParaRPr lang="en-US" sz="1050" dirty="0"/>
           </a:p>
         </p:txBody>
       </p:sp>
@@ -5707,8 +5707,8 @@
         </p:nvSpPr>
         <p:spPr>
           <a:xfrm>
-            <a:off x="502920" y="3538728"/>
-            <a:ext cx="1143000" cy="288036"/>
+            <a:off x="502920" y="3429000"/>
+            <a:ext cx="1143000" cy="274320"/>
           </a:xfrm>
           <a:prstGeom prst="rect">
             <a:avLst/>
@@ -5732,8 +5732,8 @@
         </p:nvSpPr>
         <p:spPr>
           <a:xfrm>
-            <a:off x="566928" y="3625596"/>
-            <a:ext cx="1014984" cy="150876"/>
+            <a:off x="566928" y="3515868"/>
+            <a:ext cx="1014984" cy="137160"/>
           </a:xfrm>
           <a:prstGeom prst="rect">
             <a:avLst/>
@@ -5751,14 +5751,14 @@
               <a:buNone/>
             </a:pPr>
             <a:r>
-              <a:rPr lang="en-US" sz="1080" b="1" dirty="0">
+              <a:rPr lang="en-US" sz="1050" b="1" dirty="0">
                 <a:solidFill>
                   <a:srgbClr val="18212F"/>
                 </a:solidFill>
               </a:rPr>
               <a:t>optimize</a:t>
             </a:r>
-            <a:endParaRPr lang="en-US" sz="1080" dirty="0"/>
+            <a:endParaRPr lang="en-US" sz="1050" dirty="0"/>
           </a:p>
         </p:txBody>
       </p:sp>
@@ -5770,8 +5770,8 @@
         </p:nvSpPr>
         <p:spPr>
           <a:xfrm>
-            <a:off x="1645920" y="3538728"/>
-            <a:ext cx="4251960" cy="288036"/>
+            <a:off x="1645920" y="3429000"/>
+            <a:ext cx="4251960" cy="274320"/>
           </a:xfrm>
           <a:prstGeom prst="rect">
             <a:avLst/>
@@ -5795,8 +5795,8 @@
         </p:nvSpPr>
         <p:spPr>
           <a:xfrm>
-            <a:off x="1709928" y="3625596"/>
-            <a:ext cx="4123944" cy="150876"/>
+            <a:off x="1709928" y="3515868"/>
+            <a:ext cx="4123944" cy="137160"/>
           </a:xfrm>
           <a:prstGeom prst="rect">
             <a:avLst/>
@@ -5814,14 +5814,14 @@
               <a:buNone/>
             </a:pPr>
             <a:r>
-              <a:rPr lang="en-US" sz="1080" dirty="0">
+              <a:rPr lang="en-US" sz="1050" dirty="0">
                 <a:solidFill>
                   <a:srgbClr val="18212F"/>
                 </a:solidFill>
               </a:rPr>
               <a:t>Converted-data destruction</a:t>
             </a:r>
-            <a:endParaRPr lang="en-US" sz="1080" dirty="0"/>
+            <a:endParaRPr lang="en-US" sz="1050" dirty="0"/>
           </a:p>
         </p:txBody>
       </p:sp>
@@ -5833,8 +5833,8 @@
         </p:nvSpPr>
         <p:spPr>
           <a:xfrm>
-            <a:off x="5897880" y="3538728"/>
-            <a:ext cx="1234440" cy="288036"/>
+            <a:off x="5897880" y="3429000"/>
+            <a:ext cx="1234440" cy="274320"/>
           </a:xfrm>
           <a:prstGeom prst="rect">
             <a:avLst/>
@@ -5858,8 +5858,8 @@
         </p:nvSpPr>
         <p:spPr>
           <a:xfrm>
-            <a:off x="5961888" y="3625596"/>
-            <a:ext cx="1106424" cy="150876"/>
+            <a:off x="5961888" y="3515868"/>
+            <a:ext cx="1106424" cy="137160"/>
           </a:xfrm>
           <a:prstGeom prst="rect">
             <a:avLst/>
@@ -5877,14 +5877,14 @@
               <a:buNone/>
             </a:pPr>
             <a:r>
-              <a:rPr lang="en-US" sz="1080" dirty="0">
+              <a:rPr lang="en-US" sz="1050" dirty="0">
                 <a:solidFill>
                   <a:srgbClr val="18212F"/>
                 </a:solidFill>
               </a:rPr>
               <a:t>30.247</a:t>
             </a:r>
-            <a:endParaRPr lang="en-US" sz="1080" dirty="0"/>
+            <a:endParaRPr lang="en-US" sz="1050" dirty="0"/>
           </a:p>
         </p:txBody>
       </p:sp>
@@ -5896,8 +5896,8 @@
         </p:nvSpPr>
         <p:spPr>
           <a:xfrm>
-            <a:off x="7132320" y="3538728"/>
-            <a:ext cx="1417320" cy="288036"/>
+            <a:off x="7132320" y="3429000"/>
+            <a:ext cx="1417320" cy="274320"/>
           </a:xfrm>
           <a:prstGeom prst="rect">
             <a:avLst/>
@@ -5921,8 +5921,8 @@
         </p:nvSpPr>
         <p:spPr>
           <a:xfrm>
-            <a:off x="7196328" y="3625596"/>
-            <a:ext cx="1289304" cy="150876"/>
+            <a:off x="7196328" y="3515868"/>
+            <a:ext cx="1289304" cy="137160"/>
           </a:xfrm>
           <a:prstGeom prst="rect">
             <a:avLst/>
@@ -5940,14 +5940,14 @@
               <a:buNone/>
             </a:pPr>
             <a:r>
-              <a:rPr lang="en-US" sz="1080" dirty="0">
+              <a:rPr lang="en-US" sz="1050" dirty="0">
                 <a:solidFill>
                   <a:srgbClr val="18212F"/>
                 </a:solidFill>
               </a:rPr>
               <a:t>7.10%</a:t>
             </a:r>
-            <a:endParaRPr lang="en-US" sz="1080" dirty="0"/>
+            <a:endParaRPr lang="en-US" sz="1050" dirty="0"/>
           </a:p>
         </p:txBody>
       </p:sp>
@@ -5959,8 +5959,8 @@
         </p:nvSpPr>
         <p:spPr>
           <a:xfrm>
-            <a:off x="8549640" y="3538728"/>
-            <a:ext cx="1325880" cy="288036"/>
+            <a:off x="8549640" y="3429000"/>
+            <a:ext cx="1325880" cy="274320"/>
           </a:xfrm>
           <a:prstGeom prst="rect">
             <a:avLst/>
@@ -5984,8 +5984,8 @@
         </p:nvSpPr>
         <p:spPr>
           <a:xfrm>
-            <a:off x="8613648" y="3625596"/>
-            <a:ext cx="1197864" cy="150876"/>
+            <a:off x="8613648" y="3515868"/>
+            <a:ext cx="1197864" cy="137160"/>
           </a:xfrm>
           <a:prstGeom prst="rect">
             <a:avLst/>
@@ -6003,14 +6003,14 @@
               <a:buNone/>
             </a:pPr>
             <a:r>
-              <a:rPr lang="en-US" sz="1080" dirty="0">
+              <a:rPr lang="en-US" sz="1050" dirty="0">
                 <a:solidFill>
                   <a:srgbClr val="18212F"/>
                 </a:solidFill>
               </a:rPr>
               <a:t>8.04%</a:t>
             </a:r>
-            <a:endParaRPr lang="en-US" sz="1080" dirty="0"/>
+            <a:endParaRPr lang="en-US" sz="1050" dirty="0"/>
           </a:p>
         </p:txBody>
       </p:sp>
@@ -6022,8 +6022,8 @@
         </p:nvSpPr>
         <p:spPr>
           <a:xfrm>
-            <a:off x="502920" y="3826764"/>
-            <a:ext cx="1143000" cy="288036"/>
+            <a:off x="502920" y="3703320"/>
+            <a:ext cx="1143000" cy="274320"/>
           </a:xfrm>
           <a:prstGeom prst="rect">
             <a:avLst/>
@@ -6047,8 +6047,8 @@
         </p:nvSpPr>
         <p:spPr>
           <a:xfrm>
-            <a:off x="566928" y="3913632"/>
-            <a:ext cx="1014984" cy="150876"/>
+            <a:off x="566928" y="3790188"/>
+            <a:ext cx="1014984" cy="137160"/>
           </a:xfrm>
           <a:prstGeom prst="rect">
             <a:avLst/>
@@ -6066,14 +6066,14 @@
               <a:buNone/>
             </a:pPr>
             <a:r>
-              <a:rPr lang="en-US" sz="1080" b="1" dirty="0">
+              <a:rPr lang="en-US" sz="1050" b="1" dirty="0">
                 <a:solidFill>
                   <a:srgbClr val="18212F"/>
                 </a:solidFill>
               </a:rPr>
               <a:t>backend</a:t>
             </a:r>
-            <a:endParaRPr lang="en-US" sz="1080" dirty="0"/>
+            <a:endParaRPr lang="en-US" sz="1050" dirty="0"/>
           </a:p>
         </p:txBody>
       </p:sp>
@@ -6085,8 +6085,8 @@
         </p:nvSpPr>
         <p:spPr>
           <a:xfrm>
-            <a:off x="1645920" y="3826764"/>
-            <a:ext cx="4251960" cy="288036"/>
+            <a:off x="1645920" y="3703320"/>
+            <a:ext cx="4251960" cy="274320"/>
           </a:xfrm>
           <a:prstGeom prst="rect">
             <a:avLst/>
@@ -6110,8 +6110,8 @@
         </p:nvSpPr>
         <p:spPr>
           <a:xfrm>
-            <a:off x="1709928" y="3913632"/>
-            <a:ext cx="4123944" cy="150876"/>
+            <a:off x="1709928" y="3790188"/>
+            <a:ext cx="4123944" cy="137160"/>
           </a:xfrm>
           <a:prstGeom prst="rect">
             <a:avLst/>
@@ -6129,14 +6129,14 @@
               <a:buNone/>
             </a:pPr>
             <a:r>
-              <a:rPr lang="en-US" sz="1080" dirty="0">
+              <a:rPr lang="en-US" sz="1050" dirty="0">
                 <a:solidFill>
                   <a:srgbClr val="18212F"/>
                 </a:solidFill>
               </a:rPr>
               <a:t>Setup</a:t>
             </a:r>
-            <a:endParaRPr lang="en-US" sz="1080" dirty="0"/>
+            <a:endParaRPr lang="en-US" sz="1050" dirty="0"/>
           </a:p>
         </p:txBody>
       </p:sp>
@@ -6148,8 +6148,8 @@
         </p:nvSpPr>
         <p:spPr>
           <a:xfrm>
-            <a:off x="5897880" y="3826764"/>
-            <a:ext cx="1234440" cy="288036"/>
+            <a:off x="5897880" y="3703320"/>
+            <a:ext cx="1234440" cy="274320"/>
           </a:xfrm>
           <a:prstGeom prst="rect">
             <a:avLst/>
@@ -6173,8 +6173,8 @@
         </p:nvSpPr>
         <p:spPr>
           <a:xfrm>
-            <a:off x="5961888" y="3913632"/>
-            <a:ext cx="1106424" cy="150876"/>
+            <a:off x="5961888" y="3790188"/>
+            <a:ext cx="1106424" cy="137160"/>
           </a:xfrm>
           <a:prstGeom prst="rect">
             <a:avLst/>
@@ -6192,14 +6192,14 @@
               <a:buNone/>
             </a:pPr>
             <a:r>
-              <a:rPr lang="en-US" sz="1080" dirty="0">
+              <a:rPr lang="en-US" sz="1050" dirty="0">
                 <a:solidFill>
                   <a:srgbClr val="18212F"/>
                 </a:solidFill>
               </a:rPr>
               <a:t>67.544</a:t>
             </a:r>
-            <a:endParaRPr lang="en-US" sz="1080" dirty="0"/>
+            <a:endParaRPr lang="en-US" sz="1050" dirty="0"/>
           </a:p>
         </p:txBody>
       </p:sp>
@@ -6211,8 +6211,8 @@
         </p:nvSpPr>
         <p:spPr>
           <a:xfrm>
-            <a:off x="7132320" y="3826764"/>
-            <a:ext cx="1417320" cy="288036"/>
+            <a:off x="7132320" y="3703320"/>
+            <a:ext cx="1417320" cy="274320"/>
           </a:xfrm>
           <a:prstGeom prst="rect">
             <a:avLst/>
@@ -6236,8 +6236,8 @@
         </p:nvSpPr>
         <p:spPr>
           <a:xfrm>
-            <a:off x="7196328" y="3913632"/>
-            <a:ext cx="1289304" cy="150876"/>
+            <a:off x="7196328" y="3790188"/>
+            <a:ext cx="1289304" cy="137160"/>
           </a:xfrm>
           <a:prstGeom prst="rect">
             <a:avLst/>
@@ -6255,14 +6255,14 @@
               <a:buNone/>
             </a:pPr>
             <a:r>
-              <a:rPr lang="en-US" sz="1080" dirty="0">
+              <a:rPr lang="en-US" sz="1050" dirty="0">
                 <a:solidFill>
                   <a:srgbClr val="18212F"/>
                 </a:solidFill>
               </a:rPr>
               <a:t>15.85%</a:t>
             </a:r>
-            <a:endParaRPr lang="en-US" sz="1080" dirty="0"/>
+            <a:endParaRPr lang="en-US" sz="1050" dirty="0"/>
           </a:p>
         </p:txBody>
       </p:sp>
@@ -6274,8 +6274,8 @@
         </p:nvSpPr>
         <p:spPr>
           <a:xfrm>
-            <a:off x="8549640" y="3826764"/>
-            <a:ext cx="1325880" cy="288036"/>
+            <a:off x="8549640" y="3703320"/>
+            <a:ext cx="1325880" cy="274320"/>
           </a:xfrm>
           <a:prstGeom prst="rect">
             <a:avLst/>
@@ -6299,8 +6299,8 @@
         </p:nvSpPr>
         <p:spPr>
           <a:xfrm>
-            <a:off x="8613648" y="3913632"/>
-            <a:ext cx="1197864" cy="150876"/>
+            <a:off x="8613648" y="3790188"/>
+            <a:ext cx="1197864" cy="137160"/>
           </a:xfrm>
           <a:prstGeom prst="rect">
             <a:avLst/>
@@ -6318,14 +6318,14 @@
               <a:buNone/>
             </a:pPr>
             <a:r>
-              <a:rPr lang="en-US" sz="1080" dirty="0">
+              <a:rPr lang="en-US" sz="1050" dirty="0">
                 <a:solidFill>
                   <a:srgbClr val="18212F"/>
                 </a:solidFill>
               </a:rPr>
               <a:t>49.11%</a:t>
             </a:r>
-            <a:endParaRPr lang="en-US" sz="1080" dirty="0"/>
+            <a:endParaRPr lang="en-US" sz="1050" dirty="0"/>
           </a:p>
         </p:txBody>
       </p:sp>
@@ -6337,8 +6337,8 @@
         </p:nvSpPr>
         <p:spPr>
           <a:xfrm>
-            <a:off x="502920" y="4114800"/>
-            <a:ext cx="1143000" cy="288036"/>
+            <a:off x="502920" y="3977640"/>
+            <a:ext cx="1143000" cy="274320"/>
           </a:xfrm>
           <a:prstGeom prst="rect">
             <a:avLst/>
@@ -6362,8 +6362,8 @@
         </p:nvSpPr>
         <p:spPr>
           <a:xfrm>
-            <a:off x="566928" y="4201668"/>
-            <a:ext cx="1014984" cy="150876"/>
+            <a:off x="566928" y="4064508"/>
+            <a:ext cx="1014984" cy="137160"/>
           </a:xfrm>
           <a:prstGeom prst="rect">
             <a:avLst/>
@@ -6381,14 +6381,14 @@
               <a:buNone/>
             </a:pPr>
             <a:r>
-              <a:rPr lang="en-US" sz="1080" b="1" dirty="0">
+              <a:rPr lang="en-US" sz="1050" b="1" dirty="0">
                 <a:solidFill>
                   <a:srgbClr val="18212F"/>
                 </a:solidFill>
               </a:rPr>
               <a:t>backend</a:t>
             </a:r>
-            <a:endParaRPr lang="en-US" sz="1080" dirty="0"/>
+            <a:endParaRPr lang="en-US" sz="1050" dirty="0"/>
           </a:p>
         </p:txBody>
       </p:sp>
@@ -6400,8 +6400,8 @@
         </p:nvSpPr>
         <p:spPr>
           <a:xfrm>
-            <a:off x="1645920" y="4114800"/>
-            <a:ext cx="4251960" cy="288036"/>
+            <a:off x="1645920" y="3977640"/>
+            <a:ext cx="4251960" cy="274320"/>
           </a:xfrm>
           <a:prstGeom prst="rect">
             <a:avLst/>
@@ -6425,8 +6425,8 @@
         </p:nvSpPr>
         <p:spPr>
           <a:xfrm>
-            <a:off x="1709928" y="4201668"/>
-            <a:ext cx="4123944" cy="150876"/>
+            <a:off x="1709928" y="4064508"/>
+            <a:ext cx="4123944" cy="137160"/>
           </a:xfrm>
           <a:prstGeom prst="rect">
             <a:avLst/>
@@ -6444,14 +6444,14 @@
               <a:buNone/>
             </a:pPr>
             <a:r>
-              <a:rPr lang="en-US" sz="1080" dirty="0">
+              <a:rPr lang="en-US" sz="1050" dirty="0">
                 <a:solidFill>
                   <a:srgbClr val="18212F"/>
                 </a:solidFill>
               </a:rPr>
               <a:t>Solve loop</a:t>
             </a:r>
-            <a:endParaRPr lang="en-US" sz="1080" dirty="0"/>
+            <a:endParaRPr lang="en-US" sz="1050" dirty="0"/>
           </a:p>
         </p:txBody>
       </p:sp>
@@ -6463,8 +6463,8 @@
         </p:nvSpPr>
         <p:spPr>
           <a:xfrm>
-            <a:off x="5897880" y="4114800"/>
-            <a:ext cx="1234440" cy="288036"/>
+            <a:off x="5897880" y="3977640"/>
+            <a:ext cx="1234440" cy="274320"/>
           </a:xfrm>
           <a:prstGeom prst="rect">
             <a:avLst/>
@@ -6488,8 +6488,8 @@
         </p:nvSpPr>
         <p:spPr>
           <a:xfrm>
-            <a:off x="5961888" y="4201668"/>
-            <a:ext cx="1106424" cy="150876"/>
+            <a:off x="5961888" y="4064508"/>
+            <a:ext cx="1106424" cy="137160"/>
           </a:xfrm>
           <a:prstGeom prst="rect">
             <a:avLst/>
@@ -6507,14 +6507,14 @@
               <a:buNone/>
             </a:pPr>
             <a:r>
-              <a:rPr lang="en-US" sz="1080" dirty="0">
+              <a:rPr lang="en-US" sz="1050" dirty="0">
                 <a:solidFill>
                   <a:srgbClr val="18212F"/>
                 </a:solidFill>
               </a:rPr>
               <a:t>29.968</a:t>
             </a:r>
-            <a:endParaRPr lang="en-US" sz="1080" dirty="0"/>
+            <a:endParaRPr lang="en-US" sz="1050" dirty="0"/>
           </a:p>
         </p:txBody>
       </p:sp>
@@ -6526,8 +6526,8 @@
         </p:nvSpPr>
         <p:spPr>
           <a:xfrm>
-            <a:off x="7132320" y="4114800"/>
-            <a:ext cx="1417320" cy="288036"/>
+            <a:off x="7132320" y="3977640"/>
+            <a:ext cx="1417320" cy="274320"/>
           </a:xfrm>
           <a:prstGeom prst="rect">
             <a:avLst/>
@@ -6551,8 +6551,8 @@
         </p:nvSpPr>
         <p:spPr>
           <a:xfrm>
-            <a:off x="7196328" y="4201668"/>
-            <a:ext cx="1289304" cy="150876"/>
+            <a:off x="7196328" y="4064508"/>
+            <a:ext cx="1289304" cy="137160"/>
           </a:xfrm>
           <a:prstGeom prst="rect">
             <a:avLst/>
@@ -6570,14 +6570,14 @@
               <a:buNone/>
             </a:pPr>
             <a:r>
-              <a:rPr lang="en-US" sz="1080" dirty="0">
+              <a:rPr lang="en-US" sz="1050" dirty="0">
                 <a:solidFill>
                   <a:srgbClr val="18212F"/>
                 </a:solidFill>
               </a:rPr>
               <a:t>7.03%</a:t>
             </a:r>
-            <a:endParaRPr lang="en-US" sz="1080" dirty="0"/>
+            <a:endParaRPr lang="en-US" sz="1050" dirty="0"/>
           </a:p>
         </p:txBody>
       </p:sp>
@@ -6589,8 +6589,8 @@
         </p:nvSpPr>
         <p:spPr>
           <a:xfrm>
-            <a:off x="8549640" y="4114800"/>
-            <a:ext cx="1325880" cy="288036"/>
+            <a:off x="8549640" y="3977640"/>
+            <a:ext cx="1325880" cy="274320"/>
           </a:xfrm>
           <a:prstGeom prst="rect">
             <a:avLst/>
@@ -6614,8 +6614,8 @@
         </p:nvSpPr>
         <p:spPr>
           <a:xfrm>
-            <a:off x="8613648" y="4201668"/>
-            <a:ext cx="1197864" cy="150876"/>
+            <a:off x="8613648" y="4064508"/>
+            <a:ext cx="1197864" cy="137160"/>
           </a:xfrm>
           <a:prstGeom prst="rect">
             <a:avLst/>
@@ -6633,14 +6633,14 @@
               <a:buNone/>
             </a:pPr>
             <a:r>
-              <a:rPr lang="en-US" sz="1080" dirty="0">
+              <a:rPr lang="en-US" sz="1050" dirty="0">
                 <a:solidFill>
                   <a:srgbClr val="18212F"/>
                 </a:solidFill>
               </a:rPr>
               <a:t>21.79%</a:t>
             </a:r>
-            <a:endParaRPr lang="en-US" sz="1080" dirty="0"/>
+            <a:endParaRPr lang="en-US" sz="1050" dirty="0"/>
           </a:p>
         </p:txBody>
       </p:sp>
@@ -6652,8 +6652,8 @@
         </p:nvSpPr>
         <p:spPr>
           <a:xfrm>
-            <a:off x="502920" y="4402836"/>
-            <a:ext cx="1143000" cy="288036"/>
+            <a:off x="502920" y="4251960"/>
+            <a:ext cx="1143000" cy="274320"/>
           </a:xfrm>
           <a:prstGeom prst="rect">
             <a:avLst/>
@@ -6677,8 +6677,8 @@
         </p:nvSpPr>
         <p:spPr>
           <a:xfrm>
-            <a:off x="566928" y="4489704"/>
-            <a:ext cx="1014984" cy="150876"/>
+            <a:off x="566928" y="4338828"/>
+            <a:ext cx="1014984" cy="137160"/>
           </a:xfrm>
           <a:prstGeom prst="rect">
             <a:avLst/>
@@ -6696,14 +6696,14 @@
               <a:buNone/>
             </a:pPr>
             <a:r>
-              <a:rPr lang="en-US" sz="1080" b="1" dirty="0">
+              <a:rPr lang="en-US" sz="1050" b="1" dirty="0">
                 <a:solidFill>
                   <a:srgbClr val="18212F"/>
                 </a:solidFill>
               </a:rPr>
               <a:t>backend</a:t>
             </a:r>
-            <a:endParaRPr lang="en-US" sz="1080" dirty="0"/>
+            <a:endParaRPr lang="en-US" sz="1050" dirty="0"/>
           </a:p>
         </p:txBody>
       </p:sp>
@@ -6715,8 +6715,8 @@
         </p:nvSpPr>
         <p:spPr>
           <a:xfrm>
-            <a:off x="1645920" y="4402836"/>
-            <a:ext cx="4251960" cy="288036"/>
+            <a:off x="1645920" y="4251960"/>
+            <a:ext cx="4251960" cy="274320"/>
           </a:xfrm>
           <a:prstGeom prst="rect">
             <a:avLst/>
@@ -6740,8 +6740,8 @@
         </p:nvSpPr>
         <p:spPr>
           <a:xfrm>
-            <a:off x="1709928" y="4489704"/>
-            <a:ext cx="4123944" cy="150876"/>
+            <a:off x="1709928" y="4338828"/>
+            <a:ext cx="4123944" cy="137160"/>
           </a:xfrm>
           <a:prstGeom prst="rect">
             <a:avLst/>
@@ -6759,14 +6759,14 @@
               <a:buNone/>
             </a:pPr>
             <a:r>
-              <a:rPr lang="en-US" sz="1080" dirty="0">
+              <a:rPr lang="en-US" sz="1050" dirty="0">
                 <a:solidFill>
                   <a:srgbClr val="18212F"/>
                 </a:solidFill>
               </a:rPr>
               <a:t>Download Values</a:t>
             </a:r>
-            <a:endParaRPr lang="en-US" sz="1080" dirty="0"/>
+            <a:endParaRPr lang="en-US" sz="1050" dirty="0"/>
           </a:p>
         </p:txBody>
       </p:sp>
@@ -6778,8 +6778,8 @@
         </p:nvSpPr>
         <p:spPr>
           <a:xfrm>
-            <a:off x="5897880" y="4402836"/>
-            <a:ext cx="1234440" cy="288036"/>
+            <a:off x="5897880" y="4251960"/>
+            <a:ext cx="1234440" cy="274320"/>
           </a:xfrm>
           <a:prstGeom prst="rect">
             <a:avLst/>
@@ -6803,8 +6803,8 @@
         </p:nvSpPr>
         <p:spPr>
           <a:xfrm>
-            <a:off x="5961888" y="4489704"/>
-            <a:ext cx="1106424" cy="150876"/>
+            <a:off x="5961888" y="4338828"/>
+            <a:ext cx="1106424" cy="137160"/>
           </a:xfrm>
           <a:prstGeom prst="rect">
             <a:avLst/>
@@ -6822,14 +6822,14 @@
               <a:buNone/>
             </a:pPr>
             <a:r>
-              <a:rPr lang="en-US" sz="1080" dirty="0">
+              <a:rPr lang="en-US" sz="1050" dirty="0">
                 <a:solidFill>
                   <a:srgbClr val="18212F"/>
                 </a:solidFill>
               </a:rPr>
               <a:t>40.030</a:t>
             </a:r>
-            <a:endParaRPr lang="en-US" sz="1080" dirty="0"/>
+            <a:endParaRPr lang="en-US" sz="1050" dirty="0"/>
           </a:p>
         </p:txBody>
       </p:sp>
@@ -6841,8 +6841,8 @@
         </p:nvSpPr>
         <p:spPr>
           <a:xfrm>
-            <a:off x="7132320" y="4402836"/>
-            <a:ext cx="1417320" cy="288036"/>
+            <a:off x="7132320" y="4251960"/>
+            <a:ext cx="1417320" cy="274320"/>
           </a:xfrm>
           <a:prstGeom prst="rect">
             <a:avLst/>
@@ -6866,8 +6866,8 @@
         </p:nvSpPr>
         <p:spPr>
           <a:xfrm>
-            <a:off x="7196328" y="4489704"/>
-            <a:ext cx="1289304" cy="150876"/>
+            <a:off x="7196328" y="4338828"/>
+            <a:ext cx="1289304" cy="137160"/>
           </a:xfrm>
           <a:prstGeom prst="rect">
             <a:avLst/>
@@ -6885,14 +6885,14 @@
               <a:buNone/>
             </a:pPr>
             <a:r>
-              <a:rPr lang="en-US" sz="1080" dirty="0">
+              <a:rPr lang="en-US" sz="1050" dirty="0">
                 <a:solidFill>
                   <a:srgbClr val="18212F"/>
                 </a:solidFill>
               </a:rPr>
               <a:t>9.39%</a:t>
             </a:r>
-            <a:endParaRPr lang="en-US" sz="1080" dirty="0"/>
+            <a:endParaRPr lang="en-US" sz="1050" dirty="0"/>
           </a:p>
         </p:txBody>
       </p:sp>
@@ -6904,8 +6904,8 @@
         </p:nvSpPr>
         <p:spPr>
           <a:xfrm>
-            <a:off x="8549640" y="4402836"/>
-            <a:ext cx="1325880" cy="288036"/>
+            <a:off x="8549640" y="4251960"/>
+            <a:ext cx="1325880" cy="274320"/>
           </a:xfrm>
           <a:prstGeom prst="rect">
             <a:avLst/>
@@ -6929,8 +6929,8 @@
         </p:nvSpPr>
         <p:spPr>
           <a:xfrm>
-            <a:off x="8613648" y="4489704"/>
-            <a:ext cx="1197864" cy="150876"/>
+            <a:off x="8613648" y="4338828"/>
+            <a:ext cx="1197864" cy="137160"/>
           </a:xfrm>
           <a:prstGeom prst="rect">
             <a:avLst/>
@@ -6948,14 +6948,14 @@
               <a:buNone/>
             </a:pPr>
             <a:r>
-              <a:rPr lang="en-US" sz="1080" dirty="0">
+              <a:rPr lang="en-US" sz="1050" dirty="0">
                 <a:solidFill>
                   <a:srgbClr val="18212F"/>
                 </a:solidFill>
               </a:rPr>
               <a:t>29.10%</a:t>
             </a:r>
-            <a:endParaRPr lang="en-US" sz="1080" dirty="0"/>
+            <a:endParaRPr lang="en-US" sz="1050" dirty="0"/>
           </a:p>
         </p:txBody>
       </p:sp>
@@ -6967,8 +6967,8 @@
         </p:nvSpPr>
         <p:spPr>
           <a:xfrm>
-            <a:off x="502920" y="5010912"/>
-            <a:ext cx="3520440" cy="288036"/>
+            <a:off x="502920" y="4681728"/>
+            <a:ext cx="3520440" cy="274320"/>
           </a:xfrm>
           <a:prstGeom prst="rect">
             <a:avLst/>
@@ -6992,8 +6992,8 @@
         </p:nvSpPr>
         <p:spPr>
           <a:xfrm>
-            <a:off x="566928" y="5097780"/>
-            <a:ext cx="3392424" cy="150876"/>
+            <a:off x="566928" y="4768596"/>
+            <a:ext cx="3392424" cy="137160"/>
           </a:xfrm>
           <a:prstGeom prst="rect">
             <a:avLst/>
@@ -7011,14 +7011,14 @@
               <a:buNone/>
             </a:pPr>
             <a:r>
-              <a:rPr lang="en-US" sz="1060" b="1" dirty="0">
+              <a:rPr lang="en-US" sz="1040" b="1" dirty="0">
                 <a:solidFill>
                   <a:srgbClr val="FFFFFF"/>
                 </a:solidFill>
               </a:rPr>
               <a:t>Detail</a:t>
             </a:r>
-            <a:endParaRPr lang="en-US" sz="1060" dirty="0"/>
+            <a:endParaRPr lang="en-US" sz="1040" dirty="0"/>
           </a:p>
         </p:txBody>
       </p:sp>
@@ -7030,8 +7030,8 @@
         </p:nvSpPr>
         <p:spPr>
           <a:xfrm>
-            <a:off x="4023360" y="5010912"/>
-            <a:ext cx="1417320" cy="288036"/>
+            <a:off x="4023360" y="4681728"/>
+            <a:ext cx="1417320" cy="274320"/>
           </a:xfrm>
           <a:prstGeom prst="rect">
             <a:avLst/>
@@ -7055,8 +7055,8 @@
         </p:nvSpPr>
         <p:spPr>
           <a:xfrm>
-            <a:off x="4087368" y="5097780"/>
-            <a:ext cx="1289304" cy="150876"/>
+            <a:off x="4087368" y="4768596"/>
+            <a:ext cx="1289304" cy="137160"/>
           </a:xfrm>
           <a:prstGeom prst="rect">
             <a:avLst/>
@@ -7074,14 +7074,14 @@
               <a:buNone/>
             </a:pPr>
             <a:r>
-              <a:rPr lang="en-US" sz="1060" b="1" dirty="0">
+              <a:rPr lang="en-US" sz="1040" b="1" dirty="0">
                 <a:solidFill>
                   <a:srgbClr val="FFFFFF"/>
                 </a:solidFill>
               </a:rPr>
               <a:t>Time</a:t>
             </a:r>
-            <a:endParaRPr lang="en-US" sz="1060" dirty="0"/>
+            <a:endParaRPr lang="en-US" sz="1040" dirty="0"/>
           </a:p>
         </p:txBody>
       </p:sp>
@@ -7093,8 +7093,8 @@
         </p:nvSpPr>
         <p:spPr>
           <a:xfrm>
-            <a:off x="5440680" y="5010912"/>
-            <a:ext cx="3520440" cy="288036"/>
+            <a:off x="5440680" y="4681728"/>
+            <a:ext cx="3520440" cy="274320"/>
           </a:xfrm>
           <a:prstGeom prst="rect">
             <a:avLst/>
@@ -7118,8 +7118,8 @@
         </p:nvSpPr>
         <p:spPr>
           <a:xfrm>
-            <a:off x="5504688" y="5097780"/>
-            <a:ext cx="3392424" cy="150876"/>
+            <a:off x="5504688" y="4768596"/>
+            <a:ext cx="3392424" cy="137160"/>
           </a:xfrm>
           <a:prstGeom prst="rect">
             <a:avLst/>
@@ -7137,14 +7137,14 @@
               <a:buNone/>
             </a:pPr>
             <a:r>
-              <a:rPr lang="en-US" sz="1060" b="1" dirty="0">
+              <a:rPr lang="en-US" sz="1040" b="1" dirty="0">
                 <a:solidFill>
                   <a:srgbClr val="FFFFFF"/>
                 </a:solidFill>
               </a:rPr>
               <a:t>Detail</a:t>
             </a:r>
-            <a:endParaRPr lang="en-US" sz="1060" dirty="0"/>
+            <a:endParaRPr lang="en-US" sz="1040" dirty="0"/>
           </a:p>
         </p:txBody>
       </p:sp>
@@ -7156,8 +7156,8 @@
         </p:nvSpPr>
         <p:spPr>
           <a:xfrm>
-            <a:off x="8961120" y="5010912"/>
-            <a:ext cx="1417320" cy="288036"/>
+            <a:off x="8961120" y="4681728"/>
+            <a:ext cx="1417320" cy="274320"/>
           </a:xfrm>
           <a:prstGeom prst="rect">
             <a:avLst/>
@@ -7181,8 +7181,8 @@
         </p:nvSpPr>
         <p:spPr>
           <a:xfrm>
-            <a:off x="9025128" y="5097780"/>
-            <a:ext cx="1289304" cy="150876"/>
+            <a:off x="9025128" y="4768596"/>
+            <a:ext cx="1289304" cy="137160"/>
           </a:xfrm>
           <a:prstGeom prst="rect">
             <a:avLst/>
@@ -7200,14 +7200,14 @@
               <a:buNone/>
             </a:pPr>
             <a:r>
-              <a:rPr lang="en-US" sz="1060" b="1" dirty="0">
+              <a:rPr lang="en-US" sz="1040" b="1" dirty="0">
                 <a:solidFill>
                   <a:srgbClr val="FFFFFF"/>
                 </a:solidFill>
               </a:rPr>
               <a:t>Time</a:t>
             </a:r>
-            <a:endParaRPr lang="en-US" sz="1060" dirty="0"/>
+            <a:endParaRPr lang="en-US" sz="1040" dirty="0"/>
           </a:p>
         </p:txBody>
       </p:sp>
@@ -7219,8 +7219,8 @@
         </p:nvSpPr>
         <p:spPr>
           <a:xfrm>
-            <a:off x="502920" y="5298948"/>
-            <a:ext cx="3520440" cy="288036"/>
+            <a:off x="502920" y="4956048"/>
+            <a:ext cx="3520440" cy="274320"/>
           </a:xfrm>
           <a:prstGeom prst="rect">
             <a:avLst/>
@@ -7244,8 +7244,8 @@
         </p:nvSpPr>
         <p:spPr>
           <a:xfrm>
-            <a:off x="566928" y="5385816"/>
-            <a:ext cx="3392424" cy="150876"/>
+            <a:off x="566928" y="5042916"/>
+            <a:ext cx="3392424" cy="137160"/>
           </a:xfrm>
           <a:prstGeom prst="rect">
             <a:avLst/>
@@ -7263,14 +7263,14 @@
               <a:buNone/>
             </a:pPr>
             <a:r>
-              <a:rPr lang="en-US" sz="1060" b="1" dirty="0">
+              <a:rPr lang="en-US" sz="1040" b="1" dirty="0">
                 <a:solidFill>
                   <a:srgbClr val="18212F"/>
                 </a:solidFill>
               </a:rPr>
               <a:t>Setup: projection host build</a:t>
             </a:r>
-            <a:endParaRPr lang="en-US" sz="1060" dirty="0"/>
+            <a:endParaRPr lang="en-US" sz="1040" dirty="0"/>
           </a:p>
         </p:txBody>
       </p:sp>
@@ -7282,8 +7282,8 @@
         </p:nvSpPr>
         <p:spPr>
           <a:xfrm>
-            <a:off x="4023360" y="5298948"/>
-            <a:ext cx="1417320" cy="288036"/>
+            <a:off x="4023360" y="4956048"/>
+            <a:ext cx="1417320" cy="274320"/>
           </a:xfrm>
           <a:prstGeom prst="rect">
             <a:avLst/>
@@ -7307,8 +7307,8 @@
         </p:nvSpPr>
         <p:spPr>
           <a:xfrm>
-            <a:off x="4087368" y="5385816"/>
-            <a:ext cx="1289304" cy="150876"/>
+            <a:off x="4087368" y="5042916"/>
+            <a:ext cx="1289304" cy="137160"/>
           </a:xfrm>
           <a:prstGeom prst="rect">
             <a:avLst/>
@@ -7326,14 +7326,14 @@
               <a:buNone/>
             </a:pPr>
             <a:r>
-              <a:rPr lang="en-US" sz="1060" dirty="0">
+              <a:rPr lang="en-US" sz="1040" dirty="0">
                 <a:solidFill>
                   <a:srgbClr val="18212F"/>
                 </a:solidFill>
               </a:rPr>
               <a:t>38.686 ms</a:t>
             </a:r>
-            <a:endParaRPr lang="en-US" sz="1060" dirty="0"/>
+            <a:endParaRPr lang="en-US" sz="1040" dirty="0"/>
           </a:p>
         </p:txBody>
       </p:sp>
@@ -7345,8 +7345,8 @@
         </p:nvSpPr>
         <p:spPr>
           <a:xfrm>
-            <a:off x="5440680" y="5298948"/>
-            <a:ext cx="3520440" cy="288036"/>
+            <a:off x="5440680" y="4956048"/>
+            <a:ext cx="3520440" cy="274320"/>
           </a:xfrm>
           <a:prstGeom prst="rect">
             <a:avLst/>
@@ -7370,8 +7370,8 @@
         </p:nvSpPr>
         <p:spPr>
           <a:xfrm>
-            <a:off x="5504688" y="5385816"/>
-            <a:ext cx="3392424" cy="150876"/>
+            <a:off x="5504688" y="5042916"/>
+            <a:ext cx="3392424" cy="137160"/>
           </a:xfrm>
           <a:prstGeom prst="rect">
             <a:avLst/>
@@ -7389,14 +7389,14 @@
               <a:buNone/>
             </a:pPr>
             <a:r>
-              <a:rPr lang="en-US" sz="1060" dirty="0">
+              <a:rPr lang="en-US" sz="1040" dirty="0">
                 <a:solidFill>
                   <a:srgbClr val="18212F"/>
                 </a:solidFill>
               </a:rPr>
               <a:t>Solve: dense Schur</a:t>
             </a:r>
-            <a:endParaRPr lang="en-US" sz="1060" dirty="0"/>
+            <a:endParaRPr lang="en-US" sz="1040" dirty="0"/>
           </a:p>
         </p:txBody>
       </p:sp>
@@ -7408,8 +7408,8 @@
         </p:nvSpPr>
         <p:spPr>
           <a:xfrm>
-            <a:off x="8961120" y="5298948"/>
-            <a:ext cx="1417320" cy="288036"/>
+            <a:off x="8961120" y="4956048"/>
+            <a:ext cx="1417320" cy="274320"/>
           </a:xfrm>
           <a:prstGeom prst="rect">
             <a:avLst/>
@@ -7433,8 +7433,8 @@
         </p:nvSpPr>
         <p:spPr>
           <a:xfrm>
-            <a:off x="9025128" y="5385816"/>
-            <a:ext cx="1289304" cy="150876"/>
+            <a:off x="9025128" y="5042916"/>
+            <a:ext cx="1289304" cy="137160"/>
           </a:xfrm>
           <a:prstGeom prst="rect">
             <a:avLst/>
@@ -7452,14 +7452,14 @@
               <a:buNone/>
             </a:pPr>
             <a:r>
-              <a:rPr lang="en-US" sz="1060" dirty="0">
+              <a:rPr lang="en-US" sz="1040" dirty="0">
                 <a:solidFill>
                   <a:srgbClr val="18212F"/>
                 </a:solidFill>
               </a:rPr>
               <a:t>23.009 ms</a:t>
             </a:r>
-            <a:endParaRPr lang="en-US" sz="1060" dirty="0"/>
+            <a:endParaRPr lang="en-US" sz="1040" dirty="0"/>
           </a:p>
         </p:txBody>
       </p:sp>
@@ -7471,8 +7471,8 @@
         </p:nvSpPr>
         <p:spPr>
           <a:xfrm>
-            <a:off x="502920" y="5586984"/>
-            <a:ext cx="3520440" cy="288036"/>
+            <a:off x="502920" y="5230368"/>
+            <a:ext cx="3520440" cy="274320"/>
           </a:xfrm>
           <a:prstGeom prst="rect">
             <a:avLst/>
@@ -7496,8 +7496,8 @@
         </p:nvSpPr>
         <p:spPr>
           <a:xfrm>
-            <a:off x="566928" y="5673852"/>
-            <a:ext cx="3392424" cy="150876"/>
+            <a:off x="566928" y="5317236"/>
+            <a:ext cx="3392424" cy="137160"/>
           </a:xfrm>
           <a:prstGeom prst="rect">
             <a:avLst/>
@@ -7515,14 +7515,14 @@
               <a:buNone/>
             </a:pPr>
             <a:r>
-              <a:rPr lang="en-US" sz="1060" b="1" dirty="0">
+              <a:rPr lang="en-US" sz="1040" b="1" dirty="0">
                 <a:solidFill>
                   <a:srgbClr val="18212F"/>
                 </a:solidFill>
               </a:rPr>
               <a:t>Setup: pack values</a:t>
             </a:r>
-            <a:endParaRPr lang="en-US" sz="1060" dirty="0"/>
+            <a:endParaRPr lang="en-US" sz="1040" dirty="0"/>
           </a:p>
         </p:txBody>
       </p:sp>
@@ -7534,8 +7534,8 @@
         </p:nvSpPr>
         <p:spPr>
           <a:xfrm>
-            <a:off x="4023360" y="5586984"/>
-            <a:ext cx="1417320" cy="288036"/>
+            <a:off x="4023360" y="5230368"/>
+            <a:ext cx="1417320" cy="274320"/>
           </a:xfrm>
           <a:prstGeom prst="rect">
             <a:avLst/>
@@ -7559,8 +7559,8 @@
         </p:nvSpPr>
         <p:spPr>
           <a:xfrm>
-            <a:off x="4087368" y="5673852"/>
-            <a:ext cx="1289304" cy="150876"/>
+            <a:off x="4087368" y="5317236"/>
+            <a:ext cx="1289304" cy="137160"/>
           </a:xfrm>
           <a:prstGeom prst="rect">
             <a:avLst/>
@@ -7578,14 +7578,14 @@
               <a:buNone/>
             </a:pPr>
             <a:r>
-              <a:rPr lang="en-US" sz="1060" dirty="0">
+              <a:rPr lang="en-US" sz="1040" dirty="0">
                 <a:solidFill>
                   <a:srgbClr val="18212F"/>
                 </a:solidFill>
               </a:rPr>
               <a:t>13.688 ms</a:t>
             </a:r>
-            <a:endParaRPr lang="en-US" sz="1060" dirty="0"/>
+            <a:endParaRPr lang="en-US" sz="1040" dirty="0"/>
           </a:p>
         </p:txBody>
       </p:sp>
@@ -7597,8 +7597,8 @@
         </p:nvSpPr>
         <p:spPr>
           <a:xfrm>
-            <a:off x="5440680" y="5586984"/>
-            <a:ext cx="3520440" cy="288036"/>
+            <a:off x="5440680" y="5230368"/>
+            <a:ext cx="3520440" cy="274320"/>
           </a:xfrm>
           <a:prstGeom prst="rect">
             <a:avLst/>
@@ -7622,8 +7622,8 @@
         </p:nvSpPr>
         <p:spPr>
           <a:xfrm>
-            <a:off x="5504688" y="5673852"/>
-            <a:ext cx="3392424" cy="150876"/>
+            <a:off x="5504688" y="5317236"/>
+            <a:ext cx="3392424" cy="137160"/>
           </a:xfrm>
           <a:prstGeom prst="rect">
             <a:avLst/>
@@ -7641,14 +7641,14 @@
               <a:buNone/>
             </a:pPr>
             <a:r>
-              <a:rPr lang="en-US" sz="1060" dirty="0">
+              <a:rPr lang="en-US" sz="1040" dirty="0">
                 <a:solidFill>
                   <a:srgbClr val="18212F"/>
                 </a:solidFill>
               </a:rPr>
               <a:t>Solve: damping diagonal</a:t>
             </a:r>
-            <a:endParaRPr lang="en-US" sz="1060" dirty="0"/>
+            <a:endParaRPr lang="en-US" sz="1040" dirty="0"/>
           </a:p>
         </p:txBody>
       </p:sp>
@@ -7660,8 +7660,8 @@
         </p:nvSpPr>
         <p:spPr>
           <a:xfrm>
-            <a:off x="8961120" y="5586984"/>
-            <a:ext cx="1417320" cy="288036"/>
+            <a:off x="8961120" y="5230368"/>
+            <a:ext cx="1417320" cy="274320"/>
           </a:xfrm>
           <a:prstGeom prst="rect">
             <a:avLst/>
@@ -7685,8 +7685,8 @@
         </p:nvSpPr>
         <p:spPr>
           <a:xfrm>
-            <a:off x="9025128" y="5673852"/>
-            <a:ext cx="1289304" cy="150876"/>
+            <a:off x="9025128" y="5317236"/>
+            <a:ext cx="1289304" cy="137160"/>
           </a:xfrm>
           <a:prstGeom prst="rect">
             <a:avLst/>
@@ -7704,14 +7704,14 @@
               <a:buNone/>
             </a:pPr>
             <a:r>
-              <a:rPr lang="en-US" sz="1060" dirty="0">
+              <a:rPr lang="en-US" sz="1040" dirty="0">
                 <a:solidFill>
                   <a:srgbClr val="18212F"/>
                 </a:solidFill>
               </a:rPr>
               <a:t>2.979 ms</a:t>
             </a:r>
-            <a:endParaRPr lang="en-US" sz="1060" dirty="0"/>
+            <a:endParaRPr lang="en-US" sz="1040" dirty="0"/>
           </a:p>
         </p:txBody>
       </p:sp>
@@ -7723,8 +7723,8 @@
         </p:nvSpPr>
         <p:spPr>
           <a:xfrm>
-            <a:off x="502920" y="5875020"/>
-            <a:ext cx="3520440" cy="288036"/>
+            <a:off x="502920" y="5504688"/>
+            <a:ext cx="3520440" cy="274320"/>
           </a:xfrm>
           <a:prstGeom prst="rect">
             <a:avLst/>
@@ -7748,8 +7748,8 @@
         </p:nvSpPr>
         <p:spPr>
           <a:xfrm>
-            <a:off x="566928" y="5961888"/>
-            <a:ext cx="3392424" cy="150876"/>
+            <a:off x="566928" y="5591556"/>
+            <a:ext cx="3392424" cy="137160"/>
           </a:xfrm>
           <a:prstGeom prst="rect">
             <a:avLst/>
@@ -7767,14 +7767,14 @@
               <a:buNone/>
             </a:pPr>
             <a:r>
-              <a:rPr lang="en-US" sz="1060" b="1" dirty="0">
+              <a:rPr lang="en-US" sz="1040" b="1" dirty="0">
                 <a:solidFill>
                   <a:srgbClr val="18212F"/>
                 </a:solidFill>
               </a:rPr>
               <a:t>Setup: allocate trial values</a:t>
             </a:r>
-            <a:endParaRPr lang="en-US" sz="1060" dirty="0"/>
+            <a:endParaRPr lang="en-US" sz="1040" dirty="0"/>
           </a:p>
         </p:txBody>
       </p:sp>
@@ -7786,8 +7786,8 @@
         </p:nvSpPr>
         <p:spPr>
           <a:xfrm>
-            <a:off x="4023360" y="5875020"/>
-            <a:ext cx="1417320" cy="288036"/>
+            <a:off x="4023360" y="5504688"/>
+            <a:ext cx="1417320" cy="274320"/>
           </a:xfrm>
           <a:prstGeom prst="rect">
             <a:avLst/>
@@ -7811,8 +7811,8 @@
         </p:nvSpPr>
         <p:spPr>
           <a:xfrm>
-            <a:off x="4087368" y="5961888"/>
-            <a:ext cx="1289304" cy="150876"/>
+            <a:off x="4087368" y="5591556"/>
+            <a:ext cx="1289304" cy="137160"/>
           </a:xfrm>
           <a:prstGeom prst="rect">
             <a:avLst/>
@@ -7830,14 +7830,14 @@
               <a:buNone/>
             </a:pPr>
             <a:r>
-              <a:rPr lang="en-US" sz="1060" dirty="0">
+              <a:rPr lang="en-US" sz="1040" dirty="0">
                 <a:solidFill>
                   <a:srgbClr val="18212F"/>
                 </a:solidFill>
               </a:rPr>
               <a:t>11.769 ms</a:t>
             </a:r>
-            <a:endParaRPr lang="en-US" sz="1060" dirty="0"/>
+            <a:endParaRPr lang="en-US" sz="1040" dirty="0"/>
           </a:p>
         </p:txBody>
       </p:sp>
@@ -7849,8 +7849,8 @@
         </p:nvSpPr>
         <p:spPr>
           <a:xfrm>
-            <a:off x="5440680" y="5875020"/>
-            <a:ext cx="3520440" cy="288036"/>
+            <a:off x="5440680" y="5504688"/>
+            <a:ext cx="3520440" cy="274320"/>
           </a:xfrm>
           <a:prstGeom prst="rect">
             <a:avLst/>
@@ -7874,8 +7874,8 @@
         </p:nvSpPr>
         <p:spPr>
           <a:xfrm>
-            <a:off x="5504688" y="5961888"/>
-            <a:ext cx="3392424" cy="150876"/>
+            <a:off x="5504688" y="5591556"/>
+            <a:ext cx="3392424" cy="137160"/>
           </a:xfrm>
           <a:prstGeom prst="rect">
             <a:avLst/>
@@ -7893,14 +7893,14 @@
               <a:buNone/>
             </a:pPr>
             <a:r>
-              <a:rPr lang="en-US" sz="1060" dirty="0">
+              <a:rPr lang="en-US" sz="1040" dirty="0">
                 <a:solidFill>
                   <a:srgbClr val="18212F"/>
                 </a:solidFill>
               </a:rPr>
               <a:t>Solve: linearized error change</a:t>
             </a:r>
-            <a:endParaRPr lang="en-US" sz="1060" dirty="0"/>
+            <a:endParaRPr lang="en-US" sz="1040" dirty="0"/>
           </a:p>
         </p:txBody>
       </p:sp>
@@ -7912,8 +7912,8 @@
         </p:nvSpPr>
         <p:spPr>
           <a:xfrm>
-            <a:off x="8961120" y="5875020"/>
-            <a:ext cx="1417320" cy="288036"/>
+            <a:off x="8961120" y="5504688"/>
+            <a:ext cx="1417320" cy="274320"/>
           </a:xfrm>
           <a:prstGeom prst="rect">
             <a:avLst/>
@@ -7937,8 +7937,8 @@
         </p:nvSpPr>
         <p:spPr>
           <a:xfrm>
-            <a:off x="9025128" y="5961888"/>
-            <a:ext cx="1289304" cy="150876"/>
+            <a:off x="9025128" y="5591556"/>
+            <a:ext cx="1289304" cy="137160"/>
           </a:xfrm>
           <a:prstGeom prst="rect">
             <a:avLst/>
@@ -7956,14 +7956,14 @@
               <a:buNone/>
             </a:pPr>
             <a:r>
-              <a:rPr lang="en-US" sz="1060" dirty="0">
+              <a:rPr lang="en-US" sz="1040" dirty="0">
                 <a:solidFill>
                   <a:srgbClr val="18212F"/>
                 </a:solidFill>
               </a:rPr>
               <a:t>3.655 ms</a:t>
             </a:r>
-            <a:endParaRPr lang="en-US" sz="1060" dirty="0"/>
+            <a:endParaRPr lang="en-US" sz="1040" dirty="0"/>
           </a:p>
         </p:txBody>
       </p:sp>
@@ -7975,8 +7975,8 @@
         </p:nvSpPr>
         <p:spPr>
           <a:xfrm>
-            <a:off x="502920" y="6163056"/>
-            <a:ext cx="3520440" cy="288036"/>
+            <a:off x="502920" y="5779008"/>
+            <a:ext cx="3520440" cy="274320"/>
           </a:xfrm>
           <a:prstGeom prst="rect">
             <a:avLst/>
@@ -8000,8 +8000,8 @@
         </p:nvSpPr>
         <p:spPr>
           <a:xfrm>
-            <a:off x="566928" y="6249924"/>
-            <a:ext cx="3392424" cy="150876"/>
+            <a:off x="566928" y="5865876"/>
+            <a:ext cx="3392424" cy="137160"/>
           </a:xfrm>
           <a:prstGeom prst="rect">
             <a:avLst/>
@@ -8019,14 +8019,14 @@
               <a:buNone/>
             </a:pPr>
             <a:r>
-              <a:rPr lang="en-US" sz="1060" b="1" dirty="0">
+              <a:rPr lang="en-US" sz="1040" b="1" dirty="0">
                 <a:solidFill>
                   <a:srgbClr val="18212F"/>
                 </a:solidFill>
               </a:rPr>
               <a:t>Transfer: total H2D memcpy</a:t>
             </a:r>
-            <a:endParaRPr lang="en-US" sz="1060" dirty="0"/>
+            <a:endParaRPr lang="en-US" sz="1040" dirty="0"/>
           </a:p>
         </p:txBody>
       </p:sp>
@@ -8038,8 +8038,8 @@
         </p:nvSpPr>
         <p:spPr>
           <a:xfrm>
-            <a:off x="4023360" y="6163056"/>
-            <a:ext cx="1417320" cy="288036"/>
+            <a:off x="4023360" y="5779008"/>
+            <a:ext cx="1417320" cy="274320"/>
           </a:xfrm>
           <a:prstGeom prst="rect">
             <a:avLst/>
@@ -8063,8 +8063,8 @@
         </p:nvSpPr>
         <p:spPr>
           <a:xfrm>
-            <a:off x="4087368" y="6249924"/>
-            <a:ext cx="1289304" cy="150876"/>
+            <a:off x="4087368" y="5865876"/>
+            <a:ext cx="1289304" cy="137160"/>
           </a:xfrm>
           <a:prstGeom prst="rect">
             <a:avLst/>
@@ -8082,14 +8082,14 @@
               <a:buNone/>
             </a:pPr>
             <a:r>
-              <a:rPr lang="en-US" sz="1060" dirty="0">
+              <a:rPr lang="en-US" sz="1040" dirty="0">
                 <a:solidFill>
                   <a:srgbClr val="18212F"/>
                 </a:solidFill>
               </a:rPr>
               <a:t>1.526 ms</a:t>
             </a:r>
-            <a:endParaRPr lang="en-US" sz="1060" dirty="0"/>
+            <a:endParaRPr lang="en-US" sz="1040" dirty="0"/>
           </a:p>
         </p:txBody>
       </p:sp>
@@ -8101,8 +8101,8 @@
         </p:nvSpPr>
         <p:spPr>
           <a:xfrm>
-            <a:off x="5440680" y="6163056"/>
-            <a:ext cx="3520440" cy="288036"/>
+            <a:off x="5440680" y="5779008"/>
+            <a:ext cx="3520440" cy="274320"/>
           </a:xfrm>
           <a:prstGeom prst="rect">
             <a:avLst/>
@@ -8126,8 +8126,8 @@
         </p:nvSpPr>
         <p:spPr>
           <a:xfrm>
-            <a:off x="5504688" y="6249924"/>
-            <a:ext cx="3392424" cy="150876"/>
+            <a:off x="5504688" y="5865876"/>
+            <a:ext cx="3392424" cy="137160"/>
           </a:xfrm>
           <a:prstGeom prst="rect">
             <a:avLst/>
@@ -8145,14 +8145,14 @@
               <a:buNone/>
             </a:pPr>
             <a:r>
-              <a:rPr lang="en-US" sz="1060" dirty="0">
+              <a:rPr lang="en-US" sz="1040" dirty="0">
                 <a:solidFill>
                   <a:srgbClr val="18212F"/>
                 </a:solidFill>
               </a:rPr>
               <a:t>Transfer: total D2H memcpy</a:t>
             </a:r>
-            <a:endParaRPr lang="en-US" sz="1060" dirty="0"/>
+            <a:endParaRPr lang="en-US" sz="1040" dirty="0"/>
           </a:p>
         </p:txBody>
       </p:sp>
@@ -8164,8 +8164,8 @@
         </p:nvSpPr>
         <p:spPr>
           <a:xfrm>
-            <a:off x="8961120" y="6163056"/>
-            <a:ext cx="1417320" cy="288036"/>
+            <a:off x="8961120" y="5779008"/>
+            <a:ext cx="1417320" cy="274320"/>
           </a:xfrm>
           <a:prstGeom prst="rect">
             <a:avLst/>
@@ -8189,8 +8189,8 @@
         </p:nvSpPr>
         <p:spPr>
           <a:xfrm>
-            <a:off x="9025128" y="6249924"/>
-            <a:ext cx="1289304" cy="150876"/>
+            <a:off x="9025128" y="5865876"/>
+            <a:ext cx="1289304" cy="137160"/>
           </a:xfrm>
           <a:prstGeom prst="rect">
             <a:avLst/>
@@ -8208,14 +8208,14 @@
               <a:buNone/>
             </a:pPr>
             <a:r>
-              <a:rPr lang="en-US" sz="1060" dirty="0">
+              <a:rPr lang="en-US" sz="1040" dirty="0">
                 <a:solidFill>
                   <a:srgbClr val="18212F"/>
                 </a:solidFill>
               </a:rPr>
               <a:t>0.615 ms</a:t>
             </a:r>
-            <a:endParaRPr lang="en-US" sz="1060" dirty="0"/>
+            <a:endParaRPr lang="en-US" sz="1040" dirty="0"/>
           </a:p>
         </p:txBody>
       </p:sp>
@@ -8227,8 +8227,8 @@
         </p:nvSpPr>
         <p:spPr>
           <a:xfrm>
-            <a:off x="502920" y="6451092"/>
-            <a:ext cx="3520440" cy="288036"/>
+            <a:off x="502920" y="6053328"/>
+            <a:ext cx="3520440" cy="274320"/>
           </a:xfrm>
           <a:prstGeom prst="rect">
             <a:avLst/>
@@ -8252,8 +8252,8 @@
         </p:nvSpPr>
         <p:spPr>
           <a:xfrm>
-            <a:off x="566928" y="6537960"/>
-            <a:ext cx="3392424" cy="150876"/>
+            <a:off x="566928" y="6140196"/>
+            <a:ext cx="3392424" cy="137160"/>
           </a:xfrm>
           <a:prstGeom prst="rect">
             <a:avLst/>
@@ -8271,14 +8271,14 @@
               <a:buNone/>
             </a:pPr>
             <a:r>
-              <a:rPr lang="en-US" sz="1060" b="1" dirty="0">
+              <a:rPr lang="en-US" sz="1040" b="1" dirty="0">
                 <a:solidFill>
                   <a:srgbClr val="18212F"/>
                 </a:solidFill>
               </a:rPr>
               <a:t>Download: Values rebuild</a:t>
             </a:r>
-            <a:endParaRPr lang="en-US" sz="1060" dirty="0"/>
+            <a:endParaRPr lang="en-US" sz="1040" dirty="0"/>
           </a:p>
         </p:txBody>
       </p:sp>
@@ -8290,8 +8290,8 @@
         </p:nvSpPr>
         <p:spPr>
           <a:xfrm>
-            <a:off x="4023360" y="6451092"/>
-            <a:ext cx="1417320" cy="288036"/>
+            <a:off x="4023360" y="6053328"/>
+            <a:ext cx="1417320" cy="274320"/>
           </a:xfrm>
           <a:prstGeom prst="rect">
             <a:avLst/>
@@ -8315,8 +8315,8 @@
         </p:nvSpPr>
         <p:spPr>
           <a:xfrm>
-            <a:off x="4087368" y="6537960"/>
-            <a:ext cx="1289304" cy="150876"/>
+            <a:off x="4087368" y="6140196"/>
+            <a:ext cx="1289304" cy="137160"/>
           </a:xfrm>
           <a:prstGeom prst="rect">
             <a:avLst/>
@@ -8334,14 +8334,14 @@
               <a:buNone/>
             </a:pPr>
             <a:r>
-              <a:rPr lang="en-US" sz="1060" dirty="0">
+              <a:rPr lang="en-US" sz="1040" dirty="0">
                 <a:solidFill>
                   <a:srgbClr val="18212F"/>
                 </a:solidFill>
               </a:rPr>
               <a:t>15.537 ms</a:t>
             </a:r>
-            <a:endParaRPr lang="en-US" sz="1060" dirty="0"/>
+            <a:endParaRPr lang="en-US" sz="1040" dirty="0"/>
           </a:p>
         </p:txBody>
       </p:sp>
@@ -8353,8 +8353,8 @@
         </p:nvSpPr>
         <p:spPr>
           <a:xfrm>
-            <a:off x="5440680" y="6451092"/>
-            <a:ext cx="3520440" cy="288036"/>
+            <a:off x="5440680" y="6053328"/>
+            <a:ext cx="3520440" cy="274320"/>
           </a:xfrm>
           <a:prstGeom prst="rect">
             <a:avLst/>
@@ -8378,8 +8378,8 @@
         </p:nvSpPr>
         <p:spPr>
           <a:xfrm>
-            <a:off x="5504688" y="6537960"/>
-            <a:ext cx="3392424" cy="150876"/>
+            <a:off x="5504688" y="6140196"/>
+            <a:ext cx="3392424" cy="137160"/>
           </a:xfrm>
           <a:prstGeom prst="rect">
             <a:avLst/>
@@ -8397,14 +8397,14 @@
               <a:buNone/>
             </a:pPr>
             <a:r>
-              <a:rPr lang="en-US" sz="1060" dirty="0">
+              <a:rPr lang="en-US" sz="1040" dirty="0">
                 <a:solidFill>
                   <a:srgbClr val="18212F"/>
                 </a:solidFill>
               </a:rPr>
               <a:t>Pure H2D + D2H</a:t>
             </a:r>
-            <a:endParaRPr lang="en-US" sz="1060" dirty="0"/>
+            <a:endParaRPr lang="en-US" sz="1040" dirty="0"/>
           </a:p>
         </p:txBody>
       </p:sp>
@@ -8416,8 +8416,8 @@
         </p:nvSpPr>
         <p:spPr>
           <a:xfrm>
-            <a:off x="8961120" y="6451092"/>
-            <a:ext cx="1417320" cy="288036"/>
+            <a:off x="8961120" y="6053328"/>
+            <a:ext cx="1417320" cy="274320"/>
           </a:xfrm>
           <a:prstGeom prst="rect">
             <a:avLst/>
@@ -8441,8 +8441,8 @@
         </p:nvSpPr>
         <p:spPr>
           <a:xfrm>
-            <a:off x="9025128" y="6537960"/>
-            <a:ext cx="1289304" cy="150876"/>
+            <a:off x="9025128" y="6140196"/>
+            <a:ext cx="1289304" cy="137160"/>
           </a:xfrm>
           <a:prstGeom prst="rect">
             <a:avLst/>
@@ -8460,14 +8460,14 @@
               <a:buNone/>
             </a:pPr>
             <a:r>
-              <a:rPr lang="en-US" sz="1060" dirty="0">
+              <a:rPr lang="en-US" sz="1040" dirty="0">
                 <a:solidFill>
                   <a:srgbClr val="18212F"/>
                 </a:solidFill>
               </a:rPr>
               <a:t>2.141 ms</a:t>
             </a:r>
-            <a:endParaRPr lang="en-US" sz="1060" dirty="0"/>
+            <a:endParaRPr lang="en-US" sz="1040" dirty="0"/>
           </a:p>
         </p:txBody>
       </p:sp>
@@ -8479,7 +8479,7 @@
         </p:nvSpPr>
         <p:spPr>
           <a:xfrm>
-            <a:off x="502920" y="6437376"/>
+            <a:off x="502920" y="6382512"/>
             <a:ext cx="10789920" cy="109728"/>
           </a:xfrm>
           <a:prstGeom prst="rect">
@@ -17765,16 +17765,18 @@
         <p:spPr>
           <a:xfrm>
             <a:off x="6583680" y="4572000"/>
-            <a:ext cx="2834640" cy="182880"/>
-          </a:xfrm>
-          <a:prstGeom prst="rect">
-            <a:avLst/>
-          </a:prstGeom>
-          <a:noFill/>
-          <a:ln/>
-        </p:spPr>
-        <p:txBody>
-          <a:bodyPr wrap="square" lIns="0" tIns="0" rIns="0" bIns="0" rtlCol="0" anchor="ctr"/>
+            <a:ext cx="4480560" cy="182880"/>
+          </a:xfrm>
+          <a:prstGeom prst="rect">
+            <a:avLst/>
+          </a:prstGeom>
+          <a:noFill/>
+          <a:ln/>
+        </p:spPr>
+        <p:txBody>
+          <a:bodyPr wrap="square" lIns="0" tIns="0" rIns="0" bIns="0" rtlCol="0" anchor="ctr">
+            <a:normAutofit/>
+          </a:bodyPr>
           <a:lstStyle/>
           <a:p>
             <a:pPr indent="0" marL="0">
@@ -21386,7 +21388,7 @@
               <a:buNone/>
             </a:pPr>
             <a:r>
-              <a:rPr lang="en-US" sz="950" dirty="0">
+              <a:rPr lang="en-US" sz="1050" dirty="0">
                 <a:solidFill>
                   <a:srgbClr val="5A6472"/>
                 </a:solidFill>
@@ -21397,7 +21399,7 @@
               <a:buNone/>
             </a:pPr>
             <a:r>
-              <a:rPr lang="en-US" sz="950" u="sng" dirty="0">
+              <a:rPr lang="en-US" sz="1050" u="sng" dirty="0">
                 <a:solidFill>
                   <a:srgbClr val="3E74B8"/>
                 </a:solidFill>
@@ -21409,13 +21411,13 @@
                   </a:extLst>
                 </a:hlinkClick>
               </a:rPr>
-              <a:t>https://ceres-solver.readthedocs.io/latest/installation.html</a:t>
+              <a:t>Ceres installation</a:t>
             </a:r>
             <a:pPr indent="0" marL="0">
               <a:buNone/>
             </a:pPr>
             <a:r>
-              <a:rPr lang="en-US" sz="950" dirty="0">
+              <a:rPr lang="en-US" sz="1050" dirty="0">
                 <a:solidFill>
                   <a:srgbClr val="5A6472"/>
                 </a:solidFill>
@@ -21426,7 +21428,7 @@
               <a:buNone/>
             </a:pPr>
             <a:r>
-              <a:rPr lang="en-US" sz="950" u="sng" dirty="0">
+              <a:rPr lang="en-US" sz="1050" u="sng" dirty="0">
                 <a:solidFill>
                   <a:srgbClr val="3E74B8"/>
                 </a:solidFill>
@@ -21438,9 +21440,9 @@
                   </a:extLst>
                 </a:hlinkClick>
               </a:rPr>
-              <a:t>https://ceres-solver.readthedocs.io/latest/nnls_solving.html</a:t>
-            </a:r>
-            <a:endParaRPr lang="en-US" sz="950" dirty="0"/>
+              <a:t>Ceres nonlinear least-squares</a:t>
+            </a:r>
+            <a:endParaRPr lang="en-US" sz="1050" dirty="0"/>
           </a:p>
         </p:txBody>
       </p:sp>
@@ -22697,8 +22699,8 @@
         </p:nvSpPr>
         <p:spPr>
           <a:xfrm>
-            <a:off x="8229600" y="1335024"/>
-            <a:ext cx="3182112" cy="2011680"/>
+            <a:off x="8686800" y="1335024"/>
+            <a:ext cx="2724912" cy="2011680"/>
           </a:xfrm>
           <a:prstGeom prst="rect">
             <a:avLst/>
@@ -22722,7 +22724,7 @@
         </p:nvSpPr>
         <p:spPr>
           <a:xfrm>
-            <a:off x="8229600" y="1335024"/>
+            <a:off x="8686800" y="1335024"/>
             <a:ext cx="64008" cy="2011680"/>
           </a:xfrm>
           <a:prstGeom prst="rect">
@@ -22747,31 +22749,33 @@
         </p:nvSpPr>
         <p:spPr>
           <a:xfrm>
-            <a:off x="8485632" y="1627632"/>
-            <a:ext cx="2670048" cy="182880"/>
-          </a:xfrm>
-          <a:prstGeom prst="rect">
-            <a:avLst/>
-          </a:prstGeom>
-          <a:noFill/>
-          <a:ln/>
-        </p:spPr>
-        <p:txBody>
-          <a:bodyPr wrap="square" lIns="0" tIns="0" rIns="0" bIns="0" rtlCol="0" anchor="ctr"/>
+            <a:off x="8915400" y="1627632"/>
+            <a:ext cx="2267712" cy="182880"/>
+          </a:xfrm>
+          <a:prstGeom prst="rect">
+            <a:avLst/>
+          </a:prstGeom>
+          <a:noFill/>
+          <a:ln/>
+        </p:spPr>
+        <p:txBody>
+          <a:bodyPr wrap="square" lIns="0" tIns="0" rIns="0" bIns="0" rtlCol="0" anchor="ctr">
+            <a:normAutofit/>
+          </a:bodyPr>
           <a:lstStyle/>
           <a:p>
             <a:pPr algn="ctr" indent="0" marL="0">
               <a:buNone/>
             </a:pPr>
             <a:r>
-              <a:rPr lang="en-US" sz="1500" b="1" dirty="0">
+              <a:rPr lang="en-US" sz="1400" b="1" dirty="0">
                 <a:solidFill>
                   <a:srgbClr val="46A06F"/>
                 </a:solidFill>
               </a:rPr>
               <a:t>Synthetic GPU reference</a:t>
             </a:r>
-            <a:endParaRPr lang="en-US" sz="1500" dirty="0"/>
+            <a:endParaRPr lang="en-US" sz="1400" dirty="0"/>
           </a:p>
         </p:txBody>
       </p:sp>
@@ -22783,31 +22787,33 @@
         </p:nvSpPr>
         <p:spPr>
           <a:xfrm>
-            <a:off x="8485632" y="1993392"/>
-            <a:ext cx="2670048" cy="310896"/>
-          </a:xfrm>
-          <a:prstGeom prst="rect">
-            <a:avLst/>
-          </a:prstGeom>
-          <a:noFill/>
-          <a:ln/>
-        </p:spPr>
-        <p:txBody>
-          <a:bodyPr wrap="square" lIns="0" tIns="0" rIns="0" bIns="0" rtlCol="0" anchor="ctr"/>
+            <a:off x="8915400" y="1993392"/>
+            <a:ext cx="2267712" cy="310896"/>
+          </a:xfrm>
+          <a:prstGeom prst="rect">
+            <a:avLst/>
+          </a:prstGeom>
+          <a:noFill/>
+          <a:ln/>
+        </p:spPr>
+        <p:txBody>
+          <a:bodyPr wrap="square" lIns="0" tIns="0" rIns="0" bIns="0" rtlCol="0" anchor="ctr">
+            <a:normAutofit/>
+          </a:bodyPr>
           <a:lstStyle/>
           <a:p>
             <a:pPr algn="ctr" indent="0" marL="0">
               <a:buNone/>
             </a:pPr>
             <a:r>
-              <a:rPr lang="en-US" sz="2700" b="1" dirty="0">
+              <a:rPr lang="en-US" sz="2600" b="1" dirty="0">
                 <a:solidFill>
                   <a:srgbClr val="46A06F"/>
                 </a:solidFill>
               </a:rPr>
               <a:t>8.051 ms</a:t>
             </a:r>
-            <a:endParaRPr lang="en-US" sz="2700" dirty="0"/>
+            <a:endParaRPr lang="en-US" sz="2600" dirty="0"/>
           </a:p>
         </p:txBody>
       </p:sp>
@@ -22819,8 +22825,8 @@
         </p:nvSpPr>
         <p:spPr>
           <a:xfrm>
-            <a:off x="8485632" y="2505456"/>
-            <a:ext cx="2670048" cy="365760"/>
+            <a:off x="8915400" y="2468880"/>
+            <a:ext cx="2267712" cy="475488"/>
           </a:xfrm>
           <a:prstGeom prst="rect">
             <a:avLst/>
@@ -23507,7 +23513,7 @@
         </p:nvSpPr>
         <p:spPr>
           <a:xfrm>
-            <a:off x="10378440" y="429768"/>
+            <a:off x="9738360" y="429768"/>
             <a:ext cx="1234440" cy="274320"/>
           </a:xfrm>
           <a:prstGeom prst="rect">
@@ -23532,7 +23538,7 @@
         </p:nvSpPr>
         <p:spPr>
           <a:xfrm>
-            <a:off x="10451592" y="498348"/>
+            <a:off x="9811512" y="498348"/>
             <a:ext cx="1088136" cy="100584"/>
           </a:xfrm>
           <a:prstGeom prst="rect">
@@ -23570,7 +23576,7 @@
         </p:nvSpPr>
         <p:spPr>
           <a:xfrm>
-            <a:off x="11201400" y="429768"/>
+            <a:off x="11082528" y="429768"/>
             <a:ext cx="1069848" cy="274320"/>
           </a:xfrm>
           <a:prstGeom prst="rect">
@@ -23595,7 +23601,7 @@
         </p:nvSpPr>
         <p:spPr>
           <a:xfrm>
-            <a:off x="11274552" y="498348"/>
+            <a:off x="11155680" y="498348"/>
             <a:ext cx="923544" cy="100584"/>
           </a:xfrm>
           <a:prstGeom prst="rect">

</xml_diff>

<commit_message>
docs: clarify graph representation boundaries
</commit_message>
<xml_diff>
--- a/timing/sfm_ba/benchmark_logs/20260710T_cuda_sfm_progress/cuda_sfm_progress_update.pptx
+++ b/timing/sfm_ba/benchmark_logs/20260710T_cuda_sfm_progress/cuda_sfm_progress_update.pptx
@@ -776,7 +776,7 @@
           <a:p>
             <a:r>
               <a:rPr lang="en-US" dirty="0"/>
-              <a:t>About 60 seconds. Start from the left: the user-facing input is a normal GTSAM graph and Values, with generic factor ownership and the current variable state. The specialized path scans that graph, selects the SFM subset, and creates arrays for cameras, points, measurements, and key maps. CUDA operates on those arrays, not on arbitrary GTSAM factors. After the backend returns, optimized arrays must be rebuilt as Values and merged into the original state. I am calling out each boundary because the timing includes this integration work, not only the GPU kernel.</a:t>
+              <a:t>About 60 seconds. Start from the left: the user-facing input is a normal GTSAM graph containing generic factors, together with the current variable estimates in Values. The specialized path scans that graph, selects the SFM subset, and creates arrays for cameras, points, measurements, and key maps. CUDA operates on those arrays, not on arbitrary GTSAM factors. After the backend returns, optimized arrays must be rebuilt as Values and merged into the original state. I am calling out each representation boundary because the timing includes this integration work, not only the GPU kernel.</a:t>
             </a:r>
             <a:endParaRPr lang="en-US" dirty="0"/>
           </a:p>
@@ -10839,7 +10839,7 @@
                   <a:srgbClr val="5A6472"/>
                 </a:solidFill>
               </a:rPr>
-              <a:t>Generic graph, current variable state, and factor ownership.</a:t>
+              <a:t>Generic factors and current variable estimates.</a:t>
             </a:r>
             <a:endParaRPr lang="en-US" sz="1250" dirty="0"/>
           </a:p>
@@ -11479,7 +11479,7 @@
                   <a:srgbClr val="18212F"/>
                 </a:solidFill>
               </a:rPr>
-              <a:t>Boundary responsibilities</a:t>
+              <a:t>Work performed at each representation boundary</a:t>
             </a:r>
             <a:endParaRPr lang="en-US" sz="1700" dirty="0"/>
           </a:p>

</xml_diff>

<commit_message>
docs: simplify current implementation slide
</commit_message>
<xml_diff>
--- a/timing/sfm_ba/benchmark_logs/20260710T_cuda_sfm_progress/cuda_sfm_progress_update.pptx
+++ b/timing/sfm_ba/benchmark_logs/20260710T_cuda_sfm_progress/cuda_sfm_progress_update.pptx
@@ -776,7 +776,7 @@
           <a:p>
             <a:r>
               <a:rPr lang="en-US" dirty="0"/>
-              <a:t>About 60 seconds. Start from the left: the user-facing input is a normal GTSAM graph containing generic factors, together with the current variable estimates in Values. The specialized path scans that graph, selects the SFM subset, and creates arrays for cameras, points, measurements, and key maps. CUDA operates on those arrays, not on arbitrary GTSAM factors. After the backend returns, optimized arrays must be rebuilt as Values and merged into the original state. I am calling out each representation boundary because the timing includes this integration work, not only the GPU kernel.</a:t>
+              <a:t>About 60 seconds. Start from the left: the user-facing input is a normal GTSAM graph containing generic factors, together with the current variable estimates in Values. The specialized path scans that graph, selects the supported SFM subset, and creates CPU arrays for cameras, points, measurements, and key maps. Those arrays are allocated and copied to the GPU for LM with dense Schur. After the backend returns, the optimized camera and point arrays are copied back, rebuilt as typed GTSAM Values, and merged into the original state. The main point is that the measured API includes this entire integration path, not only GPU kernel time.</a:t>
             </a:r>
             <a:endParaRPr lang="en-US" dirty="0"/>
           </a:p>
@@ -10952,7 +10952,7 @@
                   <a:srgbClr val="18212F"/>
                 </a:solidFill>
               </a:rPr>
-              <a:t>Specialized graph conversion</a:t>
+              <a:t>SFM host arrays</a:t>
             </a:r>
             <a:endParaRPr lang="en-US" sz="1500" dirty="0"/>
           </a:p>
@@ -10990,7 +10990,7 @@
                   <a:srgbClr val="5A6472"/>
                 </a:solidFill>
               </a:rPr>
-              <a:t>Extract SFM factors, keys, measurements, cameras, and points into host arrays.</a:t>
+              <a:t>Extract supported factors, keys, measurements, cameras, and points on the CPU.</a:t>
             </a:r>
             <a:endParaRPr lang="en-US" sz="1250" dirty="0"/>
           </a:p>
@@ -11103,7 +11103,7 @@
                   <a:srgbClr val="18212F"/>
                 </a:solidFill>
               </a:rPr>
-              <a:t>CUDA SFM arrays / backend</a:t>
+              <a:t>GPU backend</a:t>
             </a:r>
             <a:endParaRPr lang="en-US" sz="1500" dirty="0"/>
           </a:p>
@@ -11141,7 +11141,7 @@
                   <a:srgbClr val="5A6472"/>
                 </a:solidFill>
               </a:rPr>
-              <a:t>Pack, upload, run LM with dense Schur, and retain packed result arrays.</a:t>
+              <a:t>Allocate and copy arrays, run LM with dense Schur, and retain packed results.</a:t>
             </a:r>
             <a:endParaRPr lang="en-US" sz="1250" dirty="0"/>
           </a:p>
@@ -11254,7 +11254,7 @@
                   <a:srgbClr val="18212F"/>
                 </a:solidFill>
               </a:rPr>
-              <a:t>Downloaded Values</a:t>
+              <a:t>Downloaded result arrays</a:t>
             </a:r>
             <a:endParaRPr lang="en-US" sz="1500" dirty="0"/>
           </a:p>
@@ -11292,7 +11292,7 @@
                   <a:srgbClr val="5A6472"/>
                 </a:solidFill>
               </a:rPr>
-              <a:t>Rebuild optimized camera and point Values from host-side result arrays.</a:t>
+              <a:t>Copy optimized camera and point arrays back to the CPU and rebuild typed Values.</a:t>
             </a:r>
             <a:endParaRPr lang="en-US" sz="1250" dirty="0"/>
           </a:p>
@@ -11457,8 +11457,8 @@
         </p:nvSpPr>
         <p:spPr>
           <a:xfrm>
-            <a:off x="658368" y="3803904"/>
-            <a:ext cx="3840480" cy="210312"/>
+            <a:off x="658368" y="4005072"/>
+            <a:ext cx="4572000" cy="256032"/>
           </a:xfrm>
           <a:prstGeom prst="rect">
             <a:avLst/>
@@ -11474,814 +11474,58 @@
               <a:buNone/>
             </a:pPr>
             <a:r>
-              <a:rPr lang="en-US" sz="1700" b="1" dirty="0">
+              <a:rPr lang="en-US" sz="1800" b="1" dirty="0">
+                <a:solidFill>
+                  <a:srgbClr val="0E7C86"/>
+                </a:solidFill>
+              </a:rPr>
+              <a:t>What the timing includes</a:t>
+            </a:r>
+            <a:endParaRPr lang="en-US" sz="1800" dirty="0"/>
+          </a:p>
+        </p:txBody>
+      </p:sp>
+      <p:sp>
+        <p:nvSpPr>
+          <p:cNvPr id="32" name="Text 30"/>
+          <p:cNvSpPr/>
+          <p:nvPr/>
+        </p:nvSpPr>
+        <p:spPr>
+          <a:xfrm>
+            <a:off x="658368" y="4462272"/>
+            <a:ext cx="10515600" cy="822960"/>
+          </a:xfrm>
+          <a:prstGeom prst="rect">
+            <a:avLst/>
+          </a:prstGeom>
+          <a:noFill/>
+          <a:ln/>
+        </p:spPr>
+        <p:txBody>
+          <a:bodyPr wrap="square" lIns="0" tIns="0" rIns="0" bIns="0" rtlCol="0" anchor="ctr">
+            <a:normAutofit/>
+          </a:bodyPr>
+          <a:lstStyle/>
+          <a:p>
+            <a:pPr indent="0" marL="0">
+              <a:buNone/>
+            </a:pPr>
+            <a:r>
+              <a:rPr lang="en-US" sz="2400" b="1" dirty="0">
                 <a:solidFill>
                   <a:srgbClr val="18212F"/>
                 </a:solidFill>
               </a:rPr>
-              <a:t>Work performed at each representation boundary</a:t>
-            </a:r>
-            <a:endParaRPr lang="en-US" sz="1700" dirty="0"/>
-          </a:p>
-        </p:txBody>
-      </p:sp>
-      <p:sp>
-        <p:nvSpPr>
-          <p:cNvPr id="32" name="Shape 30"/>
-          <p:cNvSpPr/>
-          <p:nvPr/>
-        </p:nvSpPr>
-        <p:spPr>
-          <a:xfrm>
-            <a:off x="658368" y="4261104"/>
-            <a:ext cx="1965960" cy="429768"/>
-          </a:xfrm>
-          <a:prstGeom prst="rect">
-            <a:avLst/>
-          </a:prstGeom>
-          <a:solidFill>
-            <a:srgbClr val="1F2A44"/>
-          </a:solidFill>
-          <a:ln w="5715">
-            <a:solidFill>
-              <a:srgbClr val="F7F8FA"/>
-            </a:solidFill>
-            <a:prstDash val="solid"/>
-          </a:ln>
-        </p:spPr>
+              <a:t>The measured API includes CPU graph conversion, GPU setup and solving, and reconstruction of the final GTSAM Values.</a:t>
+            </a:r>
+            <a:endParaRPr lang="en-US" sz="2400" dirty="0"/>
+          </a:p>
+        </p:txBody>
       </p:sp>
       <p:sp>
         <p:nvSpPr>
           <p:cNvPr id="33" name="Text 31"/>
-          <p:cNvSpPr/>
-          <p:nvPr/>
-        </p:nvSpPr>
-        <p:spPr>
-          <a:xfrm>
-            <a:off x="722376" y="4347972"/>
-            <a:ext cx="1837944" cy="292608"/>
-          </a:xfrm>
-          <a:prstGeom prst="rect">
-            <a:avLst/>
-          </a:prstGeom>
-          <a:noFill/>
-          <a:ln/>
-        </p:spPr>
-        <p:txBody>
-          <a:bodyPr wrap="square" lIns="0" tIns="0" rIns="0" bIns="0" rtlCol="0" anchor="ctr">
-            <a:normAutofit/>
-          </a:bodyPr>
-          <a:lstStyle/>
-          <a:p>
-            <a:pPr algn="l" indent="0" marL="0">
-              <a:buNone/>
-            </a:pPr>
-            <a:r>
-              <a:rPr lang="en-US" sz="1220" b="1" dirty="0">
-                <a:solidFill>
-                  <a:srgbClr val="FFFFFF"/>
-                </a:solidFill>
-              </a:rPr>
-              <a:t>Boundary</a:t>
-            </a:r>
-            <a:endParaRPr lang="en-US" sz="1220" dirty="0"/>
-          </a:p>
-        </p:txBody>
-      </p:sp>
-      <p:sp>
-        <p:nvSpPr>
-          <p:cNvPr id="34" name="Shape 32"/>
-          <p:cNvSpPr/>
-          <p:nvPr/>
-        </p:nvSpPr>
-        <p:spPr>
-          <a:xfrm>
-            <a:off x="2624328" y="4261104"/>
-            <a:ext cx="3520440" cy="429768"/>
-          </a:xfrm>
-          <a:prstGeom prst="rect">
-            <a:avLst/>
-          </a:prstGeom>
-          <a:solidFill>
-            <a:srgbClr val="1F2A44"/>
-          </a:solidFill>
-          <a:ln w="5715">
-            <a:solidFill>
-              <a:srgbClr val="F7F8FA"/>
-            </a:solidFill>
-            <a:prstDash val="solid"/>
-          </a:ln>
-        </p:spPr>
-      </p:sp>
-      <p:sp>
-        <p:nvSpPr>
-          <p:cNvPr id="35" name="Text 33"/>
-          <p:cNvSpPr/>
-          <p:nvPr/>
-        </p:nvSpPr>
-        <p:spPr>
-          <a:xfrm>
-            <a:off x="2688336" y="4347972"/>
-            <a:ext cx="3392424" cy="292608"/>
-          </a:xfrm>
-          <a:prstGeom prst="rect">
-            <a:avLst/>
-          </a:prstGeom>
-          <a:noFill/>
-          <a:ln/>
-        </p:spPr>
-        <p:txBody>
-          <a:bodyPr wrap="square" lIns="0" tIns="0" rIns="0" bIns="0" rtlCol="0" anchor="ctr">
-            <a:normAutofit/>
-          </a:bodyPr>
-          <a:lstStyle/>
-          <a:p>
-            <a:pPr algn="l" indent="0" marL="0">
-              <a:buNone/>
-            </a:pPr>
-            <a:r>
-              <a:rPr lang="en-US" sz="1220" b="1" dirty="0">
-                <a:solidFill>
-                  <a:srgbClr val="FFFFFF"/>
-                </a:solidFill>
-              </a:rPr>
-              <a:t>What it does</a:t>
-            </a:r>
-            <a:endParaRPr lang="en-US" sz="1220" dirty="0"/>
-          </a:p>
-        </p:txBody>
-      </p:sp>
-      <p:sp>
-        <p:nvSpPr>
-          <p:cNvPr id="36" name="Shape 34"/>
-          <p:cNvSpPr/>
-          <p:nvPr/>
-        </p:nvSpPr>
-        <p:spPr>
-          <a:xfrm>
-            <a:off x="6144768" y="4261104"/>
-            <a:ext cx="5394960" cy="429768"/>
-          </a:xfrm>
-          <a:prstGeom prst="rect">
-            <a:avLst/>
-          </a:prstGeom>
-          <a:solidFill>
-            <a:srgbClr val="1F2A44"/>
-          </a:solidFill>
-          <a:ln w="5715">
-            <a:solidFill>
-              <a:srgbClr val="F7F8FA"/>
-            </a:solidFill>
-            <a:prstDash val="solid"/>
-          </a:ln>
-        </p:spPr>
-      </p:sp>
-      <p:sp>
-        <p:nvSpPr>
-          <p:cNvPr id="37" name="Text 35"/>
-          <p:cNvSpPr/>
-          <p:nvPr/>
-        </p:nvSpPr>
-        <p:spPr>
-          <a:xfrm>
-            <a:off x="6208776" y="4347972"/>
-            <a:ext cx="5266944" cy="292608"/>
-          </a:xfrm>
-          <a:prstGeom prst="rect">
-            <a:avLst/>
-          </a:prstGeom>
-          <a:noFill/>
-          <a:ln/>
-        </p:spPr>
-        <p:txBody>
-          <a:bodyPr wrap="square" lIns="0" tIns="0" rIns="0" bIns="0" rtlCol="0" anchor="ctr">
-            <a:normAutofit/>
-          </a:bodyPr>
-          <a:lstStyle/>
-          <a:p>
-            <a:pPr algn="l" indent="0" marL="0">
-              <a:buNone/>
-            </a:pPr>
-            <a:r>
-              <a:rPr lang="en-US" sz="1220" b="1" dirty="0">
-                <a:solidFill>
-                  <a:srgbClr val="FFFFFF"/>
-                </a:solidFill>
-              </a:rPr>
-              <a:t>Why it matters</a:t>
-            </a:r>
-            <a:endParaRPr lang="en-US" sz="1220" dirty="0"/>
-          </a:p>
-        </p:txBody>
-      </p:sp>
-      <p:sp>
-        <p:nvSpPr>
-          <p:cNvPr id="38" name="Shape 36"/>
-          <p:cNvSpPr/>
-          <p:nvPr/>
-        </p:nvSpPr>
-        <p:spPr>
-          <a:xfrm>
-            <a:off x="658368" y="4690872"/>
-            <a:ext cx="1965960" cy="429768"/>
-          </a:xfrm>
-          <a:prstGeom prst="rect">
-            <a:avLst/>
-          </a:prstGeom>
-          <a:solidFill>
-            <a:srgbClr val="FFFFFF"/>
-          </a:solidFill>
-          <a:ln w="5715">
-            <a:solidFill>
-              <a:srgbClr val="F7F8FA"/>
-            </a:solidFill>
-            <a:prstDash val="solid"/>
-          </a:ln>
-        </p:spPr>
-      </p:sp>
-      <p:sp>
-        <p:nvSpPr>
-          <p:cNvPr id="39" name="Text 37"/>
-          <p:cNvSpPr/>
-          <p:nvPr/>
-        </p:nvSpPr>
-        <p:spPr>
-          <a:xfrm>
-            <a:off x="722376" y="4777740"/>
-            <a:ext cx="1837944" cy="292608"/>
-          </a:xfrm>
-          <a:prstGeom prst="rect">
-            <a:avLst/>
-          </a:prstGeom>
-          <a:noFill/>
-          <a:ln/>
-        </p:spPr>
-        <p:txBody>
-          <a:bodyPr wrap="square" lIns="0" tIns="0" rIns="0" bIns="0" rtlCol="0" anchor="ctr">
-            <a:normAutofit/>
-          </a:bodyPr>
-          <a:lstStyle/>
-          <a:p>
-            <a:pPr algn="l" indent="0" marL="0">
-              <a:buNone/>
-            </a:pPr>
-            <a:r>
-              <a:rPr lang="en-US" sz="1220" b="1" dirty="0">
-                <a:solidFill>
-                  <a:srgbClr val="18212F"/>
-                </a:solidFill>
-              </a:rPr>
-              <a:t>Generic to SFM</a:t>
-            </a:r>
-            <a:endParaRPr lang="en-US" sz="1220" dirty="0"/>
-          </a:p>
-        </p:txBody>
-      </p:sp>
-      <p:sp>
-        <p:nvSpPr>
-          <p:cNvPr id="40" name="Shape 38"/>
-          <p:cNvSpPr/>
-          <p:nvPr/>
-        </p:nvSpPr>
-        <p:spPr>
-          <a:xfrm>
-            <a:off x="2624328" y="4690872"/>
-            <a:ext cx="3520440" cy="429768"/>
-          </a:xfrm>
-          <a:prstGeom prst="rect">
-            <a:avLst/>
-          </a:prstGeom>
-          <a:solidFill>
-            <a:srgbClr val="FFFFFF"/>
-          </a:solidFill>
-          <a:ln w="5715">
-            <a:solidFill>
-              <a:srgbClr val="F7F8FA"/>
-            </a:solidFill>
-            <a:prstDash val="solid"/>
-          </a:ln>
-        </p:spPr>
-      </p:sp>
-      <p:sp>
-        <p:nvSpPr>
-          <p:cNvPr id="41" name="Text 39"/>
-          <p:cNvSpPr/>
-          <p:nvPr/>
-        </p:nvSpPr>
-        <p:spPr>
-          <a:xfrm>
-            <a:off x="2688336" y="4777740"/>
-            <a:ext cx="3392424" cy="292608"/>
-          </a:xfrm>
-          <a:prstGeom prst="rect">
-            <a:avLst/>
-          </a:prstGeom>
-          <a:noFill/>
-          <a:ln/>
-        </p:spPr>
-        <p:txBody>
-          <a:bodyPr wrap="square" lIns="0" tIns="0" rIns="0" bIns="0" rtlCol="0" anchor="ctr">
-            <a:normAutofit/>
-          </a:bodyPr>
-          <a:lstStyle/>
-          <a:p>
-            <a:pPr algn="l" indent="0" marL="0">
-              <a:buNone/>
-            </a:pPr>
-            <a:r>
-              <a:rPr lang="en-US" sz="1220" dirty="0">
-                <a:solidFill>
-                  <a:srgbClr val="18212F"/>
-                </a:solidFill>
-              </a:rPr>
-              <a:t>CPU representation conversion</a:t>
-            </a:r>
-            <a:endParaRPr lang="en-US" sz="1220" dirty="0"/>
-          </a:p>
-        </p:txBody>
-      </p:sp>
-      <p:sp>
-        <p:nvSpPr>
-          <p:cNvPr id="42" name="Shape 40"/>
-          <p:cNvSpPr/>
-          <p:nvPr/>
-        </p:nvSpPr>
-        <p:spPr>
-          <a:xfrm>
-            <a:off x="6144768" y="4690872"/>
-            <a:ext cx="5394960" cy="429768"/>
-          </a:xfrm>
-          <a:prstGeom prst="rect">
-            <a:avLst/>
-          </a:prstGeom>
-          <a:solidFill>
-            <a:srgbClr val="FFFFFF"/>
-          </a:solidFill>
-          <a:ln w="5715">
-            <a:solidFill>
-              <a:srgbClr val="F7F8FA"/>
-            </a:solidFill>
-            <a:prstDash val="solid"/>
-          </a:ln>
-        </p:spPr>
-      </p:sp>
-      <p:sp>
-        <p:nvSpPr>
-          <p:cNvPr id="43" name="Text 41"/>
-          <p:cNvSpPr/>
-          <p:nvPr/>
-        </p:nvSpPr>
-        <p:spPr>
-          <a:xfrm>
-            <a:off x="6208776" y="4777740"/>
-            <a:ext cx="5266944" cy="292608"/>
-          </a:xfrm>
-          <a:prstGeom prst="rect">
-            <a:avLst/>
-          </a:prstGeom>
-          <a:noFill/>
-          <a:ln/>
-        </p:spPr>
-        <p:txBody>
-          <a:bodyPr wrap="square" lIns="0" tIns="0" rIns="0" bIns="0" rtlCol="0" anchor="ctr">
-            <a:normAutofit/>
-          </a:bodyPr>
-          <a:lstStyle/>
-          <a:p>
-            <a:pPr algn="l" indent="0" marL="0">
-              <a:buNone/>
-            </a:pPr>
-            <a:r>
-              <a:rPr lang="en-US" sz="1220" dirty="0">
-                <a:solidFill>
-                  <a:srgbClr val="18212F"/>
-                </a:solidFill>
-              </a:rPr>
-              <a:t>The CUDA backend does not consume arbitrary GTSAM factors.</a:t>
-            </a:r>
-            <a:endParaRPr lang="en-US" sz="1220" dirty="0"/>
-          </a:p>
-        </p:txBody>
-      </p:sp>
-      <p:sp>
-        <p:nvSpPr>
-          <p:cNvPr id="44" name="Shape 42"/>
-          <p:cNvSpPr/>
-          <p:nvPr/>
-        </p:nvSpPr>
-        <p:spPr>
-          <a:xfrm>
-            <a:off x="658368" y="5120640"/>
-            <a:ext cx="1965960" cy="429768"/>
-          </a:xfrm>
-          <a:prstGeom prst="rect">
-            <a:avLst/>
-          </a:prstGeom>
-          <a:solidFill>
-            <a:srgbClr val="F0F4F7"/>
-          </a:solidFill>
-          <a:ln w="5715">
-            <a:solidFill>
-              <a:srgbClr val="F7F8FA"/>
-            </a:solidFill>
-            <a:prstDash val="solid"/>
-          </a:ln>
-        </p:spPr>
-      </p:sp>
-      <p:sp>
-        <p:nvSpPr>
-          <p:cNvPr id="45" name="Text 43"/>
-          <p:cNvSpPr/>
-          <p:nvPr/>
-        </p:nvSpPr>
-        <p:spPr>
-          <a:xfrm>
-            <a:off x="722376" y="5207508"/>
-            <a:ext cx="1837944" cy="292608"/>
-          </a:xfrm>
-          <a:prstGeom prst="rect">
-            <a:avLst/>
-          </a:prstGeom>
-          <a:noFill/>
-          <a:ln/>
-        </p:spPr>
-        <p:txBody>
-          <a:bodyPr wrap="square" lIns="0" tIns="0" rIns="0" bIns="0" rtlCol="0" anchor="ctr">
-            <a:normAutofit/>
-          </a:bodyPr>
-          <a:lstStyle/>
-          <a:p>
-            <a:pPr algn="l" indent="0" marL="0">
-              <a:buNone/>
-            </a:pPr>
-            <a:r>
-              <a:rPr lang="en-US" sz="1220" b="1" dirty="0">
-                <a:solidFill>
-                  <a:srgbClr val="18212F"/>
-                </a:solidFill>
-              </a:rPr>
-              <a:t>SFM to device</a:t>
-            </a:r>
-            <a:endParaRPr lang="en-US" sz="1220" dirty="0"/>
-          </a:p>
-        </p:txBody>
-      </p:sp>
-      <p:sp>
-        <p:nvSpPr>
-          <p:cNvPr id="46" name="Shape 44"/>
-          <p:cNvSpPr/>
-          <p:nvPr/>
-        </p:nvSpPr>
-        <p:spPr>
-          <a:xfrm>
-            <a:off x="2624328" y="5120640"/>
-            <a:ext cx="3520440" cy="429768"/>
-          </a:xfrm>
-          <a:prstGeom prst="rect">
-            <a:avLst/>
-          </a:prstGeom>
-          <a:solidFill>
-            <a:srgbClr val="F0F4F7"/>
-          </a:solidFill>
-          <a:ln w="5715">
-            <a:solidFill>
-              <a:srgbClr val="F7F8FA"/>
-            </a:solidFill>
-            <a:prstDash val="solid"/>
-          </a:ln>
-        </p:spPr>
-      </p:sp>
-      <p:sp>
-        <p:nvSpPr>
-          <p:cNvPr id="47" name="Text 45"/>
-          <p:cNvSpPr/>
-          <p:nvPr/>
-        </p:nvSpPr>
-        <p:spPr>
-          <a:xfrm>
-            <a:off x="2688336" y="5207508"/>
-            <a:ext cx="3392424" cy="292608"/>
-          </a:xfrm>
-          <a:prstGeom prst="rect">
-            <a:avLst/>
-          </a:prstGeom>
-          <a:noFill/>
-          <a:ln/>
-        </p:spPr>
-        <p:txBody>
-          <a:bodyPr wrap="square" lIns="0" tIns="0" rIns="0" bIns="0" rtlCol="0" anchor="ctr">
-            <a:normAutofit/>
-          </a:bodyPr>
-          <a:lstStyle/>
-          <a:p>
-            <a:pPr algn="l" indent="0" marL="0">
-              <a:buNone/>
-            </a:pPr>
-            <a:r>
-              <a:rPr lang="en-US" sz="1220" dirty="0">
-                <a:solidFill>
-                  <a:srgbClr val="18212F"/>
-                </a:solidFill>
-              </a:rPr>
-              <a:t>Array packing and backend setup</a:t>
-            </a:r>
-            <a:endParaRPr lang="en-US" sz="1220" dirty="0"/>
-          </a:p>
-        </p:txBody>
-      </p:sp>
-      <p:sp>
-        <p:nvSpPr>
-          <p:cNvPr id="48" name="Shape 46"/>
-          <p:cNvSpPr/>
-          <p:nvPr/>
-        </p:nvSpPr>
-        <p:spPr>
-          <a:xfrm>
-            <a:off x="6144768" y="5120640"/>
-            <a:ext cx="5394960" cy="429768"/>
-          </a:xfrm>
-          <a:prstGeom prst="rect">
-            <a:avLst/>
-          </a:prstGeom>
-          <a:solidFill>
-            <a:srgbClr val="F0F4F7"/>
-          </a:solidFill>
-          <a:ln w="5715">
-            <a:solidFill>
-              <a:srgbClr val="F7F8FA"/>
-            </a:solidFill>
-            <a:prstDash val="solid"/>
-          </a:ln>
-        </p:spPr>
-      </p:sp>
-      <p:sp>
-        <p:nvSpPr>
-          <p:cNvPr id="49" name="Text 47"/>
-          <p:cNvSpPr/>
-          <p:nvPr/>
-        </p:nvSpPr>
-        <p:spPr>
-          <a:xfrm>
-            <a:off x="6208776" y="5207508"/>
-            <a:ext cx="5266944" cy="292608"/>
-          </a:xfrm>
-          <a:prstGeom prst="rect">
-            <a:avLst/>
-          </a:prstGeom>
-          <a:noFill/>
-          <a:ln/>
-        </p:spPr>
-        <p:txBody>
-          <a:bodyPr wrap="square" lIns="0" tIns="0" rIns="0" bIns="0" rtlCol="0" anchor="ctr">
-            <a:normAutofit/>
-          </a:bodyPr>
-          <a:lstStyle/>
-          <a:p>
-            <a:pPr algn="l" indent="0" marL="0">
-              <a:buNone/>
-            </a:pPr>
-            <a:r>
-              <a:rPr lang="en-US" sz="1220" dirty="0">
-                <a:solidFill>
-                  <a:srgbClr val="18212F"/>
-                </a:solidFill>
-              </a:rPr>
-              <a:t>Includes host builds as well as GPU work.</a:t>
-            </a:r>
-            <a:endParaRPr lang="en-US" sz="1220" dirty="0"/>
-          </a:p>
-        </p:txBody>
-      </p:sp>
-      <p:sp>
-        <p:nvSpPr>
-          <p:cNvPr id="50" name="Shape 48"/>
-          <p:cNvSpPr/>
-          <p:nvPr/>
-        </p:nvSpPr>
-        <p:spPr>
-          <a:xfrm>
-            <a:off x="658368" y="5550408"/>
-            <a:ext cx="1965960" cy="429768"/>
-          </a:xfrm>
-          <a:prstGeom prst="rect">
-            <a:avLst/>
-          </a:prstGeom>
-          <a:solidFill>
-            <a:srgbClr val="FFFFFF"/>
-          </a:solidFill>
-          <a:ln w="5715">
-            <a:solidFill>
-              <a:srgbClr val="F7F8FA"/>
-            </a:solidFill>
-            <a:prstDash val="solid"/>
-          </a:ln>
-        </p:spPr>
-      </p:sp>
-      <p:sp>
-        <p:nvSpPr>
-          <p:cNvPr id="51" name="Text 49"/>
-          <p:cNvSpPr/>
-          <p:nvPr/>
-        </p:nvSpPr>
-        <p:spPr>
-          <a:xfrm>
-            <a:off x="722376" y="5637276"/>
-            <a:ext cx="1837944" cy="292608"/>
-          </a:xfrm>
-          <a:prstGeom prst="rect">
-            <a:avLst/>
-          </a:prstGeom>
-          <a:noFill/>
-          <a:ln/>
-        </p:spPr>
-        <p:txBody>
-          <a:bodyPr wrap="square" lIns="0" tIns="0" rIns="0" bIns="0" rtlCol="0" anchor="ctr">
-            <a:normAutofit/>
-          </a:bodyPr>
-          <a:lstStyle/>
-          <a:p>
-            <a:pPr algn="l" indent="0" marL="0">
-              <a:buNone/>
-            </a:pPr>
-            <a:r>
-              <a:rPr lang="en-US" sz="1220" b="1" dirty="0">
-                <a:solidFill>
-                  <a:srgbClr val="18212F"/>
-                </a:solidFill>
-              </a:rPr>
-              <a:t>Result to Values</a:t>
-            </a:r>
-            <a:endParaRPr lang="en-US" sz="1220" dirty="0"/>
-          </a:p>
-        </p:txBody>
-      </p:sp>
-      <p:sp>
-        <p:nvSpPr>
-          <p:cNvPr id="52" name="Shape 50"/>
-          <p:cNvSpPr/>
-          <p:nvPr/>
-        </p:nvSpPr>
-        <p:spPr>
-          <a:xfrm>
-            <a:off x="2624328" y="5550408"/>
-            <a:ext cx="3520440" cy="429768"/>
-          </a:xfrm>
-          <a:prstGeom prst="rect">
-            <a:avLst/>
-          </a:prstGeom>
-          <a:solidFill>
-            <a:srgbClr val="FFFFFF"/>
-          </a:solidFill>
-          <a:ln w="5715">
-            <a:solidFill>
-              <a:srgbClr val="F7F8FA"/>
-            </a:solidFill>
-            <a:prstDash val="solid"/>
-          </a:ln>
-        </p:spPr>
-      </p:sp>
-      <p:sp>
-        <p:nvSpPr>
-          <p:cNvPr id="53" name="Text 51"/>
-          <p:cNvSpPr/>
-          <p:nvPr/>
-        </p:nvSpPr>
-        <p:spPr>
-          <a:xfrm>
-            <a:off x="2688336" y="5637276"/>
-            <a:ext cx="3392424" cy="292608"/>
-          </a:xfrm>
-          <a:prstGeom prst="rect">
-            <a:avLst/>
-          </a:prstGeom>
-          <a:noFill/>
-          <a:ln/>
-        </p:spPr>
-        <p:txBody>
-          <a:bodyPr wrap="square" lIns="0" tIns="0" rIns="0" bIns="0" rtlCol="0" anchor="ctr">
-            <a:normAutofit/>
-          </a:bodyPr>
-          <a:lstStyle/>
-          <a:p>
-            <a:pPr algn="l" indent="0" marL="0">
-              <a:buNone/>
-            </a:pPr>
-            <a:r>
-              <a:rPr lang="en-US" sz="1220" dirty="0">
-                <a:solidFill>
-                  <a:srgbClr val="18212F"/>
-                </a:solidFill>
-              </a:rPr>
-              <a:t>CPU reconstruction and merge</a:t>
-            </a:r>
-            <a:endParaRPr lang="en-US" sz="1220" dirty="0"/>
-          </a:p>
-        </p:txBody>
-      </p:sp>
-      <p:sp>
-        <p:nvSpPr>
-          <p:cNvPr id="54" name="Shape 52"/>
-          <p:cNvSpPr/>
-          <p:nvPr/>
-        </p:nvSpPr>
-        <p:spPr>
-          <a:xfrm>
-            <a:off x="6144768" y="5550408"/>
-            <a:ext cx="5394960" cy="429768"/>
-          </a:xfrm>
-          <a:prstGeom prst="rect">
-            <a:avLst/>
-          </a:prstGeom>
-          <a:solidFill>
-            <a:srgbClr val="FFFFFF"/>
-          </a:solidFill>
-          <a:ln w="5715">
-            <a:solidFill>
-              <a:srgbClr val="F7F8FA"/>
-            </a:solidFill>
-            <a:prstDash val="solid"/>
-          </a:ln>
-        </p:spPr>
-      </p:sp>
-      <p:sp>
-        <p:nvSpPr>
-          <p:cNvPr id="55" name="Text 53"/>
-          <p:cNvSpPr/>
-          <p:nvPr/>
-        </p:nvSpPr>
-        <p:spPr>
-          <a:xfrm>
-            <a:off x="6208776" y="5637276"/>
-            <a:ext cx="5266944" cy="292608"/>
-          </a:xfrm>
-          <a:prstGeom prst="rect">
-            <a:avLst/>
-          </a:prstGeom>
-          <a:noFill/>
-          <a:ln/>
-        </p:spPr>
-        <p:txBody>
-          <a:bodyPr wrap="square" lIns="0" tIns="0" rIns="0" bIns="0" rtlCol="0" anchor="ctr">
-            <a:normAutofit/>
-          </a:bodyPr>
-          <a:lstStyle/>
-          <a:p>
-            <a:pPr algn="l" indent="0" marL="0">
-              <a:buNone/>
-            </a:pPr>
-            <a:r>
-              <a:rPr lang="en-US" sz="1220" dirty="0">
-                <a:solidFill>
-                  <a:srgbClr val="18212F"/>
-                </a:solidFill>
-              </a:rPr>
-              <a:t>Object/state handling is included in end-to-end time.</a:t>
-            </a:r>
-            <a:endParaRPr lang="en-US" sz="1220" dirty="0"/>
-          </a:p>
-        </p:txBody>
-      </p:sp>
-      <p:sp>
-        <p:nvSpPr>
-          <p:cNvPr id="56" name="Text 54"/>
-          <p:cNvSpPr/>
-          <p:nvPr/>
-        </p:nvSpPr>
-        <p:spPr>
-          <a:xfrm>
-            <a:off x="658368" y="6144768"/>
-            <a:ext cx="8138160" cy="237744"/>
-          </a:xfrm>
-          <a:prstGeom prst="rect">
-            <a:avLst/>
-          </a:prstGeom>
-          <a:noFill/>
-          <a:ln/>
-        </p:spPr>
-        <p:txBody>
-          <a:bodyPr wrap="square" lIns="0" tIns="0" rIns="0" bIns="0" rtlCol="0" anchor="ctr">
-            <a:normAutofit/>
-          </a:bodyPr>
-          <a:lstStyle/>
-          <a:p>
-            <a:pPr indent="0" marL="0">
-              <a:buNone/>
-            </a:pPr>
-            <a:r>
-              <a:rPr lang="en-US" sz="1600" b="1" dirty="0">
-                <a:solidFill>
-                  <a:srgbClr val="0E7C86"/>
-                </a:solidFill>
-              </a:rPr>
-              <a:t>Framing: this profile measures an integration path, not only GPU kernel time.</a:t>
-            </a:r>
-            <a:endParaRPr lang="en-US" sz="1600" dirty="0"/>
-          </a:p>
-        </p:txBody>
-      </p:sp>
-      <p:sp>
-        <p:nvSpPr>
-          <p:cNvPr id="57" name="Text 55"/>
           <p:cNvSpPr/>
           <p:nvPr/>
         </p:nvSpPr>

</xml_diff>

<commit_message>
docs: label optimize timing segments
</commit_message>
<xml_diff>
--- a/timing/sfm_ba/benchmark_logs/20260710T_cuda_sfm_progress/cuda_sfm_progress_update.pptx
+++ b/timing/sfm_ba/benchmark_logs/20260710T_cuda_sfm_progress/cuda_sfm_progress_update.pptx
@@ -13572,7 +13572,45 @@
       </p:sp>
       <p:sp>
         <p:nvSpPr>
-          <p:cNvPr id="12" name="Shape 10"/>
+          <p:cNvPr id="12" name="Text 10"/>
+          <p:cNvSpPr/>
+          <p:nvPr/>
+        </p:nvSpPr>
+        <p:spPr>
+          <a:xfrm>
+            <a:off x="7996204" y="1655064"/>
+            <a:ext cx="662136" cy="146304"/>
+          </a:xfrm>
+          <a:prstGeom prst="rect">
+            <a:avLst/>
+          </a:prstGeom>
+          <a:noFill/>
+          <a:ln/>
+        </p:spPr>
+        <p:txBody>
+          <a:bodyPr wrap="square" lIns="0" tIns="0" rIns="0" bIns="0" rtlCol="0" anchor="ctr">
+            <a:normAutofit/>
+          </a:bodyPr>
+          <a:lstStyle/>
+          <a:p>
+            <a:pPr algn="ctr" indent="0" marL="0">
+              <a:buNone/>
+            </a:pPr>
+            <a:r>
+              <a:rPr lang="en-US" sz="1100" b="1" dirty="0">
+                <a:solidFill>
+                  <a:srgbClr val="FFFFFF"/>
+                </a:solidFill>
+              </a:rPr>
+              <a:t>7%</a:t>
+            </a:r>
+            <a:endParaRPr lang="en-US" sz="1100" dirty="0"/>
+          </a:p>
+        </p:txBody>
+      </p:sp>
+      <p:sp>
+        <p:nvSpPr>
+          <p:cNvPr id="13" name="Shape 11"/>
           <p:cNvSpPr/>
           <p:nvPr/>
         </p:nvSpPr>
@@ -13597,7 +13635,7 @@
       </p:sp>
       <p:sp>
         <p:nvSpPr>
-          <p:cNvPr id="13" name="Text 11"/>
+          <p:cNvPr id="14" name="Text 12"/>
           <p:cNvSpPr/>
           <p:nvPr/>
         </p:nvSpPr>
@@ -13635,7 +13673,7 @@
       </p:sp>
       <p:sp>
         <p:nvSpPr>
-          <p:cNvPr id="14" name="Shape 12"/>
+          <p:cNvPr id="15" name="Shape 13"/>
           <p:cNvSpPr/>
           <p:nvPr/>
         </p:nvSpPr>
@@ -13660,7 +13698,45 @@
       </p:sp>
       <p:sp>
         <p:nvSpPr>
-          <p:cNvPr id="15" name="Shape 13"/>
+          <p:cNvPr id="16" name="Text 14"/>
+          <p:cNvSpPr/>
+          <p:nvPr/>
+        </p:nvSpPr>
+        <p:spPr>
+          <a:xfrm>
+            <a:off x="10719466" y="1655064"/>
+            <a:ext cx="765167" cy="146304"/>
+          </a:xfrm>
+          <a:prstGeom prst="rect">
+            <a:avLst/>
+          </a:prstGeom>
+          <a:noFill/>
+          <a:ln/>
+        </p:spPr>
+        <p:txBody>
+          <a:bodyPr wrap="square" lIns="0" tIns="0" rIns="0" bIns="0" rtlCol="0" anchor="ctr">
+            <a:normAutofit/>
+          </a:bodyPr>
+          <a:lstStyle/>
+          <a:p>
+            <a:pPr algn="ctr" indent="0" marL="0">
+              <a:buNone/>
+            </a:pPr>
+            <a:r>
+              <a:rPr lang="en-US" sz="1100" b="1" dirty="0">
+                <a:solidFill>
+                  <a:srgbClr val="FFFFFF"/>
+                </a:solidFill>
+              </a:rPr>
+              <a:t>8%</a:t>
+            </a:r>
+            <a:endParaRPr lang="en-US" sz="1100" dirty="0"/>
+          </a:p>
+        </p:txBody>
+      </p:sp>
+      <p:sp>
+        <p:nvSpPr>
+          <p:cNvPr id="17" name="Shape 15"/>
           <p:cNvSpPr/>
           <p:nvPr/>
         </p:nvSpPr>
@@ -13685,7 +13761,7 @@
       </p:sp>
       <p:sp>
         <p:nvSpPr>
-          <p:cNvPr id="16" name="Shape 14"/>
+          <p:cNvPr id="18" name="Shape 16"/>
           <p:cNvSpPr/>
           <p:nvPr/>
         </p:nvSpPr>
@@ -13710,7 +13786,7 @@
       </p:sp>
       <p:sp>
         <p:nvSpPr>
-          <p:cNvPr id="17" name="Text 15"/>
+          <p:cNvPr id="19" name="Text 17"/>
           <p:cNvSpPr/>
           <p:nvPr/>
         </p:nvSpPr>
@@ -13748,7 +13824,7 @@
       </p:sp>
       <p:sp>
         <p:nvSpPr>
-          <p:cNvPr id="18" name="Shape 16"/>
+          <p:cNvPr id="20" name="Shape 18"/>
           <p:cNvSpPr/>
           <p:nvPr/>
         </p:nvSpPr>
@@ -13773,7 +13849,7 @@
       </p:sp>
       <p:sp>
         <p:nvSpPr>
-          <p:cNvPr id="19" name="Text 17"/>
+          <p:cNvPr id="21" name="Text 19"/>
           <p:cNvSpPr/>
           <p:nvPr/>
         </p:nvSpPr>
@@ -13811,7 +13887,7 @@
       </p:sp>
       <p:sp>
         <p:nvSpPr>
-          <p:cNvPr id="20" name="Shape 18"/>
+          <p:cNvPr id="22" name="Shape 20"/>
           <p:cNvSpPr/>
           <p:nvPr/>
         </p:nvSpPr>
@@ -13836,7 +13912,7 @@
       </p:sp>
       <p:sp>
         <p:nvSpPr>
-          <p:cNvPr id="21" name="Text 19"/>
+          <p:cNvPr id="23" name="Text 21"/>
           <p:cNvSpPr/>
           <p:nvPr/>
         </p:nvSpPr>
@@ -13874,7 +13950,7 @@
       </p:sp>
       <p:sp>
         <p:nvSpPr>
-          <p:cNvPr id="22" name="Shape 20"/>
+          <p:cNvPr id="24" name="Shape 22"/>
           <p:cNvSpPr/>
           <p:nvPr/>
         </p:nvSpPr>
@@ -13899,7 +13975,7 @@
       </p:sp>
       <p:sp>
         <p:nvSpPr>
-          <p:cNvPr id="23" name="Text 21"/>
+          <p:cNvPr id="25" name="Text 23"/>
           <p:cNvSpPr/>
           <p:nvPr/>
         </p:nvSpPr>
@@ -13937,7 +14013,7 @@
       </p:sp>
       <p:sp>
         <p:nvSpPr>
-          <p:cNvPr id="24" name="Shape 22"/>
+          <p:cNvPr id="26" name="Shape 24"/>
           <p:cNvSpPr/>
           <p:nvPr/>
         </p:nvSpPr>
@@ -13962,7 +14038,7 @@
       </p:sp>
       <p:sp>
         <p:nvSpPr>
-          <p:cNvPr id="25" name="Text 23"/>
+          <p:cNvPr id="27" name="Text 25"/>
           <p:cNvSpPr/>
           <p:nvPr/>
         </p:nvSpPr>
@@ -14000,7 +14076,7 @@
       </p:sp>
       <p:sp>
         <p:nvSpPr>
-          <p:cNvPr id="26" name="Shape 24"/>
+          <p:cNvPr id="28" name="Shape 26"/>
           <p:cNvSpPr/>
           <p:nvPr/>
         </p:nvSpPr>
@@ -14025,7 +14101,7 @@
       </p:sp>
       <p:sp>
         <p:nvSpPr>
-          <p:cNvPr id="27" name="Text 25"/>
+          <p:cNvPr id="29" name="Text 27"/>
           <p:cNvSpPr/>
           <p:nvPr/>
         </p:nvSpPr>
@@ -14063,7 +14139,7 @@
       </p:sp>
       <p:sp>
         <p:nvSpPr>
-          <p:cNvPr id="28" name="Shape 26"/>
+          <p:cNvPr id="30" name="Shape 28"/>
           <p:cNvSpPr/>
           <p:nvPr/>
         </p:nvSpPr>
@@ -14088,7 +14164,7 @@
       </p:sp>
       <p:sp>
         <p:nvSpPr>
-          <p:cNvPr id="29" name="Text 27"/>
+          <p:cNvPr id="31" name="Text 29"/>
           <p:cNvSpPr/>
           <p:nvPr/>
         </p:nvSpPr>
@@ -14126,7 +14202,7 @@
       </p:sp>
       <p:sp>
         <p:nvSpPr>
-          <p:cNvPr id="30" name="Shape 28"/>
+          <p:cNvPr id="32" name="Shape 30"/>
           <p:cNvSpPr/>
           <p:nvPr/>
         </p:nvSpPr>
@@ -14151,7 +14227,7 @@
       </p:sp>
       <p:sp>
         <p:nvSpPr>
-          <p:cNvPr id="31" name="Text 29"/>
+          <p:cNvPr id="33" name="Text 31"/>
           <p:cNvSpPr/>
           <p:nvPr/>
         </p:nvSpPr>
@@ -14189,7 +14265,7 @@
       </p:sp>
       <p:sp>
         <p:nvSpPr>
-          <p:cNvPr id="32" name="Shape 30"/>
+          <p:cNvPr id="34" name="Shape 32"/>
           <p:cNvSpPr/>
           <p:nvPr/>
         </p:nvSpPr>
@@ -14214,7 +14290,7 @@
       </p:sp>
       <p:sp>
         <p:nvSpPr>
-          <p:cNvPr id="33" name="Text 31"/>
+          <p:cNvPr id="35" name="Text 33"/>
           <p:cNvSpPr/>
           <p:nvPr/>
         </p:nvSpPr>
@@ -14252,7 +14328,7 @@
       </p:sp>
       <p:sp>
         <p:nvSpPr>
-          <p:cNvPr id="34" name="Shape 32"/>
+          <p:cNvPr id="36" name="Shape 34"/>
           <p:cNvSpPr/>
           <p:nvPr/>
         </p:nvSpPr>
@@ -14277,7 +14353,7 @@
       </p:sp>
       <p:sp>
         <p:nvSpPr>
-          <p:cNvPr id="35" name="Text 33"/>
+          <p:cNvPr id="37" name="Text 35"/>
           <p:cNvSpPr/>
           <p:nvPr/>
         </p:nvSpPr>
@@ -14315,7 +14391,7 @@
       </p:sp>
       <p:sp>
         <p:nvSpPr>
-          <p:cNvPr id="36" name="Shape 34"/>
+          <p:cNvPr id="38" name="Shape 36"/>
           <p:cNvSpPr/>
           <p:nvPr/>
         </p:nvSpPr>
@@ -14340,7 +14416,7 @@
       </p:sp>
       <p:sp>
         <p:nvSpPr>
-          <p:cNvPr id="37" name="Text 35"/>
+          <p:cNvPr id="39" name="Text 37"/>
           <p:cNvSpPr/>
           <p:nvPr/>
         </p:nvSpPr>
@@ -14378,7 +14454,7 @@
       </p:sp>
       <p:sp>
         <p:nvSpPr>
-          <p:cNvPr id="38" name="Shape 36"/>
+          <p:cNvPr id="40" name="Shape 38"/>
           <p:cNvSpPr/>
           <p:nvPr/>
         </p:nvSpPr>
@@ -14403,7 +14479,7 @@
       </p:sp>
       <p:sp>
         <p:nvSpPr>
-          <p:cNvPr id="39" name="Text 37"/>
+          <p:cNvPr id="41" name="Text 39"/>
           <p:cNvSpPr/>
           <p:nvPr/>
         </p:nvSpPr>
@@ -14441,7 +14517,7 @@
       </p:sp>
       <p:sp>
         <p:nvSpPr>
-          <p:cNvPr id="40" name="Shape 38"/>
+          <p:cNvPr id="42" name="Shape 40"/>
           <p:cNvSpPr/>
           <p:nvPr/>
         </p:nvSpPr>
@@ -14466,7 +14542,7 @@
       </p:sp>
       <p:sp>
         <p:nvSpPr>
-          <p:cNvPr id="41" name="Text 39"/>
+          <p:cNvPr id="43" name="Text 41"/>
           <p:cNvSpPr/>
           <p:nvPr/>
         </p:nvSpPr>
@@ -14504,7 +14580,7 @@
       </p:sp>
       <p:sp>
         <p:nvSpPr>
-          <p:cNvPr id="42" name="Shape 40"/>
+          <p:cNvPr id="44" name="Shape 42"/>
           <p:cNvSpPr/>
           <p:nvPr/>
         </p:nvSpPr>
@@ -14529,7 +14605,7 @@
       </p:sp>
       <p:sp>
         <p:nvSpPr>
-          <p:cNvPr id="43" name="Text 41"/>
+          <p:cNvPr id="45" name="Text 43"/>
           <p:cNvSpPr/>
           <p:nvPr/>
         </p:nvSpPr>
@@ -14567,7 +14643,7 @@
       </p:sp>
       <p:sp>
         <p:nvSpPr>
-          <p:cNvPr id="44" name="Shape 42"/>
+          <p:cNvPr id="46" name="Shape 44"/>
           <p:cNvSpPr/>
           <p:nvPr/>
         </p:nvSpPr>
@@ -14592,7 +14668,7 @@
       </p:sp>
       <p:sp>
         <p:nvSpPr>
-          <p:cNvPr id="45" name="Text 43"/>
+          <p:cNvPr id="47" name="Text 45"/>
           <p:cNvSpPr/>
           <p:nvPr/>
         </p:nvSpPr>
@@ -14630,7 +14706,7 @@
       </p:sp>
       <p:sp>
         <p:nvSpPr>
-          <p:cNvPr id="46" name="Shape 44"/>
+          <p:cNvPr id="48" name="Shape 46"/>
           <p:cNvSpPr/>
           <p:nvPr/>
         </p:nvSpPr>
@@ -14655,7 +14731,7 @@
       </p:sp>
       <p:sp>
         <p:nvSpPr>
-          <p:cNvPr id="47" name="Text 45"/>
+          <p:cNvPr id="49" name="Text 47"/>
           <p:cNvSpPr/>
           <p:nvPr/>
         </p:nvSpPr>
@@ -14693,7 +14769,7 @@
       </p:sp>
       <p:sp>
         <p:nvSpPr>
-          <p:cNvPr id="48" name="Shape 46"/>
+          <p:cNvPr id="50" name="Shape 48"/>
           <p:cNvSpPr/>
           <p:nvPr/>
         </p:nvSpPr>
@@ -14718,7 +14794,7 @@
       </p:sp>
       <p:sp>
         <p:nvSpPr>
-          <p:cNvPr id="49" name="Text 47"/>
+          <p:cNvPr id="51" name="Text 49"/>
           <p:cNvSpPr/>
           <p:nvPr/>
         </p:nvSpPr>
@@ -14756,7 +14832,7 @@
       </p:sp>
       <p:sp>
         <p:nvSpPr>
-          <p:cNvPr id="50" name="Shape 48"/>
+          <p:cNvPr id="52" name="Shape 50"/>
           <p:cNvSpPr/>
           <p:nvPr/>
         </p:nvSpPr>
@@ -14781,7 +14857,7 @@
       </p:sp>
       <p:sp>
         <p:nvSpPr>
-          <p:cNvPr id="51" name="Text 49"/>
+          <p:cNvPr id="53" name="Text 51"/>
           <p:cNvSpPr/>
           <p:nvPr/>
         </p:nvSpPr>
@@ -14819,7 +14895,7 @@
       </p:sp>
       <p:sp>
         <p:nvSpPr>
-          <p:cNvPr id="52" name="Shape 50"/>
+          <p:cNvPr id="54" name="Shape 52"/>
           <p:cNvSpPr/>
           <p:nvPr/>
         </p:nvSpPr>
@@ -14844,7 +14920,7 @@
       </p:sp>
       <p:sp>
         <p:nvSpPr>
-          <p:cNvPr id="53" name="Text 51"/>
+          <p:cNvPr id="55" name="Text 53"/>
           <p:cNvSpPr/>
           <p:nvPr/>
         </p:nvSpPr>
@@ -14882,7 +14958,7 @@
       </p:sp>
       <p:sp>
         <p:nvSpPr>
-          <p:cNvPr id="54" name="Shape 52"/>
+          <p:cNvPr id="56" name="Shape 54"/>
           <p:cNvSpPr/>
           <p:nvPr/>
         </p:nvSpPr>
@@ -14907,7 +14983,7 @@
       </p:sp>
       <p:sp>
         <p:nvSpPr>
-          <p:cNvPr id="55" name="Text 53"/>
+          <p:cNvPr id="57" name="Text 55"/>
           <p:cNvSpPr/>
           <p:nvPr/>
         </p:nvSpPr>
@@ -14945,7 +15021,7 @@
       </p:sp>
       <p:sp>
         <p:nvSpPr>
-          <p:cNvPr id="56" name="Shape 54"/>
+          <p:cNvPr id="58" name="Shape 56"/>
           <p:cNvSpPr/>
           <p:nvPr/>
         </p:nvSpPr>
@@ -14970,7 +15046,7 @@
       </p:sp>
       <p:sp>
         <p:nvSpPr>
-          <p:cNvPr id="57" name="Text 55"/>
+          <p:cNvPr id="59" name="Text 57"/>
           <p:cNvSpPr/>
           <p:nvPr/>
         </p:nvSpPr>
@@ -15008,7 +15084,7 @@
       </p:sp>
       <p:sp>
         <p:nvSpPr>
-          <p:cNvPr id="58" name="Shape 56"/>
+          <p:cNvPr id="60" name="Shape 58"/>
           <p:cNvSpPr/>
           <p:nvPr/>
         </p:nvSpPr>
@@ -15033,7 +15109,7 @@
       </p:sp>
       <p:sp>
         <p:nvSpPr>
-          <p:cNvPr id="59" name="Text 57"/>
+          <p:cNvPr id="61" name="Text 59"/>
           <p:cNvSpPr/>
           <p:nvPr/>
         </p:nvSpPr>
@@ -15071,7 +15147,7 @@
       </p:sp>
       <p:sp>
         <p:nvSpPr>
-          <p:cNvPr id="60" name="Shape 58"/>
+          <p:cNvPr id="62" name="Shape 60"/>
           <p:cNvSpPr/>
           <p:nvPr/>
         </p:nvSpPr>
@@ -15096,7 +15172,7 @@
       </p:sp>
       <p:sp>
         <p:nvSpPr>
-          <p:cNvPr id="61" name="Text 59"/>
+          <p:cNvPr id="63" name="Text 61"/>
           <p:cNvSpPr/>
           <p:nvPr/>
         </p:nvSpPr>
@@ -15134,7 +15210,7 @@
       </p:sp>
       <p:sp>
         <p:nvSpPr>
-          <p:cNvPr id="62" name="Shape 60"/>
+          <p:cNvPr id="64" name="Shape 62"/>
           <p:cNvSpPr/>
           <p:nvPr/>
         </p:nvSpPr>
@@ -15159,7 +15235,7 @@
       </p:sp>
       <p:sp>
         <p:nvSpPr>
-          <p:cNvPr id="63" name="Text 61"/>
+          <p:cNvPr id="65" name="Text 63"/>
           <p:cNvSpPr/>
           <p:nvPr/>
         </p:nvSpPr>
@@ -15197,7 +15273,7 @@
       </p:sp>
       <p:sp>
         <p:nvSpPr>
-          <p:cNvPr id="64" name="Shape 62"/>
+          <p:cNvPr id="66" name="Shape 64"/>
           <p:cNvSpPr/>
           <p:nvPr/>
         </p:nvSpPr>
@@ -15222,7 +15298,7 @@
       </p:sp>
       <p:sp>
         <p:nvSpPr>
-          <p:cNvPr id="65" name="Text 63"/>
+          <p:cNvPr id="67" name="Text 65"/>
           <p:cNvSpPr/>
           <p:nvPr/>
         </p:nvSpPr>
@@ -15260,7 +15336,7 @@
       </p:sp>
       <p:sp>
         <p:nvSpPr>
-          <p:cNvPr id="66" name="Shape 64"/>
+          <p:cNvPr id="68" name="Shape 66"/>
           <p:cNvSpPr/>
           <p:nvPr/>
         </p:nvSpPr>
@@ -15285,7 +15361,7 @@
       </p:sp>
       <p:sp>
         <p:nvSpPr>
-          <p:cNvPr id="67" name="Text 65"/>
+          <p:cNvPr id="69" name="Text 67"/>
           <p:cNvSpPr/>
           <p:nvPr/>
         </p:nvSpPr>
@@ -15323,7 +15399,7 @@
       </p:sp>
       <p:sp>
         <p:nvSpPr>
-          <p:cNvPr id="68" name="Shape 66"/>
+          <p:cNvPr id="70" name="Shape 68"/>
           <p:cNvSpPr/>
           <p:nvPr/>
         </p:nvSpPr>
@@ -15348,7 +15424,7 @@
       </p:sp>
       <p:sp>
         <p:nvSpPr>
-          <p:cNvPr id="69" name="Text 67"/>
+          <p:cNvPr id="71" name="Text 69"/>
           <p:cNvSpPr/>
           <p:nvPr/>
         </p:nvSpPr>
@@ -15386,7 +15462,7 @@
       </p:sp>
       <p:sp>
         <p:nvSpPr>
-          <p:cNvPr id="70" name="Shape 68"/>
+          <p:cNvPr id="72" name="Shape 70"/>
           <p:cNvSpPr/>
           <p:nvPr/>
         </p:nvSpPr>
@@ -15411,7 +15487,7 @@
       </p:sp>
       <p:sp>
         <p:nvSpPr>
-          <p:cNvPr id="71" name="Shape 69"/>
+          <p:cNvPr id="73" name="Shape 71"/>
           <p:cNvSpPr/>
           <p:nvPr/>
         </p:nvSpPr>
@@ -15436,7 +15512,7 @@
       </p:sp>
       <p:sp>
         <p:nvSpPr>
-          <p:cNvPr id="72" name="Text 70"/>
+          <p:cNvPr id="74" name="Text 72"/>
           <p:cNvSpPr/>
           <p:nvPr/>
         </p:nvSpPr>
@@ -15472,7 +15548,7 @@
       </p:sp>
       <p:sp>
         <p:nvSpPr>
-          <p:cNvPr id="73" name="Text 71"/>
+          <p:cNvPr id="75" name="Text 73"/>
           <p:cNvSpPr/>
           <p:nvPr/>
         </p:nvSpPr>
@@ -15508,7 +15584,7 @@
       </p:sp>
       <p:sp>
         <p:nvSpPr>
-          <p:cNvPr id="74" name="Text 72"/>
+          <p:cNvPr id="76" name="Text 74"/>
           <p:cNvSpPr/>
           <p:nvPr/>
         </p:nvSpPr>
@@ -15546,7 +15622,7 @@
       </p:sp>
       <p:sp>
         <p:nvSpPr>
-          <p:cNvPr id="75" name="Text 73"/>
+          <p:cNvPr id="77" name="Text 75"/>
           <p:cNvSpPr/>
           <p:nvPr/>
         </p:nvSpPr>
@@ -15584,7 +15660,7 @@
       </p:sp>
       <p:sp>
         <p:nvSpPr>
-          <p:cNvPr id="76" name="Text 74"/>
+          <p:cNvPr id="78" name="Text 76"/>
           <p:cNvSpPr/>
           <p:nvPr/>
         </p:nvSpPr>

</xml_diff>

<commit_message>
docs: simplify general solver baseline slide
</commit_message>
<xml_diff>
--- a/timing/sfm_ba/benchmark_logs/20260710T_cuda_sfm_progress/cuda_sfm_progress_update.pptx
+++ b/timing/sfm_ba/benchmark_logs/20260710T_cuda_sfm_progress/cuda_sfm_progress_update.pptx
@@ -1216,7 +1216,7 @@
           <a:p>
             <a:r>
               <a:rPr lang="en-US" dirty="0"/>
-              <a:t>About 90 seconds. This is a proposed baseline architecture. I call it Ceres-style separation because the useful idea is to separate nonlinear residual and Jacobian evaluation from a selectable linear-algebra backend. I am not claiming that every Ceres path has this exact data flow. In this baseline, arbitrary GTSAM factors stay in the CPU and TBB nonlinear layer. The CPU fills reusable sparse numeric J or H buffers, the GPU receives the generic linear system, and only the solved delta returns. The CPU then performs manifold retraction, trial error, and the trust-region decision. This removes the current SFM-only graph conversion, while leaving the real costs of sparse packing and repeated upload to be measured.</a:t>
+              <a:t>About 90 seconds. This is the proposed baseline architecture. I call it Ceres-style separation because the useful idea is to separate nonlinear residual and Jacobian evaluation from a selectable linear-algebra backend. I am not claiming that every Ceres path has this exact data flow. The CPU and TBB layer evaluates factors and fills reusable sparse numeric J or H buffers. Those numeric values are uploaded for the GPU linear solve, and only the solved delta returns. The CPU then performs manifold retraction, trial error, and the trust-region decision.</a:t>
             </a:r>
             <a:endParaRPr lang="en-US" dirty="0"/>
           </a:p>
@@ -19624,8 +19624,8 @@
         </p:nvSpPr>
         <p:spPr>
           <a:xfrm>
-            <a:off x="502920" y="1408176"/>
-            <a:ext cx="1726692" cy="1975104"/>
+            <a:off x="502920" y="1572768"/>
+            <a:ext cx="1726692" cy="3063240"/>
           </a:xfrm>
           <a:prstGeom prst="rect">
             <a:avLst/>
@@ -19649,7 +19649,7 @@
         </p:nvSpPr>
         <p:spPr>
           <a:xfrm>
-            <a:off x="502920" y="1408176"/>
+            <a:off x="502920" y="1572768"/>
             <a:ext cx="1726692" cy="91440"/>
           </a:xfrm>
           <a:prstGeom prst="rect">
@@ -19674,7 +19674,7 @@
         </p:nvSpPr>
         <p:spPr>
           <a:xfrm>
-            <a:off x="612648" y="1600200"/>
+            <a:off x="612648" y="1764792"/>
             <a:ext cx="1507236" cy="292608"/>
           </a:xfrm>
           <a:prstGeom prst="rect">
@@ -19712,8 +19712,8 @@
         </p:nvSpPr>
         <p:spPr>
           <a:xfrm>
-            <a:off x="612648" y="2066544"/>
-            <a:ext cx="1507236" cy="1197864"/>
+            <a:off x="612648" y="2231136"/>
+            <a:ext cx="1507236" cy="2286000"/>
           </a:xfrm>
           <a:prstGeom prst="rect">
             <a:avLst/>
@@ -19750,7 +19750,7 @@
         </p:nvSpPr>
         <p:spPr>
           <a:xfrm>
-            <a:off x="2261616" y="2258568"/>
+            <a:off x="2261616" y="2967228"/>
             <a:ext cx="118872" cy="274320"/>
           </a:xfrm>
           <a:prstGeom prst="chevron">
@@ -19775,8 +19775,8 @@
         </p:nvSpPr>
         <p:spPr>
           <a:xfrm>
-            <a:off x="2394204" y="1408176"/>
-            <a:ext cx="1726692" cy="1975104"/>
+            <a:off x="2394204" y="1572768"/>
+            <a:ext cx="1726692" cy="3063240"/>
           </a:xfrm>
           <a:prstGeom prst="rect">
             <a:avLst/>
@@ -19800,7 +19800,7 @@
         </p:nvSpPr>
         <p:spPr>
           <a:xfrm>
-            <a:off x="2394204" y="1408176"/>
+            <a:off x="2394204" y="1572768"/>
             <a:ext cx="1726692" cy="91440"/>
           </a:xfrm>
           <a:prstGeom prst="rect">
@@ -19825,7 +19825,7 @@
         </p:nvSpPr>
         <p:spPr>
           <a:xfrm>
-            <a:off x="2503932" y="1600200"/>
+            <a:off x="2503932" y="1764792"/>
             <a:ext cx="1507236" cy="292608"/>
           </a:xfrm>
           <a:prstGeom prst="rect">
@@ -19863,8 +19863,8 @@
         </p:nvSpPr>
         <p:spPr>
           <a:xfrm>
-            <a:off x="2503932" y="2066544"/>
-            <a:ext cx="1507236" cy="1197864"/>
+            <a:off x="2503932" y="2231136"/>
+            <a:ext cx="1507236" cy="2286000"/>
           </a:xfrm>
           <a:prstGeom prst="rect">
             <a:avLst/>
@@ -19901,7 +19901,7 @@
         </p:nvSpPr>
         <p:spPr>
           <a:xfrm>
-            <a:off x="4152900" y="2258568"/>
+            <a:off x="4152900" y="2967228"/>
             <a:ext cx="118872" cy="274320"/>
           </a:xfrm>
           <a:prstGeom prst="chevron">
@@ -19926,8 +19926,8 @@
         </p:nvSpPr>
         <p:spPr>
           <a:xfrm>
-            <a:off x="4285488" y="1408176"/>
-            <a:ext cx="1726692" cy="1975104"/>
+            <a:off x="4285488" y="1572768"/>
+            <a:ext cx="1726692" cy="3063240"/>
           </a:xfrm>
           <a:prstGeom prst="rect">
             <a:avLst/>
@@ -19951,7 +19951,7 @@
         </p:nvSpPr>
         <p:spPr>
           <a:xfrm>
-            <a:off x="4285488" y="1408176"/>
+            <a:off x="4285488" y="1572768"/>
             <a:ext cx="1726692" cy="91440"/>
           </a:xfrm>
           <a:prstGeom prst="rect">
@@ -19976,7 +19976,7 @@
         </p:nvSpPr>
         <p:spPr>
           <a:xfrm>
-            <a:off x="4395216" y="1600200"/>
+            <a:off x="4395216" y="1764792"/>
             <a:ext cx="1507236" cy="292608"/>
           </a:xfrm>
           <a:prstGeom prst="rect">
@@ -20014,8 +20014,8 @@
         </p:nvSpPr>
         <p:spPr>
           <a:xfrm>
-            <a:off x="4395216" y="2066544"/>
-            <a:ext cx="1507236" cy="1197864"/>
+            <a:off x="4395216" y="2231136"/>
+            <a:ext cx="1507236" cy="2286000"/>
           </a:xfrm>
           <a:prstGeom prst="rect">
             <a:avLst/>
@@ -20052,7 +20052,7 @@
         </p:nvSpPr>
         <p:spPr>
           <a:xfrm>
-            <a:off x="6044184" y="2258568"/>
+            <a:off x="6044184" y="2967228"/>
             <a:ext cx="118872" cy="274320"/>
           </a:xfrm>
           <a:prstGeom prst="chevron">
@@ -20077,8 +20077,8 @@
         </p:nvSpPr>
         <p:spPr>
           <a:xfrm>
-            <a:off x="6176772" y="1408176"/>
-            <a:ext cx="1726692" cy="1975104"/>
+            <a:off x="6176772" y="1572768"/>
+            <a:ext cx="1726692" cy="3063240"/>
           </a:xfrm>
           <a:prstGeom prst="rect">
             <a:avLst/>
@@ -20102,7 +20102,7 @@
         </p:nvSpPr>
         <p:spPr>
           <a:xfrm>
-            <a:off x="6176772" y="1408176"/>
+            <a:off x="6176772" y="1572768"/>
             <a:ext cx="1726692" cy="91440"/>
           </a:xfrm>
           <a:prstGeom prst="rect">
@@ -20127,7 +20127,7 @@
         </p:nvSpPr>
         <p:spPr>
           <a:xfrm>
-            <a:off x="6286500" y="1600200"/>
+            <a:off x="6286500" y="1764792"/>
             <a:ext cx="1507236" cy="292608"/>
           </a:xfrm>
           <a:prstGeom prst="rect">
@@ -20165,8 +20165,8 @@
         </p:nvSpPr>
         <p:spPr>
           <a:xfrm>
-            <a:off x="6286500" y="2066544"/>
-            <a:ext cx="1507236" cy="1197864"/>
+            <a:off x="6286500" y="2231136"/>
+            <a:ext cx="1507236" cy="2286000"/>
           </a:xfrm>
           <a:prstGeom prst="rect">
             <a:avLst/>
@@ -20203,7 +20203,7 @@
         </p:nvSpPr>
         <p:spPr>
           <a:xfrm>
-            <a:off x="7935468" y="2258568"/>
+            <a:off x="7935468" y="2967228"/>
             <a:ext cx="118872" cy="274320"/>
           </a:xfrm>
           <a:prstGeom prst="chevron">
@@ -20228,8 +20228,8 @@
         </p:nvSpPr>
         <p:spPr>
           <a:xfrm>
-            <a:off x="8068056" y="1408176"/>
-            <a:ext cx="1726692" cy="1975104"/>
+            <a:off x="8068056" y="1572768"/>
+            <a:ext cx="1726692" cy="3063240"/>
           </a:xfrm>
           <a:prstGeom prst="rect">
             <a:avLst/>
@@ -20253,7 +20253,7 @@
         </p:nvSpPr>
         <p:spPr>
           <a:xfrm>
-            <a:off x="8068056" y="1408176"/>
+            <a:off x="8068056" y="1572768"/>
             <a:ext cx="1726692" cy="91440"/>
           </a:xfrm>
           <a:prstGeom prst="rect">
@@ -20278,7 +20278,7 @@
         </p:nvSpPr>
         <p:spPr>
           <a:xfrm>
-            <a:off x="8177784" y="1600200"/>
+            <a:off x="8177784" y="1764792"/>
             <a:ext cx="1507236" cy="292608"/>
           </a:xfrm>
           <a:prstGeom prst="rect">
@@ -20316,8 +20316,8 @@
         </p:nvSpPr>
         <p:spPr>
           <a:xfrm>
-            <a:off x="8177784" y="2066544"/>
-            <a:ext cx="1507236" cy="1197864"/>
+            <a:off x="8177784" y="2231136"/>
+            <a:ext cx="1507236" cy="2286000"/>
           </a:xfrm>
           <a:prstGeom prst="rect">
             <a:avLst/>
@@ -20354,7 +20354,7 @@
         </p:nvSpPr>
         <p:spPr>
           <a:xfrm>
-            <a:off x="9826752" y="2258568"/>
+            <a:off x="9826752" y="2967228"/>
             <a:ext cx="118872" cy="274320"/>
           </a:xfrm>
           <a:prstGeom prst="chevron">
@@ -20379,8 +20379,8 @@
         </p:nvSpPr>
         <p:spPr>
           <a:xfrm>
-            <a:off x="9959340" y="1408176"/>
-            <a:ext cx="1726692" cy="1975104"/>
+            <a:off x="9959340" y="1572768"/>
+            <a:ext cx="1726692" cy="3063240"/>
           </a:xfrm>
           <a:prstGeom prst="rect">
             <a:avLst/>
@@ -20404,7 +20404,7 @@
         </p:nvSpPr>
         <p:spPr>
           <a:xfrm>
-            <a:off x="9959340" y="1408176"/>
+            <a:off x="9959340" y="1572768"/>
             <a:ext cx="1726692" cy="91440"/>
           </a:xfrm>
           <a:prstGeom prst="rect">
@@ -20429,7 +20429,7 @@
         </p:nvSpPr>
         <p:spPr>
           <a:xfrm>
-            <a:off x="10069068" y="1600200"/>
+            <a:off x="10069068" y="1764792"/>
             <a:ext cx="1507236" cy="292608"/>
           </a:xfrm>
           <a:prstGeom prst="rect">
@@ -20467,8 +20467,8 @@
         </p:nvSpPr>
         <p:spPr>
           <a:xfrm>
-            <a:off x="10069068" y="2066544"/>
-            <a:ext cx="1507236" cy="1197864"/>
+            <a:off x="10069068" y="2231136"/>
+            <a:ext cx="1507236" cy="2286000"/>
           </a:xfrm>
           <a:prstGeom prst="rect">
             <a:avLst/>
@@ -20499,64 +20499,14 @@
       </p:sp>
       <p:sp>
         <p:nvSpPr>
-          <p:cNvPr id="36" name="Shape 34"/>
-          <p:cNvSpPr/>
-          <p:nvPr/>
-        </p:nvSpPr>
-        <p:spPr>
-          <a:xfrm>
-            <a:off x="658368" y="4041648"/>
-            <a:ext cx="5212080" cy="1325880"/>
-          </a:xfrm>
-          <a:prstGeom prst="rect">
-            <a:avLst/>
-          </a:prstGeom>
-          <a:solidFill>
-            <a:srgbClr val="F1F4F8"/>
-          </a:solidFill>
-          <a:ln w="9525">
-            <a:solidFill>
-              <a:srgbClr val="E7EBF0"/>
-            </a:solidFill>
-            <a:prstDash val="solid"/>
-          </a:ln>
-        </p:spPr>
-      </p:sp>
-      <p:sp>
-        <p:nvSpPr>
-          <p:cNvPr id="37" name="Shape 35"/>
-          <p:cNvSpPr/>
-          <p:nvPr/>
-        </p:nvSpPr>
-        <p:spPr>
-          <a:xfrm>
-            <a:off x="658368" y="4041648"/>
-            <a:ext cx="64008" cy="1325880"/>
-          </a:xfrm>
-          <a:prstGeom prst="rect">
-            <a:avLst/>
-          </a:prstGeom>
-          <a:solidFill>
-            <a:srgbClr val="1F2A44"/>
-          </a:solidFill>
-          <a:ln w="12700">
-            <a:solidFill>
-              <a:srgbClr val="1F2A44"/>
-            </a:solidFill>
-            <a:prstDash val="solid"/>
-          </a:ln>
-        </p:spPr>
-      </p:sp>
-      <p:sp>
-        <p:nvSpPr>
-          <p:cNvPr id="38" name="Text 36"/>
-          <p:cNvSpPr/>
-          <p:nvPr/>
-        </p:nvSpPr>
-        <p:spPr>
-          <a:xfrm>
-            <a:off x="914400" y="4315968"/>
-            <a:ext cx="4663440" cy="201168"/>
+          <p:cNvPr id="36" name="Text 34"/>
+          <p:cNvSpPr/>
+          <p:nvPr/>
+        </p:nvSpPr>
+        <p:spPr>
+          <a:xfrm>
+            <a:off x="658368" y="5285232"/>
+            <a:ext cx="3657600" cy="146304"/>
           </a:xfrm>
           <a:prstGeom prst="rect">
             <a:avLst/>
@@ -20568,204 +20518,6 @@
           <a:bodyPr wrap="square" lIns="0" tIns="0" rIns="0" bIns="0" rtlCol="0" anchor="ctr"/>
           <a:lstStyle/>
           <a:p>
-            <a:pPr algn="ctr" indent="0" marL="0">
-              <a:buNone/>
-            </a:pPr>
-            <a:r>
-              <a:rPr lang="en-US" sz="1700" b="1" dirty="0">
-                <a:solidFill>
-                  <a:srgbClr val="1F2A44"/>
-                </a:solidFill>
-              </a:rPr>
-              <a:t>Why this is general</a:t>
-            </a:r>
-            <a:endParaRPr lang="en-US" sz="1700" dirty="0"/>
-          </a:p>
-        </p:txBody>
-      </p:sp>
-      <p:sp>
-        <p:nvSpPr>
-          <p:cNvPr id="39" name="Text 37"/>
-          <p:cNvSpPr/>
-          <p:nvPr/>
-        </p:nvSpPr>
-        <p:spPr>
-          <a:xfrm>
-            <a:off x="914400" y="4663440"/>
-            <a:ext cx="4663440" cy="438912"/>
-          </a:xfrm>
-          <a:prstGeom prst="rect">
-            <a:avLst/>
-          </a:prstGeom>
-          <a:noFill/>
-          <a:ln/>
-        </p:spPr>
-        <p:txBody>
-          <a:bodyPr wrap="square" lIns="0" tIns="0" rIns="0" bIns="0" rtlCol="0" anchor="ctr">
-            <a:normAutofit/>
-          </a:bodyPr>
-          <a:lstStyle/>
-          <a:p>
-            <a:pPr algn="ctr" indent="0" marL="0">
-              <a:buNone/>
-            </a:pPr>
-            <a:r>
-              <a:rPr lang="en-US" sz="1450" dirty="0">
-                <a:solidFill>
-                  <a:srgbClr val="18212F"/>
-                </a:solidFill>
-              </a:rPr>
-              <a:t>Arbitrary GTSAM factors remain in the CPU nonlinear layer. The GPU receives a generic linear system rather than an SFM-specific graph representation.</a:t>
-            </a:r>
-            <a:endParaRPr lang="en-US" sz="1450" dirty="0"/>
-          </a:p>
-        </p:txBody>
-      </p:sp>
-      <p:sp>
-        <p:nvSpPr>
-          <p:cNvPr id="40" name="Shape 38"/>
-          <p:cNvSpPr/>
-          <p:nvPr/>
-        </p:nvSpPr>
-        <p:spPr>
-          <a:xfrm>
-            <a:off x="6172200" y="4041648"/>
-            <a:ext cx="5257800" cy="1325880"/>
-          </a:xfrm>
-          <a:prstGeom prst="rect">
-            <a:avLst/>
-          </a:prstGeom>
-          <a:solidFill>
-            <a:srgbClr val="FEF4E3"/>
-          </a:solidFill>
-          <a:ln w="9525">
-            <a:solidFill>
-              <a:srgbClr val="E7EBF0"/>
-            </a:solidFill>
-            <a:prstDash val="solid"/>
-          </a:ln>
-        </p:spPr>
-      </p:sp>
-      <p:sp>
-        <p:nvSpPr>
-          <p:cNvPr id="41" name="Shape 39"/>
-          <p:cNvSpPr/>
-          <p:nvPr/>
-        </p:nvSpPr>
-        <p:spPr>
-          <a:xfrm>
-            <a:off x="6172200" y="4041648"/>
-            <a:ext cx="64008" cy="1325880"/>
-          </a:xfrm>
-          <a:prstGeom prst="rect">
-            <a:avLst/>
-          </a:prstGeom>
-          <a:solidFill>
-            <a:srgbClr val="F2A23A"/>
-          </a:solidFill>
-          <a:ln w="12700">
-            <a:solidFill>
-              <a:srgbClr val="F2A23A"/>
-            </a:solidFill>
-            <a:prstDash val="solid"/>
-          </a:ln>
-        </p:spPr>
-      </p:sp>
-      <p:sp>
-        <p:nvSpPr>
-          <p:cNvPr id="42" name="Text 40"/>
-          <p:cNvSpPr/>
-          <p:nvPr/>
-        </p:nvSpPr>
-        <p:spPr>
-          <a:xfrm>
-            <a:off x="6446520" y="4315968"/>
-            <a:ext cx="4709160" cy="201168"/>
-          </a:xfrm>
-          <a:prstGeom prst="rect">
-            <a:avLst/>
-          </a:prstGeom>
-          <a:noFill/>
-          <a:ln/>
-        </p:spPr>
-        <p:txBody>
-          <a:bodyPr wrap="square" lIns="0" tIns="0" rIns="0" bIns="0" rtlCol="0" anchor="ctr"/>
-          <a:lstStyle/>
-          <a:p>
-            <a:pPr algn="ctr" indent="0" marL="0">
-              <a:buNone/>
-            </a:pPr>
-            <a:r>
-              <a:rPr lang="en-US" sz="1700" b="1" dirty="0">
-                <a:solidFill>
-                  <a:srgbClr val="F2A23A"/>
-                </a:solidFill>
-              </a:rPr>
-              <a:t>What remains a hypothesis</a:t>
-            </a:r>
-            <a:endParaRPr lang="en-US" sz="1700" dirty="0"/>
-          </a:p>
-        </p:txBody>
-      </p:sp>
-      <p:sp>
-        <p:nvSpPr>
-          <p:cNvPr id="43" name="Text 41"/>
-          <p:cNvSpPr/>
-          <p:nvPr/>
-        </p:nvSpPr>
-        <p:spPr>
-          <a:xfrm>
-            <a:off x="6446520" y="4663440"/>
-            <a:ext cx="4709160" cy="438912"/>
-          </a:xfrm>
-          <a:prstGeom prst="rect">
-            <a:avLst/>
-          </a:prstGeom>
-          <a:noFill/>
-          <a:ln/>
-        </p:spPr>
-        <p:txBody>
-          <a:bodyPr wrap="square" lIns="0" tIns="0" rIns="0" bIns="0" rtlCol="0" anchor="ctr">
-            <a:normAutofit/>
-          </a:bodyPr>
-          <a:lstStyle/>
-          <a:p>
-            <a:pPr algn="ctr" indent="0" marL="0">
-              <a:buNone/>
-            </a:pPr>
-            <a:r>
-              <a:rPr lang="en-US" sz="1450" dirty="0">
-                <a:solidFill>
-                  <a:srgbClr val="18212F"/>
-                </a:solidFill>
-              </a:rPr>
-              <a:t>Sparse packing, repeated numeric upload, delta mapping, and end-to-end convergence must be measured in the actual prototype.</a:t>
-            </a:r>
-            <a:endParaRPr lang="en-US" sz="1450" dirty="0"/>
-          </a:p>
-        </p:txBody>
-      </p:sp>
-      <p:sp>
-        <p:nvSpPr>
-          <p:cNvPr id="44" name="Text 42"/>
-          <p:cNvSpPr/>
-          <p:nvPr/>
-        </p:nvSpPr>
-        <p:spPr>
-          <a:xfrm>
-            <a:off x="658368" y="5760720"/>
-            <a:ext cx="3657600" cy="146304"/>
-          </a:xfrm>
-          <a:prstGeom prst="rect">
-            <a:avLst/>
-          </a:prstGeom>
-          <a:noFill/>
-          <a:ln/>
-        </p:spPr>
-        <p:txBody>
-          <a:bodyPr wrap="square" lIns="0" tIns="0" rIns="0" bIns="0" rtlCol="0" anchor="ctr"/>
-          <a:lstStyle/>
-          <a:p>
             <a:pPr indent="0" marL="0">
               <a:buNone/>
             </a:pPr>
@@ -20783,7 +20535,7 @@
       </p:sp>
       <p:sp>
         <p:nvSpPr>
-          <p:cNvPr id="45" name="Text 43">
+          <p:cNvPr id="37" name="Text 35">
             <a:hlinkClick r:id="rId1" tooltip=""/>
           </p:cNvPr>
           <p:cNvSpPr/>
@@ -20791,7 +20543,7 @@
         </p:nvSpPr>
         <p:spPr>
           <a:xfrm>
-            <a:off x="658368" y="5943600"/>
+            <a:off x="658368" y="5486400"/>
             <a:ext cx="10789920" cy="146304"/>
           </a:xfrm>
           <a:prstGeom prst="rect">
@@ -20830,7 +20582,7 @@
       </p:sp>
       <p:sp>
         <p:nvSpPr>
-          <p:cNvPr id="46" name="Text 44">
+          <p:cNvPr id="38" name="Text 36">
             <a:hlinkClick r:id="rId2" tooltip=""/>
           </p:cNvPr>
           <p:cNvSpPr/>
@@ -20838,7 +20590,7 @@
         </p:nvSpPr>
         <p:spPr>
           <a:xfrm>
-            <a:off x="658368" y="6144768"/>
+            <a:off x="658368" y="5705856"/>
             <a:ext cx="10789920" cy="146304"/>
           </a:xfrm>
           <a:prstGeom prst="rect">
@@ -20877,7 +20629,7 @@
       </p:sp>
       <p:sp>
         <p:nvSpPr>
-          <p:cNvPr id="47" name="Text 45"/>
+          <p:cNvPr id="39" name="Text 37"/>
           <p:cNvSpPr/>
           <p:nvPr/>
         </p:nvSpPr>

</xml_diff>